<commit_message>
🤖 Add new icons for enhanced presentation visuals and update agents.py with revised guidelines for slide layout reuse. Include new PowerPoint template for improved slide generation.
</commit_message>
<xml_diff>
--- a/ekona_slides_template_new.pptx
+++ b/ekona_slides_template_new.pptx
@@ -126,7 +126,7 @@
   <pc:docChgLst>
     <pc:chgData name="Sam Khalil" userId="82cd1ec2-6208-465b-9d4d-40ce8f0cbf96" providerId="ADAL" clId="{651B6F30-EC96-2340-AD4B-07A6B9855D0C}"/>
     <pc:docChg chg="undo custSel addSld delSld modSld modMainMaster">
-      <pc:chgData name="Sam Khalil" userId="82cd1ec2-6208-465b-9d4d-40ce8f0cbf96" providerId="ADAL" clId="{651B6F30-EC96-2340-AD4B-07A6B9855D0C}" dt="2025-07-17T16:43:33.189" v="1205" actId="962"/>
+      <pc:chgData name="Sam Khalil" userId="82cd1ec2-6208-465b-9d4d-40ce8f0cbf96" providerId="ADAL" clId="{651B6F30-EC96-2340-AD4B-07A6B9855D0C}" dt="2025-07-17T16:52:43.058" v="1222" actId="20577"/>
       <pc:docMkLst>
         <pc:docMk/>
       </pc:docMkLst>
@@ -159,7 +159,7 @@
         </pc:sldMkLst>
       </pc:sldChg>
       <pc:sldMasterChg chg="addSldLayout delSldLayout modSldLayout sldLayoutOrd">
-        <pc:chgData name="Sam Khalil" userId="82cd1ec2-6208-465b-9d4d-40ce8f0cbf96" providerId="ADAL" clId="{651B6F30-EC96-2340-AD4B-07A6B9855D0C}" dt="2025-07-17T16:43:33.189" v="1205" actId="962"/>
+        <pc:chgData name="Sam Khalil" userId="82cd1ec2-6208-465b-9d4d-40ce8f0cbf96" providerId="ADAL" clId="{651B6F30-EC96-2340-AD4B-07A6B9855D0C}" dt="2025-07-17T16:52:43.058" v="1222" actId="20577"/>
         <pc:sldMasterMkLst>
           <pc:docMk/>
           <pc:sldMasterMk cId="2940896467" sldId="2147483648"/>
@@ -454,7 +454,7 @@
           </pc:spChg>
         </pc:sldLayoutChg>
         <pc:sldLayoutChg chg="addSp delSp modSp mod ord">
-          <pc:chgData name="Sam Khalil" userId="82cd1ec2-6208-465b-9d4d-40ce8f0cbf96" providerId="ADAL" clId="{651B6F30-EC96-2340-AD4B-07A6B9855D0C}" dt="2025-07-17T16:43:33.189" v="1205" actId="962"/>
+          <pc:chgData name="Sam Khalil" userId="82cd1ec2-6208-465b-9d4d-40ce8f0cbf96" providerId="ADAL" clId="{651B6F30-EC96-2340-AD4B-07A6B9855D0C}" dt="2025-07-17T16:52:43.058" v="1222" actId="20577"/>
           <pc:sldLayoutMkLst>
             <pc:docMk/>
             <pc:sldMasterMk cId="2940896467" sldId="2147483648"/>
@@ -488,7 +488,7 @@
             </ac:spMkLst>
           </pc:spChg>
           <pc:spChg chg="add mod">
-            <ac:chgData name="Sam Khalil" userId="82cd1ec2-6208-465b-9d4d-40ce8f0cbf96" providerId="ADAL" clId="{651B6F30-EC96-2340-AD4B-07A6B9855D0C}" dt="2025-07-17T16:43:14.254" v="1198" actId="962"/>
+            <ac:chgData name="Sam Khalil" userId="82cd1ec2-6208-465b-9d4d-40ce8f0cbf96" providerId="ADAL" clId="{651B6F30-EC96-2340-AD4B-07A6B9855D0C}" dt="2025-07-17T16:52:41.643" v="1221" actId="20577"/>
             <ac:spMkLst>
               <pc:docMk/>
               <pc:sldMasterMk cId="2940896467" sldId="2147483648"/>
@@ -524,7 +524,7 @@
             </ac:spMkLst>
           </pc:spChg>
           <pc:spChg chg="add del mod">
-            <ac:chgData name="Sam Khalil" userId="82cd1ec2-6208-465b-9d4d-40ce8f0cbf96" providerId="ADAL" clId="{651B6F30-EC96-2340-AD4B-07A6B9855D0C}" dt="2025-07-17T16:43:26.258" v="1203" actId="962"/>
+            <ac:chgData name="Sam Khalil" userId="82cd1ec2-6208-465b-9d4d-40ce8f0cbf96" providerId="ADAL" clId="{651B6F30-EC96-2340-AD4B-07A6B9855D0C}" dt="2025-07-17T16:52:34.116" v="1217" actId="20577"/>
             <ac:spMkLst>
               <pc:docMk/>
               <pc:sldMasterMk cId="2940896467" sldId="2147483648"/>
@@ -569,7 +569,7 @@
             </ac:spMkLst>
           </pc:spChg>
           <pc:spChg chg="add mod">
-            <ac:chgData name="Sam Khalil" userId="82cd1ec2-6208-465b-9d4d-40ce8f0cbf96" providerId="ADAL" clId="{651B6F30-EC96-2340-AD4B-07A6B9855D0C}" dt="2025-07-17T13:45:08.199" v="1144" actId="1076"/>
+            <ac:chgData name="Sam Khalil" userId="82cd1ec2-6208-465b-9d4d-40ce8f0cbf96" providerId="ADAL" clId="{651B6F30-EC96-2340-AD4B-07A6B9855D0C}" dt="2025-07-17T16:52:25.016" v="1206" actId="20577"/>
             <ac:spMkLst>
               <pc:docMk/>
               <pc:sldMasterMk cId="2940896467" sldId="2147483648"/>
@@ -587,7 +587,7 @@
             </ac:spMkLst>
           </pc:spChg>
           <pc:spChg chg="add mod">
-            <ac:chgData name="Sam Khalil" userId="82cd1ec2-6208-465b-9d4d-40ce8f0cbf96" providerId="ADAL" clId="{651B6F30-EC96-2340-AD4B-07A6B9855D0C}" dt="2025-07-17T13:45:08.199" v="1144" actId="1076"/>
+            <ac:chgData name="Sam Khalil" userId="82cd1ec2-6208-465b-9d4d-40ce8f0cbf96" providerId="ADAL" clId="{651B6F30-EC96-2340-AD4B-07A6B9855D0C}" dt="2025-07-17T16:52:43.058" v="1222" actId="20577"/>
             <ac:spMkLst>
               <pc:docMk/>
               <pc:sldMasterMk cId="2940896467" sldId="2147483648"/>
@@ -605,7 +605,7 @@
             </ac:spMkLst>
           </pc:spChg>
           <pc:spChg chg="add mod">
-            <ac:chgData name="Sam Khalil" userId="82cd1ec2-6208-465b-9d4d-40ce8f0cbf96" providerId="ADAL" clId="{651B6F30-EC96-2340-AD4B-07A6B9855D0C}" dt="2025-07-17T13:45:08.199" v="1144" actId="1076"/>
+            <ac:chgData name="Sam Khalil" userId="82cd1ec2-6208-465b-9d4d-40ce8f0cbf96" providerId="ADAL" clId="{651B6F30-EC96-2340-AD4B-07A6B9855D0C}" dt="2025-07-17T16:52:27.742" v="1210" actId="20577"/>
             <ac:spMkLst>
               <pc:docMk/>
               <pc:sldMasterMk cId="2940896467" sldId="2147483648"/>
@@ -614,7 +614,7 @@
             </ac:spMkLst>
           </pc:spChg>
           <pc:spChg chg="add mod">
-            <ac:chgData name="Sam Khalil" userId="82cd1ec2-6208-465b-9d4d-40ce8f0cbf96" providerId="ADAL" clId="{651B6F30-EC96-2340-AD4B-07A6B9855D0C}" dt="2025-07-17T16:43:33.189" v="1205" actId="962"/>
+            <ac:chgData name="Sam Khalil" userId="82cd1ec2-6208-465b-9d4d-40ce8f0cbf96" providerId="ADAL" clId="{651B6F30-EC96-2340-AD4B-07A6B9855D0C}" dt="2025-07-17T16:52:38.759" v="1220" actId="20577"/>
             <ac:spMkLst>
               <pc:docMk/>
               <pc:sldMasterMk cId="2940896467" sldId="2147483648"/>
@@ -5220,7 +5220,7 @@
             <a:pPr lvl="0"/>
             <a:r>
               <a:rPr lang="en-US" dirty="0"/>
-              <a:t>Text beside icon 1 maximum 10 words</a:t>
+              <a:t>Text beside icon 1 maximum 8 words</a:t>
             </a:r>
           </a:p>
         </p:txBody>
@@ -5310,7 +5310,7 @@
             <a:pPr lvl="0"/>
             <a:r>
               <a:rPr lang="en-US" dirty="0"/>
-              <a:t>Text beside icon 2 maximum 10 words</a:t>
+              <a:t>Text beside icon 2 maximum 8 words</a:t>
             </a:r>
           </a:p>
         </p:txBody>
@@ -5413,7 +5413,7 @@
             <a:pPr lvl="0"/>
             <a:r>
               <a:rPr lang="en-US" dirty="0"/>
-              <a:t>Text beside icon 3 maximum 10 words</a:t>
+              <a:t>Text beside icon 3 maximum 8 words</a:t>
             </a:r>
           </a:p>
         </p:txBody>
@@ -5516,7 +5516,7 @@
             <a:pPr lvl="0"/>
             <a:r>
               <a:rPr lang="en-US" dirty="0"/>
-              <a:t>Text beside icon 4 maximum 10 words</a:t>
+              <a:t>Text beside icon 4 maximum 8 words</a:t>
             </a:r>
           </a:p>
         </p:txBody>
@@ -5619,7 +5619,7 @@
             <a:pPr lvl="0"/>
             <a:r>
               <a:rPr lang="en-US" dirty="0"/>
-              <a:t>Text beside icon 3 maximum 10 words</a:t>
+              <a:t>Text beside icon 5 maximum 8 words</a:t>
             </a:r>
           </a:p>
         </p:txBody>
@@ -5722,7 +5722,7 @@
             <a:pPr lvl="0"/>
             <a:r>
               <a:rPr lang="en-US" dirty="0"/>
-              <a:t>Text beside icon 4 maximum 10 words</a:t>
+              <a:t>Text beside icon 6 maximum 8 words</a:t>
             </a:r>
           </a:p>
         </p:txBody>

</xml_diff>

<commit_message>
🤖 Update .gitignore to include new HTML debug output directories. Enhance auto_slides.py to support HTML visualizations in presentations, updating usage instructions and examples. Revise README.md to document new HTML visualization features and agent workflow improvements. Update layouts_export.json with detailed layout instructions and add new layouts for enhanced content generation. Modify requirements.txt to include dependencies for HTML rendering.
</commit_message>
<xml_diff>
--- a/ekona_slides_template_new.pptx
+++ b/ekona_slides_template_new.pptx
@@ -7,6 +7,9 @@
   <p:notesMasterIdLst>
     <p:notesMasterId r:id="rId5"/>
   </p:notesMasterIdLst>
+  <p:handoutMasterIdLst>
+    <p:handoutMasterId r:id="rId6"/>
+  </p:handoutMasterIdLst>
   <p:sldSz cx="12192000" cy="6858000"/>
   <p:notesSz cx="6858000" cy="9144000"/>
   <p:defaultTextStyle>
@@ -115,7 +118,7 @@
 <file path=ppt/revisionInfo.xml><?xml version="1.0" encoding="utf-8"?>
 <p1510:revInfo xmlns:a="http://schemas.openxmlformats.org/drawingml/2006/main" xmlns:r="http://schemas.openxmlformats.org/officeDocument/2006/relationships" xmlns:p1510="http://schemas.microsoft.com/office/powerpoint/2015/10/main">
   <p1510:revLst>
-    <p1510:client id="{651B6F30-EC96-2340-AD4B-07A6B9855D0C}" v="124" dt="2025-07-17T20:39:56.478"/>
+    <p1510:client id="{651B6F30-EC96-2340-AD4B-07A6B9855D0C}" v="125" dt="2025-07-17T22:12:58.955"/>
   </p1510:revLst>
 </p1510:revInfo>
 </file>
@@ -125,7 +128,7 @@
   <pc:docChgLst>
     <pc:chgData name="Sam Khalil" userId="82cd1ec2-6208-465b-9d4d-40ce8f0cbf96" providerId="ADAL" clId="{651B6F30-EC96-2340-AD4B-07A6B9855D0C}"/>
     <pc:docChg chg="undo custSel addSld delSld modSld modMainMaster">
-      <pc:chgData name="Sam Khalil" userId="82cd1ec2-6208-465b-9d4d-40ce8f0cbf96" providerId="ADAL" clId="{651B6F30-EC96-2340-AD4B-07A6B9855D0C}" dt="2025-07-17T21:10:32.513" v="1239" actId="20578"/>
+      <pc:chgData name="Sam Khalil" userId="82cd1ec2-6208-465b-9d4d-40ce8f0cbf96" providerId="ADAL" clId="{651B6F30-EC96-2340-AD4B-07A6B9855D0C}" dt="2025-07-17T22:40:18.173" v="1351" actId="1076"/>
       <pc:docMkLst>
         <pc:docMk/>
       </pc:docMkLst>
@@ -188,7 +191,7 @@
         </pc:sldMkLst>
       </pc:sldChg>
       <pc:sldMasterChg chg="addSldLayout delSldLayout modSldLayout sldLayoutOrd">
-        <pc:chgData name="Sam Khalil" userId="82cd1ec2-6208-465b-9d4d-40ce8f0cbf96" providerId="ADAL" clId="{651B6F30-EC96-2340-AD4B-07A6B9855D0C}" dt="2025-07-17T21:10:32.513" v="1239" actId="20578"/>
+        <pc:chgData name="Sam Khalil" userId="82cd1ec2-6208-465b-9d4d-40ce8f0cbf96" providerId="ADAL" clId="{651B6F30-EC96-2340-AD4B-07A6B9855D0C}" dt="2025-07-17T22:40:18.173" v="1351" actId="1076"/>
         <pc:sldMasterMkLst>
           <pc:docMk/>
           <pc:sldMasterMk cId="2940896467" sldId="2147483648"/>
@@ -730,10 +733,332 @@
             </ac:spMkLst>
           </pc:spChg>
         </pc:sldLayoutChg>
+        <pc:sldLayoutChg chg="modSp add mod modTransition">
+          <pc:chgData name="Sam Khalil" userId="82cd1ec2-6208-465b-9d4d-40ce8f0cbf96" providerId="ADAL" clId="{651B6F30-EC96-2340-AD4B-07A6B9855D0C}" dt="2025-07-17T22:12:58.955" v="1348" actId="962"/>
+          <pc:sldLayoutMkLst>
+            <pc:docMk/>
+            <pc:sldMasterMk cId="2940896467" sldId="2147483648"/>
+            <pc:sldLayoutMk cId="3855316400" sldId="2147483677"/>
+          </pc:sldLayoutMkLst>
+          <pc:spChg chg="mod">
+            <ac:chgData name="Sam Khalil" userId="82cd1ec2-6208-465b-9d4d-40ce8f0cbf96" providerId="ADAL" clId="{651B6F30-EC96-2340-AD4B-07A6B9855D0C}" dt="2025-07-17T22:12:58.955" v="1348" actId="962"/>
+            <ac:spMkLst>
+              <pc:docMk/>
+              <pc:sldMasterMk cId="2940896467" sldId="2147483648"/>
+              <pc:sldLayoutMk cId="3855316400" sldId="2147483677"/>
+              <ac:spMk id="15" creationId="{6AB10746-1273-02BA-C457-602DEDA7F5F4}"/>
+            </ac:spMkLst>
+          </pc:spChg>
+        </pc:sldLayoutChg>
+        <pc:sldLayoutChg chg="delSp modSp add mod modTransition">
+          <pc:chgData name="Sam Khalil" userId="82cd1ec2-6208-465b-9d4d-40ce8f0cbf96" providerId="ADAL" clId="{651B6F30-EC96-2340-AD4B-07A6B9855D0C}" dt="2025-07-17T22:40:18.173" v="1351" actId="1076"/>
+          <pc:sldLayoutMkLst>
+            <pc:docMk/>
+            <pc:sldMasterMk cId="2940896467" sldId="2147483648"/>
+            <pc:sldLayoutMk cId="2538074859" sldId="2147483678"/>
+          </pc:sldLayoutMkLst>
+          <pc:spChg chg="mod">
+            <ac:chgData name="Sam Khalil" userId="82cd1ec2-6208-465b-9d4d-40ce8f0cbf96" providerId="ADAL" clId="{651B6F30-EC96-2340-AD4B-07A6B9855D0C}" dt="2025-07-17T22:40:18.173" v="1351" actId="1076"/>
+            <ac:spMkLst>
+              <pc:docMk/>
+              <pc:sldMasterMk cId="2940896467" sldId="2147483648"/>
+              <pc:sldLayoutMk cId="2538074859" sldId="2147483678"/>
+              <ac:spMk id="3" creationId="{B62AA6DB-552A-718F-DB54-C39FC857289E}"/>
+            </ac:spMkLst>
+          </pc:spChg>
+          <pc:spChg chg="mod">
+            <ac:chgData name="Sam Khalil" userId="82cd1ec2-6208-465b-9d4d-40ce8f0cbf96" providerId="ADAL" clId="{651B6F30-EC96-2340-AD4B-07A6B9855D0C}" dt="2025-07-17T22:40:18.173" v="1351" actId="1076"/>
+            <ac:spMkLst>
+              <pc:docMk/>
+              <pc:sldMasterMk cId="2940896467" sldId="2147483648"/>
+              <pc:sldLayoutMk cId="2538074859" sldId="2147483678"/>
+              <ac:spMk id="4" creationId="{127F3D65-4217-C7DF-99AC-5D0069212872}"/>
+            </ac:spMkLst>
+          </pc:spChg>
+          <pc:spChg chg="del">
+            <ac:chgData name="Sam Khalil" userId="82cd1ec2-6208-465b-9d4d-40ce8f0cbf96" providerId="ADAL" clId="{651B6F30-EC96-2340-AD4B-07A6B9855D0C}" dt="2025-07-17T22:40:12.022" v="1350" actId="478"/>
+            <ac:spMkLst>
+              <pc:docMk/>
+              <pc:sldMasterMk cId="2940896467" sldId="2147483648"/>
+              <pc:sldLayoutMk cId="2538074859" sldId="2147483678"/>
+              <ac:spMk id="5" creationId="{3EC742A8-1DE0-BB3C-0CAC-88DE22F8BB50}"/>
+            </ac:spMkLst>
+          </pc:spChg>
+          <pc:spChg chg="del">
+            <ac:chgData name="Sam Khalil" userId="82cd1ec2-6208-465b-9d4d-40ce8f0cbf96" providerId="ADAL" clId="{651B6F30-EC96-2340-AD4B-07A6B9855D0C}" dt="2025-07-17T22:40:12.022" v="1350" actId="478"/>
+            <ac:spMkLst>
+              <pc:docMk/>
+              <pc:sldMasterMk cId="2940896467" sldId="2147483648"/>
+              <pc:sldLayoutMk cId="2538074859" sldId="2147483678"/>
+              <ac:spMk id="6" creationId="{78C25294-674A-0237-57DC-CE5D5F857C77}"/>
+            </ac:spMkLst>
+          </pc:spChg>
+          <pc:spChg chg="mod">
+            <ac:chgData name="Sam Khalil" userId="82cd1ec2-6208-465b-9d4d-40ce8f0cbf96" providerId="ADAL" clId="{651B6F30-EC96-2340-AD4B-07A6B9855D0C}" dt="2025-07-17T22:40:18.173" v="1351" actId="1076"/>
+            <ac:spMkLst>
+              <pc:docMk/>
+              <pc:sldMasterMk cId="2940896467" sldId="2147483648"/>
+              <pc:sldLayoutMk cId="2538074859" sldId="2147483678"/>
+              <ac:spMk id="7" creationId="{B52E7DE5-AE9F-8300-785A-713154A75462}"/>
+            </ac:spMkLst>
+          </pc:spChg>
+          <pc:spChg chg="del">
+            <ac:chgData name="Sam Khalil" userId="82cd1ec2-6208-465b-9d4d-40ce8f0cbf96" providerId="ADAL" clId="{651B6F30-EC96-2340-AD4B-07A6B9855D0C}" dt="2025-07-17T22:40:12.022" v="1350" actId="478"/>
+            <ac:spMkLst>
+              <pc:docMk/>
+              <pc:sldMasterMk cId="2940896467" sldId="2147483648"/>
+              <pc:sldLayoutMk cId="2538074859" sldId="2147483678"/>
+              <ac:spMk id="8" creationId="{DCEA0E39-252E-0FD3-E342-D8B9B2DD48A8}"/>
+            </ac:spMkLst>
+          </pc:spChg>
+          <pc:spChg chg="mod">
+            <ac:chgData name="Sam Khalil" userId="82cd1ec2-6208-465b-9d4d-40ce8f0cbf96" providerId="ADAL" clId="{651B6F30-EC96-2340-AD4B-07A6B9855D0C}" dt="2025-07-17T22:40:18.173" v="1351" actId="1076"/>
+            <ac:spMkLst>
+              <pc:docMk/>
+              <pc:sldMasterMk cId="2940896467" sldId="2147483648"/>
+              <pc:sldLayoutMk cId="2538074859" sldId="2147483678"/>
+              <ac:spMk id="9" creationId="{07863F40-906D-B17E-DD34-0C4676049440}"/>
+            </ac:spMkLst>
+          </pc:spChg>
+          <pc:spChg chg="mod">
+            <ac:chgData name="Sam Khalil" userId="82cd1ec2-6208-465b-9d4d-40ce8f0cbf96" providerId="ADAL" clId="{651B6F30-EC96-2340-AD4B-07A6B9855D0C}" dt="2025-07-17T22:40:18.173" v="1351" actId="1076"/>
+            <ac:spMkLst>
+              <pc:docMk/>
+              <pc:sldMasterMk cId="2940896467" sldId="2147483648"/>
+              <pc:sldLayoutMk cId="2538074859" sldId="2147483678"/>
+              <ac:spMk id="10" creationId="{043770B4-6CFD-292F-F28C-20F74E151142}"/>
+            </ac:spMkLst>
+          </pc:spChg>
+          <pc:spChg chg="mod">
+            <ac:chgData name="Sam Khalil" userId="82cd1ec2-6208-465b-9d4d-40ce8f0cbf96" providerId="ADAL" clId="{651B6F30-EC96-2340-AD4B-07A6B9855D0C}" dt="2025-07-17T22:40:18.173" v="1351" actId="1076"/>
+            <ac:spMkLst>
+              <pc:docMk/>
+              <pc:sldMasterMk cId="2940896467" sldId="2147483648"/>
+              <pc:sldLayoutMk cId="2538074859" sldId="2147483678"/>
+              <ac:spMk id="11" creationId="{F718040C-7B8A-9487-484F-776F0815B5C6}"/>
+            </ac:spMkLst>
+          </pc:spChg>
+          <pc:spChg chg="mod">
+            <ac:chgData name="Sam Khalil" userId="82cd1ec2-6208-465b-9d4d-40ce8f0cbf96" providerId="ADAL" clId="{651B6F30-EC96-2340-AD4B-07A6B9855D0C}" dt="2025-07-17T22:40:18.173" v="1351" actId="1076"/>
+            <ac:spMkLst>
+              <pc:docMk/>
+              <pc:sldMasterMk cId="2940896467" sldId="2147483648"/>
+              <pc:sldLayoutMk cId="2538074859" sldId="2147483678"/>
+              <ac:spMk id="12" creationId="{C9C69509-EA90-629E-7594-6FF7D385A0E7}"/>
+            </ac:spMkLst>
+          </pc:spChg>
+          <pc:spChg chg="mod">
+            <ac:chgData name="Sam Khalil" userId="82cd1ec2-6208-465b-9d4d-40ce8f0cbf96" providerId="ADAL" clId="{651B6F30-EC96-2340-AD4B-07A6B9855D0C}" dt="2025-07-17T22:40:18.173" v="1351" actId="1076"/>
+            <ac:spMkLst>
+              <pc:docMk/>
+              <pc:sldMasterMk cId="2940896467" sldId="2147483648"/>
+              <pc:sldLayoutMk cId="2538074859" sldId="2147483678"/>
+              <ac:spMk id="13" creationId="{72AA8F7B-26F0-198C-F59E-D4EAAA390678}"/>
+            </ac:spMkLst>
+          </pc:spChg>
+          <pc:spChg chg="del">
+            <ac:chgData name="Sam Khalil" userId="82cd1ec2-6208-465b-9d4d-40ce8f0cbf96" providerId="ADAL" clId="{651B6F30-EC96-2340-AD4B-07A6B9855D0C}" dt="2025-07-17T22:40:12.022" v="1350" actId="478"/>
+            <ac:spMkLst>
+              <pc:docMk/>
+              <pc:sldMasterMk cId="2940896467" sldId="2147483648"/>
+              <pc:sldLayoutMk cId="2538074859" sldId="2147483678"/>
+              <ac:spMk id="14" creationId="{BCEDE17A-C31D-39B6-1DD5-DFF09F743405}"/>
+            </ac:spMkLst>
+          </pc:spChg>
+        </pc:sldLayoutChg>
       </pc:sldMasterChg>
     </pc:docChg>
   </pc:docChgLst>
 </pc:chgInfo>
+</file>
+
+<file path=ppt/handoutMasters/handoutMaster1.xml><?xml version="1.0" encoding="utf-8"?>
+<p:handoutMaster xmlns:a="http://schemas.openxmlformats.org/drawingml/2006/main" xmlns:r="http://schemas.openxmlformats.org/officeDocument/2006/relationships" xmlns:p="http://schemas.openxmlformats.org/presentationml/2006/main">
+  <p:cSld>
+    <p:bg>
+      <p:bgRef idx="1001">
+        <a:schemeClr val="bg1"/>
+      </p:bgRef>
+    </p:bg>
+    <p:spTree>
+      <p:nvGrpSpPr>
+        <p:cNvPr id="1" name=""/>
+        <p:cNvGrpSpPr/>
+        <p:nvPr/>
+      </p:nvGrpSpPr>
+      <p:grpSpPr>
+        <a:xfrm>
+          <a:off x="0" y="0"/>
+          <a:ext cx="0" cy="0"/>
+          <a:chOff x="0" y="0"/>
+          <a:chExt cx="0" cy="0"/>
+        </a:xfrm>
+      </p:grpSpPr>
+      <p:sp>
+        <p:nvSpPr>
+          <p:cNvPr id="2" name="Header Placeholder 1">
+            <a:extLst>
+              <a:ext uri="{FF2B5EF4-FFF2-40B4-BE49-F238E27FC236}">
+                <a16:creationId xmlns:a16="http://schemas.microsoft.com/office/drawing/2014/main" id="{8F176276-5C93-B291-1FFA-5EE57E770999}"/>
+              </a:ext>
+            </a:extLst>
+          </p:cNvPr>
+          <p:cNvSpPr>
+            <a:spLocks noGrp="1"/>
+          </p:cNvSpPr>
+          <p:nvPr>
+            <p:ph type="hdr" sz="quarter"/>
+          </p:nvPr>
+        </p:nvSpPr>
+        <p:spPr>
+          <a:xfrm>
+            <a:off x="0" y="0"/>
+            <a:ext cx="2971800" cy="458788"/>
+          </a:xfrm>
+          <a:prstGeom prst="rect">
+            <a:avLst/>
+          </a:prstGeom>
+        </p:spPr>
+        <p:txBody>
+          <a:bodyPr vert="horz" lIns="91440" tIns="45720" rIns="91440" bIns="45720" rtlCol="0"/>
+          <a:lstStyle>
+            <a:lvl1pPr algn="l">
+              <a:defRPr sz="1200"/>
+            </a:lvl1pPr>
+          </a:lstStyle>
+          <a:p>
+            <a:endParaRPr lang="en-US"/>
+          </a:p>
+        </p:txBody>
+      </p:sp>
+      <p:sp>
+        <p:nvSpPr>
+          <p:cNvPr id="3" name="Date Placeholder 2">
+            <a:extLst>
+              <a:ext uri="{FF2B5EF4-FFF2-40B4-BE49-F238E27FC236}">
+                <a16:creationId xmlns:a16="http://schemas.microsoft.com/office/drawing/2014/main" id="{82ABEB5B-200E-F336-CA88-E868C611F540}"/>
+              </a:ext>
+            </a:extLst>
+          </p:cNvPr>
+          <p:cNvSpPr>
+            <a:spLocks noGrp="1"/>
+          </p:cNvSpPr>
+          <p:nvPr>
+            <p:ph type="dt" sz="quarter" idx="1"/>
+          </p:nvPr>
+        </p:nvSpPr>
+        <p:spPr>
+          <a:xfrm>
+            <a:off x="3884613" y="0"/>
+            <a:ext cx="2971800" cy="458788"/>
+          </a:xfrm>
+          <a:prstGeom prst="rect">
+            <a:avLst/>
+          </a:prstGeom>
+        </p:spPr>
+        <p:txBody>
+          <a:bodyPr vert="horz" lIns="91440" tIns="45720" rIns="91440" bIns="45720" rtlCol="0"/>
+          <a:lstStyle>
+            <a:lvl1pPr algn="r">
+              <a:defRPr sz="1200"/>
+            </a:lvl1pPr>
+          </a:lstStyle>
+          <a:p>
+            <a:fld id="{D2339670-67E6-CD42-B7B2-F285F1108ED9}" type="datetimeFigureOut">
+              <a:rPr lang="en-US" smtClean="0"/>
+              <a:t>7/18/25</a:t>
+            </a:fld>
+            <a:endParaRPr lang="en-US"/>
+          </a:p>
+        </p:txBody>
+      </p:sp>
+      <p:sp>
+        <p:nvSpPr>
+          <p:cNvPr id="4" name="Footer Placeholder 3">
+            <a:extLst>
+              <a:ext uri="{FF2B5EF4-FFF2-40B4-BE49-F238E27FC236}">
+                <a16:creationId xmlns:a16="http://schemas.microsoft.com/office/drawing/2014/main" id="{E6ACAD6E-E91B-6F1E-E490-AC92B1EAA655}"/>
+              </a:ext>
+            </a:extLst>
+          </p:cNvPr>
+          <p:cNvSpPr>
+            <a:spLocks noGrp="1"/>
+          </p:cNvSpPr>
+          <p:nvPr>
+            <p:ph type="ftr" sz="quarter" idx="2"/>
+          </p:nvPr>
+        </p:nvSpPr>
+        <p:spPr>
+          <a:xfrm>
+            <a:off x="0" y="8685213"/>
+            <a:ext cx="2971800" cy="458787"/>
+          </a:xfrm>
+          <a:prstGeom prst="rect">
+            <a:avLst/>
+          </a:prstGeom>
+        </p:spPr>
+        <p:txBody>
+          <a:bodyPr vert="horz" lIns="91440" tIns="45720" rIns="91440" bIns="45720" rtlCol="0" anchor="b"/>
+          <a:lstStyle>
+            <a:lvl1pPr algn="l">
+              <a:defRPr sz="1200"/>
+            </a:lvl1pPr>
+          </a:lstStyle>
+          <a:p>
+            <a:endParaRPr lang="en-US"/>
+          </a:p>
+        </p:txBody>
+      </p:sp>
+      <p:sp>
+        <p:nvSpPr>
+          <p:cNvPr id="5" name="Slide Number Placeholder 4">
+            <a:extLst>
+              <a:ext uri="{FF2B5EF4-FFF2-40B4-BE49-F238E27FC236}">
+                <a16:creationId xmlns:a16="http://schemas.microsoft.com/office/drawing/2014/main" id="{EFFA7424-9AC4-0A8C-73C0-968DEE32D004}"/>
+              </a:ext>
+            </a:extLst>
+          </p:cNvPr>
+          <p:cNvSpPr>
+            <a:spLocks noGrp="1"/>
+          </p:cNvSpPr>
+          <p:nvPr>
+            <p:ph type="sldNum" sz="quarter" idx="3"/>
+          </p:nvPr>
+        </p:nvSpPr>
+        <p:spPr>
+          <a:xfrm>
+            <a:off x="3884613" y="8685213"/>
+            <a:ext cx="2971800" cy="458787"/>
+          </a:xfrm>
+          <a:prstGeom prst="rect">
+            <a:avLst/>
+          </a:prstGeom>
+        </p:spPr>
+        <p:txBody>
+          <a:bodyPr vert="horz" lIns="91440" tIns="45720" rIns="91440" bIns="45720" rtlCol="0" anchor="b"/>
+          <a:lstStyle>
+            <a:lvl1pPr algn="r">
+              <a:defRPr sz="1200"/>
+            </a:lvl1pPr>
+          </a:lstStyle>
+          <a:p>
+            <a:fld id="{258E359B-77B9-AE44-954F-84AC5F143DB8}" type="slidenum">
+              <a:rPr lang="en-US" smtClean="0"/>
+              <a:t>‹#›</a:t>
+            </a:fld>
+            <a:endParaRPr lang="en-US"/>
+          </a:p>
+        </p:txBody>
+      </p:sp>
+    </p:spTree>
+    <p:extLst>
+      <p:ext uri="{BB962C8B-B14F-4D97-AF65-F5344CB8AC3E}">
+        <p14:creationId xmlns:p14="http://schemas.microsoft.com/office/powerpoint/2010/main" val="1304214745"/>
+      </p:ext>
+    </p:extLst>
+  </p:cSld>
+  <p:clrMap bg1="lt1" tx1="dk1" bg2="lt2" tx2="dk2" accent1="accent1" accent2="accent2" accent3="accent3" accent4="accent4" accent5="accent5" accent6="accent6" hlink="hlink" folHlink="folHlink"/>
+</p:handoutMaster>
 </file>
 
 <file path=ppt/notesMasters/notesMaster1.xml><?xml version="1.0" encoding="utf-8"?>
@@ -1220,6 +1545,293 @@
 
 <file path=ppt/slideLayouts/slideLayout10.xml><?xml version="1.0" encoding="utf-8"?>
 <p:sldLayout xmlns:a="http://schemas.openxmlformats.org/drawingml/2006/main" xmlns:r="http://schemas.openxmlformats.org/officeDocument/2006/relationships" xmlns:p="http://schemas.openxmlformats.org/presentationml/2006/main" preserve="1" userDrawn="1">
+  <p:cSld name="1_Conclusion Slide">
+    <p:spTree>
+      <p:nvGrpSpPr>
+        <p:cNvPr id="1" name=""/>
+        <p:cNvGrpSpPr/>
+        <p:nvPr/>
+      </p:nvGrpSpPr>
+      <p:grpSpPr>
+        <a:xfrm>
+          <a:off x="0" y="0"/>
+          <a:ext cx="0" cy="0"/>
+          <a:chOff x="0" y="0"/>
+          <a:chExt cx="0" cy="0"/>
+        </a:xfrm>
+      </p:grpSpPr>
+      <p:sp>
+        <p:nvSpPr>
+          <p:cNvPr id="2" name="Conclusion Title">
+            <a:extLst>
+              <a:ext uri="{FF2B5EF4-FFF2-40B4-BE49-F238E27FC236}">
+                <a16:creationId xmlns:a16="http://schemas.microsoft.com/office/drawing/2014/main" id="{3CD97974-B93C-4C96-B3F6-F69E3D6DE6CA}"/>
+              </a:ext>
+            </a:extLst>
+          </p:cNvPr>
+          <p:cNvSpPr>
+            <a:spLocks noGrp="1"/>
+          </p:cNvSpPr>
+          <p:nvPr>
+            <p:ph type="title" hasCustomPrompt="1"/>
+          </p:nvPr>
+        </p:nvSpPr>
+        <p:spPr>
+          <a:xfrm>
+            <a:off x="381000" y="381000"/>
+            <a:ext cx="11430000" cy="1325563"/>
+          </a:xfrm>
+          <a:prstGeom prst="rect">
+            <a:avLst/>
+          </a:prstGeom>
+        </p:spPr>
+        <p:txBody>
+          <a:bodyPr vert="horz" lIns="91440" tIns="45720" rIns="91440" bIns="45720" rtlCol="0" anchor="ctr">
+            <a:noAutofit/>
+          </a:bodyPr>
+          <a:lstStyle>
+            <a:lvl1pPr algn="l" defTabSz="914400" rtl="0" eaLnBrk="1" latinLnBrk="0" hangingPunct="1">
+              <a:lnSpc>
+                <a:spcPct val="80000"/>
+              </a:lnSpc>
+              <a:spcBef>
+                <a:spcPct val="0"/>
+              </a:spcBef>
+              <a:buNone/>
+              <a:defRPr sz="4400" b="1" kern="1200">
+                <a:solidFill>
+                  <a:schemeClr val="tx1"/>
+                </a:solidFill>
+                <a:latin typeface="+mn-lt"/>
+                <a:ea typeface="+mj-ea"/>
+                <a:cs typeface="+mj-cs"/>
+              </a:defRPr>
+            </a:lvl1pPr>
+          </a:lstStyle>
+          <a:p>
+            <a:r>
+              <a:rPr lang="en-US" dirty="0"/>
+              <a:t>Short and clear conclusion Title</a:t>
+            </a:r>
+          </a:p>
+        </p:txBody>
+      </p:sp>
+      <p:sp>
+        <p:nvSpPr>
+          <p:cNvPr id="3" name="Conclusion text">
+            <a:extLst>
+              <a:ext uri="{FF2B5EF4-FFF2-40B4-BE49-F238E27FC236}">
+                <a16:creationId xmlns:a16="http://schemas.microsoft.com/office/drawing/2014/main" id="{8A6FC6F2-80B4-49A7-9448-33FE2DF0E967}"/>
+              </a:ext>
+            </a:extLst>
+          </p:cNvPr>
+          <p:cNvSpPr>
+            <a:spLocks noGrp="1"/>
+          </p:cNvSpPr>
+          <p:nvPr>
+            <p:ph idx="1" hasCustomPrompt="1"/>
+          </p:nvPr>
+        </p:nvSpPr>
+        <p:spPr>
+          <a:xfrm>
+            <a:off x="381000" y="1825625"/>
+            <a:ext cx="11430000" cy="4351338"/>
+          </a:xfrm>
+          <a:prstGeom prst="rect">
+            <a:avLst/>
+          </a:prstGeom>
+        </p:spPr>
+        <p:txBody>
+          <a:bodyPr vert="horz" lIns="91440" tIns="45720" rIns="91440" bIns="45720" rtlCol="0">
+            <a:noAutofit/>
+          </a:bodyPr>
+          <a:lstStyle>
+            <a:lvl1pPr marL="0" indent="0" algn="l" defTabSz="914400" rtl="0" eaLnBrk="1" latinLnBrk="0" hangingPunct="1">
+              <a:lnSpc>
+                <a:spcPct val="90000"/>
+              </a:lnSpc>
+              <a:spcBef>
+                <a:spcPts val="1000"/>
+              </a:spcBef>
+              <a:buFont typeface="Arial" panose="020B0604020202020204" pitchFamily="34" charset="0"/>
+              <a:buNone/>
+              <a:defRPr sz="2000" b="0" kern="1200">
+                <a:solidFill>
+                  <a:schemeClr val="tx1"/>
+                </a:solidFill>
+                <a:latin typeface="+mn-lt"/>
+                <a:ea typeface="+mn-ea"/>
+                <a:cs typeface="+mn-cs"/>
+              </a:defRPr>
+            </a:lvl1pPr>
+            <a:lvl2pPr marL="685800" indent="-228600" algn="l" defTabSz="914400" rtl="0" eaLnBrk="1" latinLnBrk="0" hangingPunct="1">
+              <a:lnSpc>
+                <a:spcPct val="90000"/>
+              </a:lnSpc>
+              <a:spcBef>
+                <a:spcPts val="500"/>
+              </a:spcBef>
+              <a:buFont typeface="Arial" panose="020B0604020202020204" pitchFamily="34" charset="0"/>
+              <a:buChar char="•"/>
+              <a:defRPr sz="2400" b="0" kern="1200">
+                <a:solidFill>
+                  <a:schemeClr val="tx1"/>
+                </a:solidFill>
+                <a:latin typeface="+mn-lt"/>
+                <a:ea typeface="+mn-ea"/>
+                <a:cs typeface="+mn-cs"/>
+              </a:defRPr>
+            </a:lvl2pPr>
+            <a:lvl3pPr marL="1143000" indent="-228600" algn="l" defTabSz="914400" rtl="0" eaLnBrk="1" latinLnBrk="0" hangingPunct="1">
+              <a:lnSpc>
+                <a:spcPct val="90000"/>
+              </a:lnSpc>
+              <a:spcBef>
+                <a:spcPts val="500"/>
+              </a:spcBef>
+              <a:buFont typeface="Arial" panose="020B0604020202020204" pitchFamily="34" charset="0"/>
+              <a:buChar char="•"/>
+              <a:defRPr sz="2000" b="0" kern="1200">
+                <a:solidFill>
+                  <a:schemeClr val="tx1"/>
+                </a:solidFill>
+                <a:latin typeface="+mn-lt"/>
+                <a:ea typeface="+mn-ea"/>
+                <a:cs typeface="+mn-cs"/>
+              </a:defRPr>
+            </a:lvl3pPr>
+            <a:lvl4pPr marL="1600200" indent="-228600" algn="l" defTabSz="914400" rtl="0" eaLnBrk="1" latinLnBrk="0" hangingPunct="1">
+              <a:lnSpc>
+                <a:spcPct val="90000"/>
+              </a:lnSpc>
+              <a:spcBef>
+                <a:spcPts val="500"/>
+              </a:spcBef>
+              <a:buFont typeface="Arial" panose="020B0604020202020204" pitchFamily="34" charset="0"/>
+              <a:buChar char="•"/>
+              <a:defRPr sz="1800" b="0" kern="1200">
+                <a:solidFill>
+                  <a:schemeClr val="tx1"/>
+                </a:solidFill>
+                <a:latin typeface="+mn-lt"/>
+                <a:ea typeface="+mn-ea"/>
+                <a:cs typeface="+mn-cs"/>
+              </a:defRPr>
+            </a:lvl4pPr>
+            <a:lvl5pPr marL="2057400" indent="-228600" algn="l" defTabSz="914400" rtl="0" eaLnBrk="1" latinLnBrk="0" hangingPunct="1">
+              <a:lnSpc>
+                <a:spcPct val="90000"/>
+              </a:lnSpc>
+              <a:spcBef>
+                <a:spcPts val="500"/>
+              </a:spcBef>
+              <a:buFont typeface="Arial" panose="020B0604020202020204" pitchFamily="34" charset="0"/>
+              <a:buChar char="•"/>
+              <a:defRPr sz="1800" b="0" kern="1200">
+                <a:solidFill>
+                  <a:schemeClr val="tx1"/>
+                </a:solidFill>
+                <a:latin typeface="+mn-lt"/>
+                <a:ea typeface="+mn-ea"/>
+                <a:cs typeface="+mn-cs"/>
+              </a:defRPr>
+            </a:lvl5pPr>
+            <a:lvl6pPr marL="2514600" indent="-228600" algn="l" defTabSz="914400" rtl="0" eaLnBrk="1" latinLnBrk="0" hangingPunct="1">
+              <a:lnSpc>
+                <a:spcPct val="90000"/>
+              </a:lnSpc>
+              <a:spcBef>
+                <a:spcPts val="500"/>
+              </a:spcBef>
+              <a:buFont typeface="Arial" panose="020B0604020202020204" pitchFamily="34" charset="0"/>
+              <a:buChar char="•"/>
+              <a:defRPr sz="1800" kern="1200">
+                <a:solidFill>
+                  <a:schemeClr val="tx1"/>
+                </a:solidFill>
+                <a:latin typeface="+mn-lt"/>
+                <a:ea typeface="+mn-ea"/>
+                <a:cs typeface="+mn-cs"/>
+              </a:defRPr>
+            </a:lvl6pPr>
+            <a:lvl7pPr marL="2971800" indent="-228600" algn="l" defTabSz="914400" rtl="0" eaLnBrk="1" latinLnBrk="0" hangingPunct="1">
+              <a:lnSpc>
+                <a:spcPct val="90000"/>
+              </a:lnSpc>
+              <a:spcBef>
+                <a:spcPts val="500"/>
+              </a:spcBef>
+              <a:buFont typeface="Arial" panose="020B0604020202020204" pitchFamily="34" charset="0"/>
+              <a:buChar char="•"/>
+              <a:defRPr sz="1800" kern="1200">
+                <a:solidFill>
+                  <a:schemeClr val="tx1"/>
+                </a:solidFill>
+                <a:latin typeface="+mn-lt"/>
+                <a:ea typeface="+mn-ea"/>
+                <a:cs typeface="+mn-cs"/>
+              </a:defRPr>
+            </a:lvl7pPr>
+            <a:lvl8pPr marL="3429000" indent="-228600" algn="l" defTabSz="914400" rtl="0" eaLnBrk="1" latinLnBrk="0" hangingPunct="1">
+              <a:lnSpc>
+                <a:spcPct val="90000"/>
+              </a:lnSpc>
+              <a:spcBef>
+                <a:spcPts val="500"/>
+              </a:spcBef>
+              <a:buFont typeface="Arial" panose="020B0604020202020204" pitchFamily="34" charset="0"/>
+              <a:buChar char="•"/>
+              <a:defRPr sz="1800" kern="1200">
+                <a:solidFill>
+                  <a:schemeClr val="tx1"/>
+                </a:solidFill>
+                <a:latin typeface="+mn-lt"/>
+                <a:ea typeface="+mn-ea"/>
+                <a:cs typeface="+mn-cs"/>
+              </a:defRPr>
+            </a:lvl8pPr>
+            <a:lvl9pPr marL="3886200" indent="-228600" algn="l" defTabSz="914400" rtl="0" eaLnBrk="1" latinLnBrk="0" hangingPunct="1">
+              <a:lnSpc>
+                <a:spcPct val="90000"/>
+              </a:lnSpc>
+              <a:spcBef>
+                <a:spcPts val="500"/>
+              </a:spcBef>
+              <a:buFont typeface="Arial" panose="020B0604020202020204" pitchFamily="34" charset="0"/>
+              <a:buChar char="•"/>
+              <a:defRPr sz="1800" kern="1200">
+                <a:solidFill>
+                  <a:schemeClr val="tx1"/>
+                </a:solidFill>
+                <a:latin typeface="+mn-lt"/>
+                <a:ea typeface="+mn-ea"/>
+                <a:cs typeface="+mn-cs"/>
+              </a:defRPr>
+            </a:lvl9pPr>
+          </a:lstStyle>
+          <a:p>
+            <a:r>
+              <a:rPr lang="en-US" dirty="0"/>
+              <a:t>A bulleted list of items and a short conclusion text</a:t>
+            </a:r>
+          </a:p>
+        </p:txBody>
+      </p:sp>
+    </p:spTree>
+    <p:extLst>
+      <p:ext uri="{BB962C8B-B14F-4D97-AF65-F5344CB8AC3E}">
+        <p14:creationId xmlns:p14="http://schemas.microsoft.com/office/powerpoint/2010/main" val="88811751"/>
+      </p:ext>
+    </p:extLst>
+  </p:cSld>
+  <p:clrMapOvr>
+    <a:masterClrMapping/>
+  </p:clrMapOvr>
+</p:sldLayout>
+</file>
+
+<file path=ppt/slideLayouts/slideLayout11.xml><?xml version="1.0" encoding="utf-8"?>
+<p:sldLayout xmlns:a="http://schemas.openxmlformats.org/drawingml/2006/main" xmlns:r="http://schemas.openxmlformats.org/officeDocument/2006/relationships" xmlns:p="http://schemas.openxmlformats.org/presentationml/2006/main" preserve="1" userDrawn="1">
   <p:cSld name="Branding Slide should always be added at the end of the deck">
     <p:spTree>
       <p:nvGrpSpPr>
@@ -1980,7 +2592,7 @@
 </p:sldLayout>
 </file>
 
-<file path=ppt/slideLayouts/slideLayout11.xml><?xml version="1.0" encoding="utf-8"?>
+<file path=ppt/slideLayouts/slideLayout12.xml><?xml version="1.0" encoding="utf-8"?>
 <p:sldLayout xmlns:a="http://schemas.openxmlformats.org/drawingml/2006/main" xmlns:r="http://schemas.openxmlformats.org/officeDocument/2006/relationships" xmlns:p="http://schemas.openxmlformats.org/presentationml/2006/main" preserve="1" userDrawn="1">
   <p:cSld name="Branding Slide #2 should always be added at the end of the deck">
     <p:spTree>
@@ -3803,6 +4415,301 @@
 
 <file path=ppt/slideLayouts/slideLayout4.xml><?xml version="1.0" encoding="utf-8"?>
 <p:sldLayout xmlns:a="http://schemas.openxmlformats.org/drawingml/2006/main" xmlns:r="http://schemas.openxmlformats.org/officeDocument/2006/relationships" xmlns:p="http://schemas.openxmlformats.org/presentationml/2006/main" preserve="1" userDrawn="1">
+  <p:cSld name="Title and Picture generated from HTML">
+    <p:spTree>
+      <p:nvGrpSpPr>
+        <p:cNvPr id="1" name=""/>
+        <p:cNvGrpSpPr/>
+        <p:nvPr/>
+      </p:nvGrpSpPr>
+      <p:grpSpPr>
+        <a:xfrm>
+          <a:off x="0" y="0"/>
+          <a:ext cx="0" cy="0"/>
+          <a:chOff x="0" y="0"/>
+          <a:chExt cx="0" cy="0"/>
+        </a:xfrm>
+      </p:grpSpPr>
+      <p:sp>
+        <p:nvSpPr>
+          <p:cNvPr id="2" name="Title">
+            <a:extLst>
+              <a:ext uri="{FF2B5EF4-FFF2-40B4-BE49-F238E27FC236}">
+                <a16:creationId xmlns:a16="http://schemas.microsoft.com/office/drawing/2014/main" id="{3CD97974-B93C-4C96-B3F6-F69E3D6DE6CA}"/>
+              </a:ext>
+            </a:extLst>
+          </p:cNvPr>
+          <p:cNvSpPr>
+            <a:spLocks noGrp="1"/>
+          </p:cNvSpPr>
+          <p:nvPr>
+            <p:ph type="title" hasCustomPrompt="1"/>
+          </p:nvPr>
+        </p:nvSpPr>
+        <p:spPr>
+          <a:xfrm>
+            <a:off x="381000" y="381000"/>
+            <a:ext cx="11430000" cy="1325563"/>
+          </a:xfrm>
+          <a:prstGeom prst="rect">
+            <a:avLst/>
+          </a:prstGeom>
+        </p:spPr>
+        <p:txBody>
+          <a:bodyPr vert="horz" lIns="91440" tIns="45720" rIns="91440" bIns="45720" rtlCol="0" anchor="ctr">
+            <a:noAutofit/>
+          </a:bodyPr>
+          <a:lstStyle>
+            <a:lvl1pPr algn="l" defTabSz="914400" rtl="0" eaLnBrk="1" latinLnBrk="0" hangingPunct="1">
+              <a:lnSpc>
+                <a:spcPct val="80000"/>
+              </a:lnSpc>
+              <a:spcBef>
+                <a:spcPct val="0"/>
+              </a:spcBef>
+              <a:buNone/>
+              <a:defRPr sz="4400" b="1" kern="1200">
+                <a:solidFill>
+                  <a:schemeClr val="tx1"/>
+                </a:solidFill>
+                <a:latin typeface="Calibri" panose="020F0502020204030204" pitchFamily="34" charset="0"/>
+                <a:ea typeface="+mj-ea"/>
+                <a:cs typeface="Calibri" panose="020F0502020204030204" pitchFamily="34" charset="0"/>
+              </a:defRPr>
+            </a:lvl1pPr>
+          </a:lstStyle>
+          <a:p>
+            <a:r>
+              <a:rPr lang="en-US" dirty="0"/>
+              <a:t>Title of the slide, short and concise</a:t>
+            </a:r>
+          </a:p>
+        </p:txBody>
+      </p:sp>
+      <p:sp>
+        <p:nvSpPr>
+          <p:cNvPr id="15" name="Picture from HTML">
+            <a:extLst>
+              <a:ext uri="{FF2B5EF4-FFF2-40B4-BE49-F238E27FC236}">
+                <a16:creationId xmlns:a16="http://schemas.microsoft.com/office/drawing/2014/main" id="{6AB10746-1273-02BA-C457-602DEDA7F5F4}"/>
+              </a:ext>
+            </a:extLst>
+          </p:cNvPr>
+          <p:cNvSpPr>
+            <a:spLocks noGrp="1"/>
+          </p:cNvSpPr>
+          <p:nvPr>
+            <p:ph type="pic" sz="quarter" idx="10" hasCustomPrompt="1"/>
+          </p:nvPr>
+        </p:nvSpPr>
+        <p:spPr>
+          <a:xfrm>
+            <a:off x="381000" y="1825625"/>
+            <a:ext cx="11430000" cy="4351338"/>
+          </a:xfrm>
+          <a:prstGeom prst="rect">
+            <a:avLst/>
+          </a:prstGeom>
+        </p:spPr>
+        <p:txBody>
+          <a:bodyPr vert="horz" lIns="91440" tIns="45720" rIns="91440" bIns="45720" rtlCol="0">
+            <a:noAutofit/>
+          </a:bodyPr>
+          <a:lstStyle>
+            <a:lvl1pPr marL="0" indent="0" algn="l" defTabSz="914400" rtl="0" eaLnBrk="1" latinLnBrk="0" hangingPunct="1">
+              <a:lnSpc>
+                <a:spcPct val="90000"/>
+              </a:lnSpc>
+              <a:spcBef>
+                <a:spcPts val="1000"/>
+              </a:spcBef>
+              <a:buFont typeface="Arial" panose="020B0604020202020204" pitchFamily="34" charset="0"/>
+              <a:buNone/>
+              <a:defRPr sz="2000" kern="1200">
+                <a:solidFill>
+                  <a:schemeClr val="tx1"/>
+                </a:solidFill>
+                <a:latin typeface="+mn-lt"/>
+                <a:ea typeface="+mn-ea"/>
+                <a:cs typeface="+mn-cs"/>
+              </a:defRPr>
+            </a:lvl1pPr>
+            <a:lvl2pPr marL="685800" indent="-228600" algn="l" defTabSz="914400" rtl="0" eaLnBrk="1" latinLnBrk="0" hangingPunct="1">
+              <a:lnSpc>
+                <a:spcPct val="90000"/>
+              </a:lnSpc>
+              <a:spcBef>
+                <a:spcPts val="500"/>
+              </a:spcBef>
+              <a:buFont typeface="Arial" panose="020B0604020202020204" pitchFamily="34" charset="0"/>
+              <a:buChar char="•"/>
+              <a:defRPr sz="2400" kern="1200">
+                <a:solidFill>
+                  <a:schemeClr val="tx1"/>
+                </a:solidFill>
+                <a:latin typeface="+mn-lt"/>
+                <a:ea typeface="+mn-ea"/>
+                <a:cs typeface="+mn-cs"/>
+              </a:defRPr>
+            </a:lvl2pPr>
+            <a:lvl3pPr marL="1143000" indent="-228600" algn="l" defTabSz="914400" rtl="0" eaLnBrk="1" latinLnBrk="0" hangingPunct="1">
+              <a:lnSpc>
+                <a:spcPct val="90000"/>
+              </a:lnSpc>
+              <a:spcBef>
+                <a:spcPts val="500"/>
+              </a:spcBef>
+              <a:buFont typeface="Arial" panose="020B0604020202020204" pitchFamily="34" charset="0"/>
+              <a:buChar char="•"/>
+              <a:defRPr sz="2000" kern="1200">
+                <a:solidFill>
+                  <a:schemeClr val="tx1"/>
+                </a:solidFill>
+                <a:latin typeface="+mn-lt"/>
+                <a:ea typeface="+mn-ea"/>
+                <a:cs typeface="+mn-cs"/>
+              </a:defRPr>
+            </a:lvl3pPr>
+            <a:lvl4pPr marL="1600200" indent="-228600" algn="l" defTabSz="914400" rtl="0" eaLnBrk="1" latinLnBrk="0" hangingPunct="1">
+              <a:lnSpc>
+                <a:spcPct val="90000"/>
+              </a:lnSpc>
+              <a:spcBef>
+                <a:spcPts val="500"/>
+              </a:spcBef>
+              <a:buFont typeface="Arial" panose="020B0604020202020204" pitchFamily="34" charset="0"/>
+              <a:buChar char="•"/>
+              <a:defRPr sz="1800" kern="1200">
+                <a:solidFill>
+                  <a:schemeClr val="tx1"/>
+                </a:solidFill>
+                <a:latin typeface="+mn-lt"/>
+                <a:ea typeface="+mn-ea"/>
+                <a:cs typeface="+mn-cs"/>
+              </a:defRPr>
+            </a:lvl4pPr>
+            <a:lvl5pPr marL="2057400" indent="-228600" algn="l" defTabSz="914400" rtl="0" eaLnBrk="1" latinLnBrk="0" hangingPunct="1">
+              <a:lnSpc>
+                <a:spcPct val="90000"/>
+              </a:lnSpc>
+              <a:spcBef>
+                <a:spcPts val="500"/>
+              </a:spcBef>
+              <a:buFont typeface="Arial" panose="020B0604020202020204" pitchFamily="34" charset="0"/>
+              <a:buChar char="•"/>
+              <a:defRPr sz="1800" kern="1200">
+                <a:solidFill>
+                  <a:schemeClr val="tx1"/>
+                </a:solidFill>
+                <a:latin typeface="+mn-lt"/>
+                <a:ea typeface="+mn-ea"/>
+                <a:cs typeface="+mn-cs"/>
+              </a:defRPr>
+            </a:lvl5pPr>
+            <a:lvl6pPr marL="2514600" indent="-228600" algn="l" defTabSz="914400" rtl="0" eaLnBrk="1" latinLnBrk="0" hangingPunct="1">
+              <a:lnSpc>
+                <a:spcPct val="90000"/>
+              </a:lnSpc>
+              <a:spcBef>
+                <a:spcPts val="500"/>
+              </a:spcBef>
+              <a:buFont typeface="Arial" panose="020B0604020202020204" pitchFamily="34" charset="0"/>
+              <a:buChar char="•"/>
+              <a:defRPr sz="1800" kern="1200">
+                <a:solidFill>
+                  <a:schemeClr val="tx1"/>
+                </a:solidFill>
+                <a:latin typeface="+mn-lt"/>
+                <a:ea typeface="+mn-ea"/>
+                <a:cs typeface="+mn-cs"/>
+              </a:defRPr>
+            </a:lvl6pPr>
+            <a:lvl7pPr marL="2971800" indent="-228600" algn="l" defTabSz="914400" rtl="0" eaLnBrk="1" latinLnBrk="0" hangingPunct="1">
+              <a:lnSpc>
+                <a:spcPct val="90000"/>
+              </a:lnSpc>
+              <a:spcBef>
+                <a:spcPts val="500"/>
+              </a:spcBef>
+              <a:buFont typeface="Arial" panose="020B0604020202020204" pitchFamily="34" charset="0"/>
+              <a:buChar char="•"/>
+              <a:defRPr sz="1800" kern="1200">
+                <a:solidFill>
+                  <a:schemeClr val="tx1"/>
+                </a:solidFill>
+                <a:latin typeface="+mn-lt"/>
+                <a:ea typeface="+mn-ea"/>
+                <a:cs typeface="+mn-cs"/>
+              </a:defRPr>
+            </a:lvl7pPr>
+            <a:lvl8pPr marL="3429000" indent="-228600" algn="l" defTabSz="914400" rtl="0" eaLnBrk="1" latinLnBrk="0" hangingPunct="1">
+              <a:lnSpc>
+                <a:spcPct val="90000"/>
+              </a:lnSpc>
+              <a:spcBef>
+                <a:spcPts val="500"/>
+              </a:spcBef>
+              <a:buFont typeface="Arial" panose="020B0604020202020204" pitchFamily="34" charset="0"/>
+              <a:buChar char="•"/>
+              <a:defRPr sz="1800" kern="1200">
+                <a:solidFill>
+                  <a:schemeClr val="tx1"/>
+                </a:solidFill>
+                <a:latin typeface="+mn-lt"/>
+                <a:ea typeface="+mn-ea"/>
+                <a:cs typeface="+mn-cs"/>
+              </a:defRPr>
+            </a:lvl8pPr>
+            <a:lvl9pPr marL="3886200" indent="-228600" algn="l" defTabSz="914400" rtl="0" eaLnBrk="1" latinLnBrk="0" hangingPunct="1">
+              <a:lnSpc>
+                <a:spcPct val="90000"/>
+              </a:lnSpc>
+              <a:spcBef>
+                <a:spcPts val="500"/>
+              </a:spcBef>
+              <a:buFont typeface="Arial" panose="020B0604020202020204" pitchFamily="34" charset="0"/>
+              <a:buChar char="•"/>
+              <a:defRPr sz="1800" kern="1200">
+                <a:solidFill>
+                  <a:schemeClr val="tx1"/>
+                </a:solidFill>
+                <a:latin typeface="+mn-lt"/>
+                <a:ea typeface="+mn-ea"/>
+                <a:cs typeface="+mn-cs"/>
+              </a:defRPr>
+            </a:lvl9pPr>
+          </a:lstStyle>
+          <a:p>
+            <a:r>
+              <a:rPr lang="en-US" dirty="0"/>
+              <a:t>A picture that has been generated from an HTML code (</a:t>
+            </a:r>
+            <a:r>
+              <a:rPr lang="en-US" dirty="0" err="1"/>
+              <a:t>e.g</a:t>
+            </a:r>
+            <a:r>
+              <a:rPr lang="en-US" dirty="0"/>
+              <a:t> Timelines, steps of action ,etc..)</a:t>
+            </a:r>
+          </a:p>
+        </p:txBody>
+      </p:sp>
+    </p:spTree>
+    <p:extLst>
+      <p:ext uri="{BB962C8B-B14F-4D97-AF65-F5344CB8AC3E}">
+        <p14:creationId xmlns:p14="http://schemas.microsoft.com/office/powerpoint/2010/main" val="3855316400"/>
+      </p:ext>
+    </p:extLst>
+  </p:cSld>
+  <p:clrMapOvr>
+    <a:masterClrMapping/>
+  </p:clrMapOvr>
+</p:sldLayout>
+</file>
+
+<file path=ppt/slideLayouts/slideLayout5.xml><?xml version="1.0" encoding="utf-8"?>
+<p:sldLayout xmlns:a="http://schemas.openxmlformats.org/drawingml/2006/main" xmlns:r="http://schemas.openxmlformats.org/officeDocument/2006/relationships" xmlns:p="http://schemas.openxmlformats.org/presentationml/2006/main" preserve="1" userDrawn="1">
   <p:cSld name="Title and Text Content">
     <p:spTree>
       <p:nvGrpSpPr>
@@ -4088,7 +4995,7 @@
 </p:sldLayout>
 </file>
 
-<file path=ppt/slideLayouts/slideLayout5.xml><?xml version="1.0" encoding="utf-8"?>
+<file path=ppt/slideLayouts/slideLayout6.xml><?xml version="1.0" encoding="utf-8"?>
 <p:sldLayout xmlns:a="http://schemas.openxmlformats.org/drawingml/2006/main" xmlns:r="http://schemas.openxmlformats.org/officeDocument/2006/relationships" xmlns:p="http://schemas.openxmlformats.org/presentationml/2006/main" preserve="1" userDrawn="1">
   <p:cSld name="Single Chart Slide">
     <p:spTree>
@@ -4375,7 +5282,7 @@
 </p:sldLayout>
 </file>
 
-<file path=ppt/slideLayouts/slideLayout6.xml><?xml version="1.0" encoding="utf-8"?>
+<file path=ppt/slideLayouts/slideLayout7.xml><?xml version="1.0" encoding="utf-8"?>
 <p:sldLayout xmlns:a="http://schemas.openxmlformats.org/drawingml/2006/main" xmlns:r="http://schemas.openxmlformats.org/officeDocument/2006/relationships" xmlns:p="http://schemas.openxmlformats.org/presentationml/2006/main" preserve="1" userDrawn="1">
   <p:cSld name="Title and Two Column Content">
     <p:spTree>
@@ -4863,7 +5770,7 @@
 </p:sldLayout>
 </file>
 
-<file path=ppt/slideLayouts/slideLayout7.xml><?xml version="1.0" encoding="utf-8"?>
+<file path=ppt/slideLayouts/slideLayout8.xml><?xml version="1.0" encoding="utf-8"?>
 <p:sldLayout xmlns:a="http://schemas.openxmlformats.org/drawingml/2006/main" xmlns:r="http://schemas.openxmlformats.org/officeDocument/2006/relationships" xmlns:p="http://schemas.openxmlformats.org/presentationml/2006/main" preserve="1" userDrawn="1">
   <p:cSld name="Slide with 6 icons and short text as a list of items">
     <p:spTree>
@@ -5542,9 +6449,9 @@
 </p:sldLayout>
 </file>
 
-<file path=ppt/slideLayouts/slideLayout8.xml><?xml version="1.0" encoding="utf-8"?>
+<file path=ppt/slideLayouts/slideLayout9.xml><?xml version="1.0" encoding="utf-8"?>
 <p:sldLayout xmlns:a="http://schemas.openxmlformats.org/drawingml/2006/main" xmlns:r="http://schemas.openxmlformats.org/officeDocument/2006/relationships" xmlns:p="http://schemas.openxmlformats.org/presentationml/2006/main" preserve="1" userDrawn="1">
-  <p:cSld name="Conclusion Slide">
+  <p:cSld name="1_Slide with 4 icons and short text as a list of items">
     <p:spTree>
       <p:nvGrpSpPr>
         <p:cNvPr id="1" name=""/>
@@ -5610,17 +6517,17 @@
           <a:p>
             <a:r>
               <a:rPr lang="en-US" dirty="0"/>
-              <a:t>Short and clear conclusion Title</a:t>
+              <a:t>Title of the slide, short and concise</a:t>
             </a:r>
           </a:p>
         </p:txBody>
       </p:sp>
       <p:sp>
         <p:nvSpPr>
-          <p:cNvPr id="3" name="Conclusion text">
-            <a:extLst>
-              <a:ext uri="{FF2B5EF4-FFF2-40B4-BE49-F238E27FC236}">
-                <a16:creationId xmlns:a16="http://schemas.microsoft.com/office/drawing/2014/main" id="{8A6FC6F2-80B4-49A7-9448-33FE2DF0E967}"/>
+          <p:cNvPr id="7" name="Icon 1">
+            <a:extLst>
+              <a:ext uri="{FF2B5EF4-FFF2-40B4-BE49-F238E27FC236}">
+                <a16:creationId xmlns:a16="http://schemas.microsoft.com/office/drawing/2014/main" id="{B52E7DE5-AE9F-8300-785A-713154A75462}"/>
               </a:ext>
             </a:extLst>
           </p:cNvPr>
@@ -5628,190 +6535,376 @@
             <a:spLocks noGrp="1"/>
           </p:cNvSpPr>
           <p:nvPr>
-            <p:ph idx="1" hasCustomPrompt="1"/>
+            <p:ph type="pic" sz="quarter" idx="10" hasCustomPrompt="1"/>
           </p:nvPr>
         </p:nvSpPr>
         <p:spPr>
           <a:xfrm>
-            <a:off x="381000" y="1825625"/>
-            <a:ext cx="11430000" cy="4351338"/>
-          </a:xfrm>
-          <a:prstGeom prst="rect">
-            <a:avLst/>
-          </a:prstGeom>
+            <a:off x="460022" y="2937664"/>
+            <a:ext cx="830263" cy="746125"/>
+          </a:xfrm>
+          <a:prstGeom prst="rect">
+            <a:avLst/>
+          </a:prstGeom>
+          <a:noFill/>
+          <a:effectLst>
+            <a:outerShdw blurRad="50800" dist="38100" dir="2700000" algn="tl" rotWithShape="0">
+              <a:prstClr val="black">
+                <a:alpha val="40000"/>
+              </a:prstClr>
+            </a:outerShdw>
+          </a:effectLst>
         </p:spPr>
         <p:txBody>
-          <a:bodyPr vert="horz" lIns="91440" tIns="45720" rIns="91440" bIns="45720" rtlCol="0">
-            <a:noAutofit/>
-          </a:bodyPr>
+          <a:bodyPr/>
           <a:lstStyle>
-            <a:lvl1pPr marL="0" indent="0" algn="l" defTabSz="914400" rtl="0" eaLnBrk="1" latinLnBrk="0" hangingPunct="1">
+            <a:lvl1pPr marL="0" indent="0" algn="ctr">
+              <a:buNone/>
+              <a:defRPr sz="2000"/>
+            </a:lvl1pPr>
+          </a:lstStyle>
+          <a:p>
+            <a:r>
+              <a:rPr lang="en-US" dirty="0"/>
+              <a:t>Icon1</a:t>
+            </a:r>
+          </a:p>
+        </p:txBody>
+      </p:sp>
+      <p:sp>
+        <p:nvSpPr>
+          <p:cNvPr id="9" name="Text Beside Icon 1">
+            <a:extLst>
+              <a:ext uri="{FF2B5EF4-FFF2-40B4-BE49-F238E27FC236}">
+                <a16:creationId xmlns:a16="http://schemas.microsoft.com/office/drawing/2014/main" id="{07863F40-906D-B17E-DD34-0C4676049440}"/>
+              </a:ext>
+            </a:extLst>
+          </p:cNvPr>
+          <p:cNvSpPr>
+            <a:spLocks noGrp="1"/>
+          </p:cNvSpPr>
+          <p:nvPr>
+            <p:ph type="body" sz="quarter" idx="11" hasCustomPrompt="1"/>
+          </p:nvPr>
+        </p:nvSpPr>
+        <p:spPr>
+          <a:xfrm>
+            <a:off x="1387122" y="2930563"/>
+            <a:ext cx="4249738" cy="769937"/>
+          </a:xfrm>
+          <a:prstGeom prst="rect">
+            <a:avLst/>
+          </a:prstGeom>
+        </p:spPr>
+        <p:txBody>
+          <a:bodyPr anchor="ctr"/>
+          <a:lstStyle>
+            <a:lvl1pPr marL="0" indent="0">
+              <a:buNone/>
+              <a:defRPr/>
+            </a:lvl1pPr>
+          </a:lstStyle>
+          <a:p>
+            <a:pPr lvl="0"/>
+            <a:r>
+              <a:rPr lang="en-US" dirty="0"/>
+              <a:t>Text beside icon 1 maximum 8 words</a:t>
+            </a:r>
+          </a:p>
+        </p:txBody>
+      </p:sp>
+      <p:sp>
+        <p:nvSpPr>
+          <p:cNvPr id="10" name="Icon 2">
+            <a:extLst>
+              <a:ext uri="{FF2B5EF4-FFF2-40B4-BE49-F238E27FC236}">
+                <a16:creationId xmlns:a16="http://schemas.microsoft.com/office/drawing/2014/main" id="{043770B4-6CFD-292F-F28C-20F74E151142}"/>
+              </a:ext>
+            </a:extLst>
+          </p:cNvPr>
+          <p:cNvSpPr>
+            <a:spLocks noGrp="1"/>
+          </p:cNvSpPr>
+          <p:nvPr>
+            <p:ph type="pic" sz="quarter" idx="12" hasCustomPrompt="1"/>
+          </p:nvPr>
+        </p:nvSpPr>
+        <p:spPr>
+          <a:xfrm>
+            <a:off x="6713184" y="2920953"/>
+            <a:ext cx="830263" cy="746125"/>
+          </a:xfrm>
+          <a:prstGeom prst="rect">
+            <a:avLst/>
+          </a:prstGeom>
+          <a:effectLst>
+            <a:outerShdw blurRad="50800" dist="38100" dir="2700000" algn="tl" rotWithShape="0">
+              <a:prstClr val="black">
+                <a:alpha val="40000"/>
+              </a:prstClr>
+            </a:outerShdw>
+          </a:effectLst>
+        </p:spPr>
+        <p:txBody>
+          <a:bodyPr/>
+          <a:lstStyle>
+            <a:lvl1pPr marL="0" indent="0">
+              <a:buNone/>
+              <a:defRPr sz="2000"/>
+            </a:lvl1pPr>
+          </a:lstStyle>
+          <a:p>
+            <a:r>
+              <a:rPr lang="en-US" dirty="0"/>
+              <a:t>Icon 2</a:t>
+            </a:r>
+          </a:p>
+        </p:txBody>
+      </p:sp>
+      <p:sp>
+        <p:nvSpPr>
+          <p:cNvPr id="11" name="Text Beside Icon 2">
+            <a:extLst>
+              <a:ext uri="{FF2B5EF4-FFF2-40B4-BE49-F238E27FC236}">
+                <a16:creationId xmlns:a16="http://schemas.microsoft.com/office/drawing/2014/main" id="{F718040C-7B8A-9487-484F-776F0815B5C6}"/>
+              </a:ext>
+            </a:extLst>
+          </p:cNvPr>
+          <p:cNvSpPr>
+            <a:spLocks noGrp="1"/>
+          </p:cNvSpPr>
+          <p:nvPr>
+            <p:ph type="body" sz="quarter" idx="13" hasCustomPrompt="1"/>
+          </p:nvPr>
+        </p:nvSpPr>
+        <p:spPr>
+          <a:xfrm>
+            <a:off x="7640284" y="2913852"/>
+            <a:ext cx="4249738" cy="769937"/>
+          </a:xfrm>
+          <a:prstGeom prst="rect">
+            <a:avLst/>
+          </a:prstGeom>
+        </p:spPr>
+        <p:txBody>
+          <a:bodyPr anchor="ctr"/>
+          <a:lstStyle>
+            <a:lvl1pPr marL="0" indent="0">
+              <a:buNone/>
+              <a:defRPr/>
+            </a:lvl1pPr>
+          </a:lstStyle>
+          <a:p>
+            <a:pPr lvl="0"/>
+            <a:r>
+              <a:rPr lang="en-US" dirty="0"/>
+              <a:t>Text beside icon 2 maximum 8 words</a:t>
+            </a:r>
+          </a:p>
+        </p:txBody>
+      </p:sp>
+      <p:sp>
+        <p:nvSpPr>
+          <p:cNvPr id="12" name="Icon 3">
+            <a:extLst>
+              <a:ext uri="{FF2B5EF4-FFF2-40B4-BE49-F238E27FC236}">
+                <a16:creationId xmlns:a16="http://schemas.microsoft.com/office/drawing/2014/main" id="{C9C69509-EA90-629E-7594-6FF7D385A0E7}"/>
+              </a:ext>
+            </a:extLst>
+          </p:cNvPr>
+          <p:cNvSpPr>
+            <a:spLocks noGrp="1"/>
+          </p:cNvSpPr>
+          <p:nvPr>
+            <p:ph type="pic" sz="quarter" idx="14" hasCustomPrompt="1"/>
+          </p:nvPr>
+        </p:nvSpPr>
+        <p:spPr>
+          <a:xfrm>
+            <a:off x="460022" y="3988422"/>
+            <a:ext cx="830263" cy="746125"/>
+          </a:xfrm>
+          <a:prstGeom prst="rect">
+            <a:avLst/>
+          </a:prstGeom>
+          <a:effectLst>
+            <a:outerShdw blurRad="50800" dist="38100" dir="2700000" algn="tl" rotWithShape="0">
+              <a:prstClr val="black">
+                <a:alpha val="40000"/>
+              </a:prstClr>
+            </a:outerShdw>
+          </a:effectLst>
+        </p:spPr>
+        <p:txBody>
+          <a:bodyPr/>
+          <a:lstStyle>
+            <a:lvl1pPr marL="0" marR="0" indent="0" algn="l" defTabSz="914400" rtl="0" eaLnBrk="1" fontAlgn="auto" latinLnBrk="0" hangingPunct="1">
               <a:lnSpc>
                 <a:spcPct val="90000"/>
               </a:lnSpc>
               <a:spcBef>
                 <a:spcPts val="1000"/>
               </a:spcBef>
+              <a:spcAft>
+                <a:spcPts val="0"/>
+              </a:spcAft>
+              <a:buClrTx/>
+              <a:buSzTx/>
               <a:buFont typeface="Arial" panose="020B0604020202020204" pitchFamily="34" charset="0"/>
               <a:buNone/>
-              <a:defRPr sz="2000" b="0" kern="1200">
-                <a:solidFill>
-                  <a:schemeClr val="tx1"/>
-                </a:solidFill>
-                <a:latin typeface="+mn-lt"/>
-                <a:ea typeface="+mn-ea"/>
-                <a:cs typeface="+mn-cs"/>
-              </a:defRPr>
+              <a:tabLst/>
+              <a:defRPr sz="2000"/>
             </a:lvl1pPr>
-            <a:lvl2pPr marL="685800" indent="-228600" algn="l" defTabSz="914400" rtl="0" eaLnBrk="1" latinLnBrk="0" hangingPunct="1">
+          </a:lstStyle>
+          <a:p>
+            <a:r>
+              <a:rPr lang="en-US" dirty="0"/>
+              <a:t>Icon 3</a:t>
+            </a:r>
+          </a:p>
+        </p:txBody>
+      </p:sp>
+      <p:sp>
+        <p:nvSpPr>
+          <p:cNvPr id="13" name="Text Beside Icon 3">
+            <a:extLst>
+              <a:ext uri="{FF2B5EF4-FFF2-40B4-BE49-F238E27FC236}">
+                <a16:creationId xmlns:a16="http://schemas.microsoft.com/office/drawing/2014/main" id="{72AA8F7B-26F0-198C-F59E-D4EAAA390678}"/>
+              </a:ext>
+            </a:extLst>
+          </p:cNvPr>
+          <p:cNvSpPr>
+            <a:spLocks noGrp="1"/>
+          </p:cNvSpPr>
+          <p:nvPr>
+            <p:ph type="body" sz="quarter" idx="15" hasCustomPrompt="1"/>
+          </p:nvPr>
+        </p:nvSpPr>
+        <p:spPr>
+          <a:xfrm>
+            <a:off x="1387122" y="3981321"/>
+            <a:ext cx="4249738" cy="769937"/>
+          </a:xfrm>
+          <a:prstGeom prst="rect">
+            <a:avLst/>
+          </a:prstGeom>
+        </p:spPr>
+        <p:txBody>
+          <a:bodyPr anchor="ctr"/>
+          <a:lstStyle>
+            <a:lvl1pPr marL="0" indent="0">
+              <a:buNone/>
+              <a:defRPr/>
+            </a:lvl1pPr>
+          </a:lstStyle>
+          <a:p>
+            <a:pPr lvl="0"/>
+            <a:r>
+              <a:rPr lang="en-US" dirty="0"/>
+              <a:t>Text beside icon 3 maximum 8 words</a:t>
+            </a:r>
+          </a:p>
+        </p:txBody>
+      </p:sp>
+      <p:sp>
+        <p:nvSpPr>
+          <p:cNvPr id="3" name="Icon 4">
+            <a:extLst>
+              <a:ext uri="{FF2B5EF4-FFF2-40B4-BE49-F238E27FC236}">
+                <a16:creationId xmlns:a16="http://schemas.microsoft.com/office/drawing/2014/main" id="{B62AA6DB-552A-718F-DB54-C39FC857289E}"/>
+              </a:ext>
+            </a:extLst>
+          </p:cNvPr>
+          <p:cNvSpPr>
+            <a:spLocks noGrp="1"/>
+          </p:cNvSpPr>
+          <p:nvPr>
+            <p:ph type="pic" sz="quarter" idx="16" hasCustomPrompt="1"/>
+          </p:nvPr>
+        </p:nvSpPr>
+        <p:spPr>
+          <a:xfrm>
+            <a:off x="6713184" y="3971711"/>
+            <a:ext cx="830263" cy="746125"/>
+          </a:xfrm>
+          <a:prstGeom prst="rect">
+            <a:avLst/>
+          </a:prstGeom>
+          <a:effectLst>
+            <a:outerShdw blurRad="50800" dist="38100" dir="2700000" algn="tl" rotWithShape="0">
+              <a:prstClr val="black">
+                <a:alpha val="40000"/>
+              </a:prstClr>
+            </a:outerShdw>
+          </a:effectLst>
+        </p:spPr>
+        <p:txBody>
+          <a:bodyPr/>
+          <a:lstStyle>
+            <a:lvl1pPr marL="0" marR="0" indent="0" algn="l" defTabSz="914400" rtl="0" eaLnBrk="1" fontAlgn="auto" latinLnBrk="0" hangingPunct="1">
               <a:lnSpc>
                 <a:spcPct val="90000"/>
               </a:lnSpc>
               <a:spcBef>
-                <a:spcPts val="500"/>
+                <a:spcPts val="1000"/>
               </a:spcBef>
+              <a:spcAft>
+                <a:spcPts val="0"/>
+              </a:spcAft>
+              <a:buClrTx/>
+              <a:buSzTx/>
               <a:buFont typeface="Arial" panose="020B0604020202020204" pitchFamily="34" charset="0"/>
-              <a:buChar char="•"/>
-              <a:defRPr sz="2400" b="0" kern="1200">
-                <a:solidFill>
-                  <a:schemeClr val="tx1"/>
-                </a:solidFill>
-                <a:latin typeface="+mn-lt"/>
-                <a:ea typeface="+mn-ea"/>
-                <a:cs typeface="+mn-cs"/>
-              </a:defRPr>
-            </a:lvl2pPr>
-            <a:lvl3pPr marL="1143000" indent="-228600" algn="l" defTabSz="914400" rtl="0" eaLnBrk="1" latinLnBrk="0" hangingPunct="1">
-              <a:lnSpc>
-                <a:spcPct val="90000"/>
-              </a:lnSpc>
-              <a:spcBef>
-                <a:spcPts val="500"/>
-              </a:spcBef>
-              <a:buFont typeface="Arial" panose="020B0604020202020204" pitchFamily="34" charset="0"/>
-              <a:buChar char="•"/>
-              <a:defRPr sz="2000" b="0" kern="1200">
-                <a:solidFill>
-                  <a:schemeClr val="tx1"/>
-                </a:solidFill>
-                <a:latin typeface="+mn-lt"/>
-                <a:ea typeface="+mn-ea"/>
-                <a:cs typeface="+mn-cs"/>
-              </a:defRPr>
-            </a:lvl3pPr>
-            <a:lvl4pPr marL="1600200" indent="-228600" algn="l" defTabSz="914400" rtl="0" eaLnBrk="1" latinLnBrk="0" hangingPunct="1">
-              <a:lnSpc>
-                <a:spcPct val="90000"/>
-              </a:lnSpc>
-              <a:spcBef>
-                <a:spcPts val="500"/>
-              </a:spcBef>
-              <a:buFont typeface="Arial" panose="020B0604020202020204" pitchFamily="34" charset="0"/>
-              <a:buChar char="•"/>
-              <a:defRPr sz="1800" b="0" kern="1200">
-                <a:solidFill>
-                  <a:schemeClr val="tx1"/>
-                </a:solidFill>
-                <a:latin typeface="+mn-lt"/>
-                <a:ea typeface="+mn-ea"/>
-                <a:cs typeface="+mn-cs"/>
-              </a:defRPr>
-            </a:lvl4pPr>
-            <a:lvl5pPr marL="2057400" indent="-228600" algn="l" defTabSz="914400" rtl="0" eaLnBrk="1" latinLnBrk="0" hangingPunct="1">
-              <a:lnSpc>
-                <a:spcPct val="90000"/>
-              </a:lnSpc>
-              <a:spcBef>
-                <a:spcPts val="500"/>
-              </a:spcBef>
-              <a:buFont typeface="Arial" panose="020B0604020202020204" pitchFamily="34" charset="0"/>
-              <a:buChar char="•"/>
-              <a:defRPr sz="1800" b="0" kern="1200">
-                <a:solidFill>
-                  <a:schemeClr val="tx1"/>
-                </a:solidFill>
-                <a:latin typeface="+mn-lt"/>
-                <a:ea typeface="+mn-ea"/>
-                <a:cs typeface="+mn-cs"/>
-              </a:defRPr>
-            </a:lvl5pPr>
-            <a:lvl6pPr marL="2514600" indent="-228600" algn="l" defTabSz="914400" rtl="0" eaLnBrk="1" latinLnBrk="0" hangingPunct="1">
-              <a:lnSpc>
-                <a:spcPct val="90000"/>
-              </a:lnSpc>
-              <a:spcBef>
-                <a:spcPts val="500"/>
-              </a:spcBef>
-              <a:buFont typeface="Arial" panose="020B0604020202020204" pitchFamily="34" charset="0"/>
-              <a:buChar char="•"/>
-              <a:defRPr sz="1800" kern="1200">
-                <a:solidFill>
-                  <a:schemeClr val="tx1"/>
-                </a:solidFill>
-                <a:latin typeface="+mn-lt"/>
-                <a:ea typeface="+mn-ea"/>
-                <a:cs typeface="+mn-cs"/>
-              </a:defRPr>
-            </a:lvl6pPr>
-            <a:lvl7pPr marL="2971800" indent="-228600" algn="l" defTabSz="914400" rtl="0" eaLnBrk="1" latinLnBrk="0" hangingPunct="1">
-              <a:lnSpc>
-                <a:spcPct val="90000"/>
-              </a:lnSpc>
-              <a:spcBef>
-                <a:spcPts val="500"/>
-              </a:spcBef>
-              <a:buFont typeface="Arial" panose="020B0604020202020204" pitchFamily="34" charset="0"/>
-              <a:buChar char="•"/>
-              <a:defRPr sz="1800" kern="1200">
-                <a:solidFill>
-                  <a:schemeClr val="tx1"/>
-                </a:solidFill>
-                <a:latin typeface="+mn-lt"/>
-                <a:ea typeface="+mn-ea"/>
-                <a:cs typeface="+mn-cs"/>
-              </a:defRPr>
-            </a:lvl7pPr>
-            <a:lvl8pPr marL="3429000" indent="-228600" algn="l" defTabSz="914400" rtl="0" eaLnBrk="1" latinLnBrk="0" hangingPunct="1">
-              <a:lnSpc>
-                <a:spcPct val="90000"/>
-              </a:lnSpc>
-              <a:spcBef>
-                <a:spcPts val="500"/>
-              </a:spcBef>
-              <a:buFont typeface="Arial" panose="020B0604020202020204" pitchFamily="34" charset="0"/>
-              <a:buChar char="•"/>
-              <a:defRPr sz="1800" kern="1200">
-                <a:solidFill>
-                  <a:schemeClr val="tx1"/>
-                </a:solidFill>
-                <a:latin typeface="+mn-lt"/>
-                <a:ea typeface="+mn-ea"/>
-                <a:cs typeface="+mn-cs"/>
-              </a:defRPr>
-            </a:lvl8pPr>
-            <a:lvl9pPr marL="3886200" indent="-228600" algn="l" defTabSz="914400" rtl="0" eaLnBrk="1" latinLnBrk="0" hangingPunct="1">
-              <a:lnSpc>
-                <a:spcPct val="90000"/>
-              </a:lnSpc>
-              <a:spcBef>
-                <a:spcPts val="500"/>
-              </a:spcBef>
-              <a:buFont typeface="Arial" panose="020B0604020202020204" pitchFamily="34" charset="0"/>
-              <a:buChar char="•"/>
-              <a:defRPr sz="1800" kern="1200">
-                <a:solidFill>
-                  <a:schemeClr val="tx1"/>
-                </a:solidFill>
-                <a:latin typeface="+mn-lt"/>
-                <a:ea typeface="+mn-ea"/>
-                <a:cs typeface="+mn-cs"/>
-              </a:defRPr>
-            </a:lvl9pPr>
+              <a:buNone/>
+              <a:tabLst/>
+              <a:defRPr sz="2000"/>
+            </a:lvl1pPr>
           </a:lstStyle>
           <a:p>
             <a:r>
               <a:rPr lang="en-US" dirty="0"/>
-              <a:t>A bulleted list of items and a short conclusion text</a:t>
+              <a:t>Icon 4</a:t>
+            </a:r>
+          </a:p>
+        </p:txBody>
+      </p:sp>
+      <p:sp>
+        <p:nvSpPr>
+          <p:cNvPr id="4" name="Text Beside Icon 4">
+            <a:extLst>
+              <a:ext uri="{FF2B5EF4-FFF2-40B4-BE49-F238E27FC236}">
+                <a16:creationId xmlns:a16="http://schemas.microsoft.com/office/drawing/2014/main" id="{127F3D65-4217-C7DF-99AC-5D0069212872}"/>
+              </a:ext>
+            </a:extLst>
+          </p:cNvPr>
+          <p:cNvSpPr>
+            <a:spLocks noGrp="1"/>
+          </p:cNvSpPr>
+          <p:nvPr>
+            <p:ph type="body" sz="quarter" idx="17" hasCustomPrompt="1"/>
+          </p:nvPr>
+        </p:nvSpPr>
+        <p:spPr>
+          <a:xfrm>
+            <a:off x="7640284" y="3964610"/>
+            <a:ext cx="4249738" cy="769937"/>
+          </a:xfrm>
+          <a:prstGeom prst="rect">
+            <a:avLst/>
+          </a:prstGeom>
+        </p:spPr>
+        <p:txBody>
+          <a:bodyPr anchor="ctr"/>
+          <a:lstStyle>
+            <a:lvl1pPr marL="0" indent="0">
+              <a:buNone/>
+              <a:defRPr/>
+            </a:lvl1pPr>
+          </a:lstStyle>
+          <a:p>
+            <a:pPr lvl="0"/>
+            <a:r>
+              <a:rPr lang="en-US" dirty="0"/>
+              <a:t>Text beside icon 4 maximum 8 words</a:t>
             </a:r>
           </a:p>
         </p:txBody>
@@ -5819,294 +6912,7 @@
     </p:spTree>
     <p:extLst>
       <p:ext uri="{BB962C8B-B14F-4D97-AF65-F5344CB8AC3E}">
-        <p14:creationId xmlns:p14="http://schemas.microsoft.com/office/powerpoint/2010/main" val="374089928"/>
-      </p:ext>
-    </p:extLst>
-  </p:cSld>
-  <p:clrMapOvr>
-    <a:masterClrMapping/>
-  </p:clrMapOvr>
-</p:sldLayout>
-</file>
-
-<file path=ppt/slideLayouts/slideLayout9.xml><?xml version="1.0" encoding="utf-8"?>
-<p:sldLayout xmlns:a="http://schemas.openxmlformats.org/drawingml/2006/main" xmlns:r="http://schemas.openxmlformats.org/officeDocument/2006/relationships" xmlns:p="http://schemas.openxmlformats.org/presentationml/2006/main" preserve="1" userDrawn="1">
-  <p:cSld name="1_Conclusion Slide">
-    <p:spTree>
-      <p:nvGrpSpPr>
-        <p:cNvPr id="1" name=""/>
-        <p:cNvGrpSpPr/>
-        <p:nvPr/>
-      </p:nvGrpSpPr>
-      <p:grpSpPr>
-        <a:xfrm>
-          <a:off x="0" y="0"/>
-          <a:ext cx="0" cy="0"/>
-          <a:chOff x="0" y="0"/>
-          <a:chExt cx="0" cy="0"/>
-        </a:xfrm>
-      </p:grpSpPr>
-      <p:sp>
-        <p:nvSpPr>
-          <p:cNvPr id="2" name="Conclusion Title">
-            <a:extLst>
-              <a:ext uri="{FF2B5EF4-FFF2-40B4-BE49-F238E27FC236}">
-                <a16:creationId xmlns:a16="http://schemas.microsoft.com/office/drawing/2014/main" id="{3CD97974-B93C-4C96-B3F6-F69E3D6DE6CA}"/>
-              </a:ext>
-            </a:extLst>
-          </p:cNvPr>
-          <p:cNvSpPr>
-            <a:spLocks noGrp="1"/>
-          </p:cNvSpPr>
-          <p:nvPr>
-            <p:ph type="title" hasCustomPrompt="1"/>
-          </p:nvPr>
-        </p:nvSpPr>
-        <p:spPr>
-          <a:xfrm>
-            <a:off x="381000" y="381000"/>
-            <a:ext cx="11430000" cy="1325563"/>
-          </a:xfrm>
-          <a:prstGeom prst="rect">
-            <a:avLst/>
-          </a:prstGeom>
-        </p:spPr>
-        <p:txBody>
-          <a:bodyPr vert="horz" lIns="91440" tIns="45720" rIns="91440" bIns="45720" rtlCol="0" anchor="ctr">
-            <a:noAutofit/>
-          </a:bodyPr>
-          <a:lstStyle>
-            <a:lvl1pPr algn="l" defTabSz="914400" rtl="0" eaLnBrk="1" latinLnBrk="0" hangingPunct="1">
-              <a:lnSpc>
-                <a:spcPct val="80000"/>
-              </a:lnSpc>
-              <a:spcBef>
-                <a:spcPct val="0"/>
-              </a:spcBef>
-              <a:buNone/>
-              <a:defRPr sz="4400" b="1" kern="1200">
-                <a:solidFill>
-                  <a:schemeClr val="tx1"/>
-                </a:solidFill>
-                <a:latin typeface="+mn-lt"/>
-                <a:ea typeface="+mj-ea"/>
-                <a:cs typeface="+mj-cs"/>
-              </a:defRPr>
-            </a:lvl1pPr>
-          </a:lstStyle>
-          <a:p>
-            <a:r>
-              <a:rPr lang="en-US" dirty="0"/>
-              <a:t>Short and clear conclusion Title</a:t>
-            </a:r>
-          </a:p>
-        </p:txBody>
-      </p:sp>
-      <p:sp>
-        <p:nvSpPr>
-          <p:cNvPr id="3" name="Conclusion text">
-            <a:extLst>
-              <a:ext uri="{FF2B5EF4-FFF2-40B4-BE49-F238E27FC236}">
-                <a16:creationId xmlns:a16="http://schemas.microsoft.com/office/drawing/2014/main" id="{8A6FC6F2-80B4-49A7-9448-33FE2DF0E967}"/>
-              </a:ext>
-            </a:extLst>
-          </p:cNvPr>
-          <p:cNvSpPr>
-            <a:spLocks noGrp="1"/>
-          </p:cNvSpPr>
-          <p:nvPr>
-            <p:ph idx="1" hasCustomPrompt="1"/>
-          </p:nvPr>
-        </p:nvSpPr>
-        <p:spPr>
-          <a:xfrm>
-            <a:off x="381000" y="1825625"/>
-            <a:ext cx="11430000" cy="4351338"/>
-          </a:xfrm>
-          <a:prstGeom prst="rect">
-            <a:avLst/>
-          </a:prstGeom>
-        </p:spPr>
-        <p:txBody>
-          <a:bodyPr vert="horz" lIns="91440" tIns="45720" rIns="91440" bIns="45720" rtlCol="0">
-            <a:noAutofit/>
-          </a:bodyPr>
-          <a:lstStyle>
-            <a:lvl1pPr marL="0" indent="0" algn="l" defTabSz="914400" rtl="0" eaLnBrk="1" latinLnBrk="0" hangingPunct="1">
-              <a:lnSpc>
-                <a:spcPct val="90000"/>
-              </a:lnSpc>
-              <a:spcBef>
-                <a:spcPts val="1000"/>
-              </a:spcBef>
-              <a:buFont typeface="Arial" panose="020B0604020202020204" pitchFamily="34" charset="0"/>
-              <a:buNone/>
-              <a:defRPr sz="2000" b="0" kern="1200">
-                <a:solidFill>
-                  <a:schemeClr val="tx1"/>
-                </a:solidFill>
-                <a:latin typeface="+mn-lt"/>
-                <a:ea typeface="+mn-ea"/>
-                <a:cs typeface="+mn-cs"/>
-              </a:defRPr>
-            </a:lvl1pPr>
-            <a:lvl2pPr marL="685800" indent="-228600" algn="l" defTabSz="914400" rtl="0" eaLnBrk="1" latinLnBrk="0" hangingPunct="1">
-              <a:lnSpc>
-                <a:spcPct val="90000"/>
-              </a:lnSpc>
-              <a:spcBef>
-                <a:spcPts val="500"/>
-              </a:spcBef>
-              <a:buFont typeface="Arial" panose="020B0604020202020204" pitchFamily="34" charset="0"/>
-              <a:buChar char="•"/>
-              <a:defRPr sz="2400" b="0" kern="1200">
-                <a:solidFill>
-                  <a:schemeClr val="tx1"/>
-                </a:solidFill>
-                <a:latin typeface="+mn-lt"/>
-                <a:ea typeface="+mn-ea"/>
-                <a:cs typeface="+mn-cs"/>
-              </a:defRPr>
-            </a:lvl2pPr>
-            <a:lvl3pPr marL="1143000" indent="-228600" algn="l" defTabSz="914400" rtl="0" eaLnBrk="1" latinLnBrk="0" hangingPunct="1">
-              <a:lnSpc>
-                <a:spcPct val="90000"/>
-              </a:lnSpc>
-              <a:spcBef>
-                <a:spcPts val="500"/>
-              </a:spcBef>
-              <a:buFont typeface="Arial" panose="020B0604020202020204" pitchFamily="34" charset="0"/>
-              <a:buChar char="•"/>
-              <a:defRPr sz="2000" b="0" kern="1200">
-                <a:solidFill>
-                  <a:schemeClr val="tx1"/>
-                </a:solidFill>
-                <a:latin typeface="+mn-lt"/>
-                <a:ea typeface="+mn-ea"/>
-                <a:cs typeface="+mn-cs"/>
-              </a:defRPr>
-            </a:lvl3pPr>
-            <a:lvl4pPr marL="1600200" indent="-228600" algn="l" defTabSz="914400" rtl="0" eaLnBrk="1" latinLnBrk="0" hangingPunct="1">
-              <a:lnSpc>
-                <a:spcPct val="90000"/>
-              </a:lnSpc>
-              <a:spcBef>
-                <a:spcPts val="500"/>
-              </a:spcBef>
-              <a:buFont typeface="Arial" panose="020B0604020202020204" pitchFamily="34" charset="0"/>
-              <a:buChar char="•"/>
-              <a:defRPr sz="1800" b="0" kern="1200">
-                <a:solidFill>
-                  <a:schemeClr val="tx1"/>
-                </a:solidFill>
-                <a:latin typeface="+mn-lt"/>
-                <a:ea typeface="+mn-ea"/>
-                <a:cs typeface="+mn-cs"/>
-              </a:defRPr>
-            </a:lvl4pPr>
-            <a:lvl5pPr marL="2057400" indent="-228600" algn="l" defTabSz="914400" rtl="0" eaLnBrk="1" latinLnBrk="0" hangingPunct="1">
-              <a:lnSpc>
-                <a:spcPct val="90000"/>
-              </a:lnSpc>
-              <a:spcBef>
-                <a:spcPts val="500"/>
-              </a:spcBef>
-              <a:buFont typeface="Arial" panose="020B0604020202020204" pitchFamily="34" charset="0"/>
-              <a:buChar char="•"/>
-              <a:defRPr sz="1800" b="0" kern="1200">
-                <a:solidFill>
-                  <a:schemeClr val="tx1"/>
-                </a:solidFill>
-                <a:latin typeface="+mn-lt"/>
-                <a:ea typeface="+mn-ea"/>
-                <a:cs typeface="+mn-cs"/>
-              </a:defRPr>
-            </a:lvl5pPr>
-            <a:lvl6pPr marL="2514600" indent="-228600" algn="l" defTabSz="914400" rtl="0" eaLnBrk="1" latinLnBrk="0" hangingPunct="1">
-              <a:lnSpc>
-                <a:spcPct val="90000"/>
-              </a:lnSpc>
-              <a:spcBef>
-                <a:spcPts val="500"/>
-              </a:spcBef>
-              <a:buFont typeface="Arial" panose="020B0604020202020204" pitchFamily="34" charset="0"/>
-              <a:buChar char="•"/>
-              <a:defRPr sz="1800" kern="1200">
-                <a:solidFill>
-                  <a:schemeClr val="tx1"/>
-                </a:solidFill>
-                <a:latin typeface="+mn-lt"/>
-                <a:ea typeface="+mn-ea"/>
-                <a:cs typeface="+mn-cs"/>
-              </a:defRPr>
-            </a:lvl6pPr>
-            <a:lvl7pPr marL="2971800" indent="-228600" algn="l" defTabSz="914400" rtl="0" eaLnBrk="1" latinLnBrk="0" hangingPunct="1">
-              <a:lnSpc>
-                <a:spcPct val="90000"/>
-              </a:lnSpc>
-              <a:spcBef>
-                <a:spcPts val="500"/>
-              </a:spcBef>
-              <a:buFont typeface="Arial" panose="020B0604020202020204" pitchFamily="34" charset="0"/>
-              <a:buChar char="•"/>
-              <a:defRPr sz="1800" kern="1200">
-                <a:solidFill>
-                  <a:schemeClr val="tx1"/>
-                </a:solidFill>
-                <a:latin typeface="+mn-lt"/>
-                <a:ea typeface="+mn-ea"/>
-                <a:cs typeface="+mn-cs"/>
-              </a:defRPr>
-            </a:lvl7pPr>
-            <a:lvl8pPr marL="3429000" indent="-228600" algn="l" defTabSz="914400" rtl="0" eaLnBrk="1" latinLnBrk="0" hangingPunct="1">
-              <a:lnSpc>
-                <a:spcPct val="90000"/>
-              </a:lnSpc>
-              <a:spcBef>
-                <a:spcPts val="500"/>
-              </a:spcBef>
-              <a:buFont typeface="Arial" panose="020B0604020202020204" pitchFamily="34" charset="0"/>
-              <a:buChar char="•"/>
-              <a:defRPr sz="1800" kern="1200">
-                <a:solidFill>
-                  <a:schemeClr val="tx1"/>
-                </a:solidFill>
-                <a:latin typeface="+mn-lt"/>
-                <a:ea typeface="+mn-ea"/>
-                <a:cs typeface="+mn-cs"/>
-              </a:defRPr>
-            </a:lvl8pPr>
-            <a:lvl9pPr marL="3886200" indent="-228600" algn="l" defTabSz="914400" rtl="0" eaLnBrk="1" latinLnBrk="0" hangingPunct="1">
-              <a:lnSpc>
-                <a:spcPct val="90000"/>
-              </a:lnSpc>
-              <a:spcBef>
-                <a:spcPts val="500"/>
-              </a:spcBef>
-              <a:buFont typeface="Arial" panose="020B0604020202020204" pitchFamily="34" charset="0"/>
-              <a:buChar char="•"/>
-              <a:defRPr sz="1800" kern="1200">
-                <a:solidFill>
-                  <a:schemeClr val="tx1"/>
-                </a:solidFill>
-                <a:latin typeface="+mn-lt"/>
-                <a:ea typeface="+mn-ea"/>
-                <a:cs typeface="+mn-cs"/>
-              </a:defRPr>
-            </a:lvl9pPr>
-          </a:lstStyle>
-          <a:p>
-            <a:r>
-              <a:rPr lang="en-US" dirty="0"/>
-              <a:t>A bulleted list of items and a short conclusion text</a:t>
-            </a:r>
-          </a:p>
-        </p:txBody>
-      </p:sp>
-    </p:spTree>
-    <p:extLst>
-      <p:ext uri="{BB962C8B-B14F-4D97-AF65-F5344CB8AC3E}">
-        <p14:creationId xmlns:p14="http://schemas.microsoft.com/office/powerpoint/2010/main" val="88811751"/>
+        <p14:creationId xmlns:p14="http://schemas.microsoft.com/office/powerpoint/2010/main" val="2538074859"/>
       </p:ext>
     </p:extLst>
   </p:cSld>
@@ -6259,7 +7065,7 @@
           <p:nvPr userDrawn="1"/>
         </p:nvPicPr>
         <p:blipFill>
-          <a:blip r:embed="rId13"/>
+          <a:blip r:embed="rId14"/>
           <a:stretch>
             <a:fillRect/>
           </a:stretch>
@@ -6323,14 +7129,15 @@
     <p:sldLayoutId id="2147483649" r:id="rId1"/>
     <p:sldLayoutId id="2147483671" r:id="rId2"/>
     <p:sldLayoutId id="2147483666" r:id="rId3"/>
-    <p:sldLayoutId id="2147483667" r:id="rId4"/>
-    <p:sldLayoutId id="2147483668" r:id="rId5"/>
-    <p:sldLayoutId id="2147483650" r:id="rId6"/>
-    <p:sldLayoutId id="2147483675" r:id="rId7"/>
-    <p:sldLayoutId id="2147483674" r:id="rId8"/>
-    <p:sldLayoutId id="2147483676" r:id="rId9"/>
-    <p:sldLayoutId id="2147483672" r:id="rId10"/>
-    <p:sldLayoutId id="2147483673" r:id="rId11"/>
+    <p:sldLayoutId id="2147483677" r:id="rId4"/>
+    <p:sldLayoutId id="2147483667" r:id="rId5"/>
+    <p:sldLayoutId id="2147483668" r:id="rId6"/>
+    <p:sldLayoutId id="2147483650" r:id="rId7"/>
+    <p:sldLayoutId id="2147483675" r:id="rId8"/>
+    <p:sldLayoutId id="2147483678" r:id="rId9"/>
+    <p:sldLayoutId id="2147483676" r:id="rId10"/>
+    <p:sldLayoutId id="2147483672" r:id="rId11"/>
+    <p:sldLayoutId id="2147483673" r:id="rId12"/>
   </p:sldLayoutIdLst>
   <p:hf hdr="0" ftr="0" dt="0"/>
   <p:txStyles>
@@ -7222,6 +8029,321 @@
 </a:theme>
 </file>
 
+<file path=ppt/theme/theme3.xml><?xml version="1.0" encoding="utf-8"?>
+<a:theme xmlns:a="http://schemas.openxmlformats.org/drawingml/2006/main" name="Office Theme">
+  <a:themeElements>
+    <a:clrScheme name="Office">
+      <a:dk1>
+        <a:sysClr val="windowText" lastClr="000000"/>
+      </a:dk1>
+      <a:lt1>
+        <a:sysClr val="window" lastClr="FFFFFF"/>
+      </a:lt1>
+      <a:dk2>
+        <a:srgbClr val="0E2841"/>
+      </a:dk2>
+      <a:lt2>
+        <a:srgbClr val="E8E8E8"/>
+      </a:lt2>
+      <a:accent1>
+        <a:srgbClr val="156082"/>
+      </a:accent1>
+      <a:accent2>
+        <a:srgbClr val="E97132"/>
+      </a:accent2>
+      <a:accent3>
+        <a:srgbClr val="196B24"/>
+      </a:accent3>
+      <a:accent4>
+        <a:srgbClr val="0F9ED5"/>
+      </a:accent4>
+      <a:accent5>
+        <a:srgbClr val="A02B93"/>
+      </a:accent5>
+      <a:accent6>
+        <a:srgbClr val="4EA72E"/>
+      </a:accent6>
+      <a:hlink>
+        <a:srgbClr val="467886"/>
+      </a:hlink>
+      <a:folHlink>
+        <a:srgbClr val="96607D"/>
+      </a:folHlink>
+    </a:clrScheme>
+    <a:fontScheme name="Office">
+      <a:majorFont>
+        <a:latin typeface="Aptos Display" panose="02110004020202020204"/>
+        <a:ea typeface=""/>
+        <a:cs typeface=""/>
+        <a:font script="Jpan" typeface="游ゴシック Light"/>
+        <a:font script="Hang" typeface="맑은 고딕"/>
+        <a:font script="Hans" typeface="等线 Light"/>
+        <a:font script="Hant" typeface="新細明體"/>
+        <a:font script="Arab" typeface="Times New Roman"/>
+        <a:font script="Hebr" typeface="Times New Roman"/>
+        <a:font script="Thai" typeface="Angsana New"/>
+        <a:font script="Ethi" typeface="Nyala"/>
+        <a:font script="Beng" typeface="Vrinda"/>
+        <a:font script="Gujr" typeface="Shruti"/>
+        <a:font script="Khmr" typeface="MoolBoran"/>
+        <a:font script="Knda" typeface="Tunga"/>
+        <a:font script="Guru" typeface="Raavi"/>
+        <a:font script="Cans" typeface="Euphemia"/>
+        <a:font script="Cher" typeface="Plantagenet Cherokee"/>
+        <a:font script="Yiii" typeface="Microsoft Yi Baiti"/>
+        <a:font script="Tibt" typeface="Microsoft Himalaya"/>
+        <a:font script="Thaa" typeface="MV Boli"/>
+        <a:font script="Deva" typeface="Mangal"/>
+        <a:font script="Telu" typeface="Gautami"/>
+        <a:font script="Taml" typeface="Latha"/>
+        <a:font script="Syrc" typeface="Estrangelo Edessa"/>
+        <a:font script="Orya" typeface="Kalinga"/>
+        <a:font script="Mlym" typeface="Kartika"/>
+        <a:font script="Laoo" typeface="DokChampa"/>
+        <a:font script="Sinh" typeface="Iskoola Pota"/>
+        <a:font script="Mong" typeface="Mongolian Baiti"/>
+        <a:font script="Viet" typeface="Times New Roman"/>
+        <a:font script="Uigh" typeface="Microsoft Uighur"/>
+        <a:font script="Geor" typeface="Sylfaen"/>
+        <a:font script="Armn" typeface="Arial"/>
+        <a:font script="Bugi" typeface="Leelawadee UI"/>
+        <a:font script="Bopo" typeface="Microsoft JhengHei"/>
+        <a:font script="Java" typeface="Javanese Text"/>
+        <a:font script="Lisu" typeface="Segoe UI"/>
+        <a:font script="Mymr" typeface="Myanmar Text"/>
+        <a:font script="Nkoo" typeface="Ebrima"/>
+        <a:font script="Olck" typeface="Nirmala UI"/>
+        <a:font script="Osma" typeface="Ebrima"/>
+        <a:font script="Phag" typeface="Phagspa"/>
+        <a:font script="Syrn" typeface="Estrangelo Edessa"/>
+        <a:font script="Syrj" typeface="Estrangelo Edessa"/>
+        <a:font script="Syre" typeface="Estrangelo Edessa"/>
+        <a:font script="Sora" typeface="Nirmala UI"/>
+        <a:font script="Tale" typeface="Microsoft Tai Le"/>
+        <a:font script="Talu" typeface="Microsoft New Tai Lue"/>
+        <a:font script="Tfng" typeface="Ebrima"/>
+      </a:majorFont>
+      <a:minorFont>
+        <a:latin typeface="Aptos" panose="02110004020202020204"/>
+        <a:ea typeface=""/>
+        <a:cs typeface=""/>
+        <a:font script="Jpan" typeface="游ゴシック"/>
+        <a:font script="Hang" typeface="맑은 고딕"/>
+        <a:font script="Hans" typeface="等线"/>
+        <a:font script="Hant" typeface="新細明體"/>
+        <a:font script="Arab" typeface="Arial"/>
+        <a:font script="Hebr" typeface="Arial"/>
+        <a:font script="Thai" typeface="Cordia New"/>
+        <a:font script="Ethi" typeface="Nyala"/>
+        <a:font script="Beng" typeface="Vrinda"/>
+        <a:font script="Gujr" typeface="Shruti"/>
+        <a:font script="Khmr" typeface="DaunPenh"/>
+        <a:font script="Knda" typeface="Tunga"/>
+        <a:font script="Guru" typeface="Raavi"/>
+        <a:font script="Cans" typeface="Euphemia"/>
+        <a:font script="Cher" typeface="Plantagenet Cherokee"/>
+        <a:font script="Yiii" typeface="Microsoft Yi Baiti"/>
+        <a:font script="Tibt" typeface="Microsoft Himalaya"/>
+        <a:font script="Thaa" typeface="MV Boli"/>
+        <a:font script="Deva" typeface="Mangal"/>
+        <a:font script="Telu" typeface="Gautami"/>
+        <a:font script="Taml" typeface="Latha"/>
+        <a:font script="Syrc" typeface="Estrangelo Edessa"/>
+        <a:font script="Orya" typeface="Kalinga"/>
+        <a:font script="Mlym" typeface="Kartika"/>
+        <a:font script="Laoo" typeface="DokChampa"/>
+        <a:font script="Sinh" typeface="Iskoola Pota"/>
+        <a:font script="Mong" typeface="Mongolian Baiti"/>
+        <a:font script="Viet" typeface="Arial"/>
+        <a:font script="Uigh" typeface="Microsoft Uighur"/>
+        <a:font script="Geor" typeface="Sylfaen"/>
+        <a:font script="Armn" typeface="Arial"/>
+        <a:font script="Bugi" typeface="Leelawadee UI"/>
+        <a:font script="Bopo" typeface="Microsoft JhengHei"/>
+        <a:font script="Java" typeface="Javanese Text"/>
+        <a:font script="Lisu" typeface="Segoe UI"/>
+        <a:font script="Mymr" typeface="Myanmar Text"/>
+        <a:font script="Nkoo" typeface="Ebrima"/>
+        <a:font script="Olck" typeface="Nirmala UI"/>
+        <a:font script="Osma" typeface="Ebrima"/>
+        <a:font script="Phag" typeface="Phagspa"/>
+        <a:font script="Syrn" typeface="Estrangelo Edessa"/>
+        <a:font script="Syrj" typeface="Estrangelo Edessa"/>
+        <a:font script="Syre" typeface="Estrangelo Edessa"/>
+        <a:font script="Sora" typeface="Nirmala UI"/>
+        <a:font script="Tale" typeface="Microsoft Tai Le"/>
+        <a:font script="Talu" typeface="Microsoft New Tai Lue"/>
+        <a:font script="Tfng" typeface="Ebrima"/>
+      </a:minorFont>
+    </a:fontScheme>
+    <a:fmtScheme name="Office">
+      <a:fillStyleLst>
+        <a:solidFill>
+          <a:schemeClr val="phClr"/>
+        </a:solidFill>
+        <a:gradFill rotWithShape="1">
+          <a:gsLst>
+            <a:gs pos="0">
+              <a:schemeClr val="phClr">
+                <a:lumMod val="110000"/>
+                <a:satMod val="105000"/>
+                <a:tint val="67000"/>
+              </a:schemeClr>
+            </a:gs>
+            <a:gs pos="50000">
+              <a:schemeClr val="phClr">
+                <a:lumMod val="105000"/>
+                <a:satMod val="103000"/>
+                <a:tint val="73000"/>
+              </a:schemeClr>
+            </a:gs>
+            <a:gs pos="100000">
+              <a:schemeClr val="phClr">
+                <a:lumMod val="105000"/>
+                <a:satMod val="109000"/>
+                <a:tint val="81000"/>
+              </a:schemeClr>
+            </a:gs>
+          </a:gsLst>
+          <a:lin ang="5400000" scaled="0"/>
+        </a:gradFill>
+        <a:gradFill rotWithShape="1">
+          <a:gsLst>
+            <a:gs pos="0">
+              <a:schemeClr val="phClr">
+                <a:satMod val="103000"/>
+                <a:lumMod val="102000"/>
+                <a:tint val="94000"/>
+              </a:schemeClr>
+            </a:gs>
+            <a:gs pos="50000">
+              <a:schemeClr val="phClr">
+                <a:satMod val="110000"/>
+                <a:lumMod val="100000"/>
+                <a:shade val="100000"/>
+              </a:schemeClr>
+            </a:gs>
+            <a:gs pos="100000">
+              <a:schemeClr val="phClr">
+                <a:lumMod val="99000"/>
+                <a:satMod val="120000"/>
+                <a:shade val="78000"/>
+              </a:schemeClr>
+            </a:gs>
+          </a:gsLst>
+          <a:lin ang="5400000" scaled="0"/>
+        </a:gradFill>
+      </a:fillStyleLst>
+      <a:lnStyleLst>
+        <a:ln w="12700" cap="flat" cmpd="sng" algn="ctr">
+          <a:solidFill>
+            <a:schemeClr val="phClr"/>
+          </a:solidFill>
+          <a:prstDash val="solid"/>
+          <a:miter lim="800000"/>
+        </a:ln>
+        <a:ln w="19050" cap="flat" cmpd="sng" algn="ctr">
+          <a:solidFill>
+            <a:schemeClr val="phClr"/>
+          </a:solidFill>
+          <a:prstDash val="solid"/>
+          <a:miter lim="800000"/>
+        </a:ln>
+        <a:ln w="25400" cap="flat" cmpd="sng" algn="ctr">
+          <a:solidFill>
+            <a:schemeClr val="phClr"/>
+          </a:solidFill>
+          <a:prstDash val="solid"/>
+          <a:miter lim="800000"/>
+        </a:ln>
+      </a:lnStyleLst>
+      <a:effectStyleLst>
+        <a:effectStyle>
+          <a:effectLst/>
+        </a:effectStyle>
+        <a:effectStyle>
+          <a:effectLst/>
+        </a:effectStyle>
+        <a:effectStyle>
+          <a:effectLst>
+            <a:outerShdw blurRad="57150" dist="19050" dir="5400000" algn="ctr" rotWithShape="0">
+              <a:srgbClr val="000000">
+                <a:alpha val="63000"/>
+              </a:srgbClr>
+            </a:outerShdw>
+          </a:effectLst>
+        </a:effectStyle>
+      </a:effectStyleLst>
+      <a:bgFillStyleLst>
+        <a:solidFill>
+          <a:schemeClr val="phClr"/>
+        </a:solidFill>
+        <a:solidFill>
+          <a:schemeClr val="phClr">
+            <a:tint val="95000"/>
+            <a:satMod val="170000"/>
+          </a:schemeClr>
+        </a:solidFill>
+        <a:gradFill rotWithShape="1">
+          <a:gsLst>
+            <a:gs pos="0">
+              <a:schemeClr val="phClr">
+                <a:tint val="93000"/>
+                <a:satMod val="150000"/>
+                <a:shade val="98000"/>
+                <a:lumMod val="102000"/>
+              </a:schemeClr>
+            </a:gs>
+            <a:gs pos="50000">
+              <a:schemeClr val="phClr">
+                <a:tint val="98000"/>
+                <a:satMod val="130000"/>
+                <a:shade val="90000"/>
+                <a:lumMod val="103000"/>
+              </a:schemeClr>
+            </a:gs>
+            <a:gs pos="100000">
+              <a:schemeClr val="phClr">
+                <a:shade val="63000"/>
+                <a:satMod val="120000"/>
+              </a:schemeClr>
+            </a:gs>
+          </a:gsLst>
+          <a:lin ang="5400000" scaled="0"/>
+        </a:gradFill>
+      </a:bgFillStyleLst>
+    </a:fmtScheme>
+  </a:themeElements>
+  <a:objectDefaults>
+    <a:lnDef>
+      <a:spPr/>
+      <a:bodyPr/>
+      <a:lstStyle/>
+      <a:style>
+        <a:lnRef idx="2">
+          <a:schemeClr val="accent1"/>
+        </a:lnRef>
+        <a:fillRef idx="0">
+          <a:schemeClr val="accent1"/>
+        </a:fillRef>
+        <a:effectRef idx="1">
+          <a:schemeClr val="accent1"/>
+        </a:effectRef>
+        <a:fontRef idx="minor">
+          <a:schemeClr val="tx1"/>
+        </a:fontRef>
+      </a:style>
+    </a:lnDef>
+  </a:objectDefaults>
+  <a:extraClrSchemeLst/>
+  <a:extLst>
+    <a:ext uri="{05A4C25C-085E-4340-85A3-A5531E510DB2}">
+      <thm15:themeFamily xmlns:thm15="http://schemas.microsoft.com/office/thememl/2012/main" name="Office Theme" id="{2E142A2C-CD16-42D6-873A-C26D2A0506FA}" vid="{1BDDFF52-6CD6-40A5-AB3C-68EB2F1E4D0A}"/>
+    </a:ext>
+  </a:extLst>
+</a:theme>
+</file>
+
 <file path=customXml/item1.xml><?xml version="1.0" encoding="utf-8"?>
 <p:properties xmlns:p="http://schemas.microsoft.com/office/2006/metadata/properties" xmlns:xsi="http://www.w3.org/2001/XMLSchema-instance" xmlns:pc="http://schemas.microsoft.com/office/infopath/2007/PartnerControls">
   <documentManagement>

</xml_diff>

<commit_message>
🤖 Update HTML content generation to support async parallel processing for improved performance. Enhance D3.js and Mermaid.js integration for advanced visualizations, ensuring strict adherence to Ekona branding guidelines. Revise README.md to document new visualization requirements and examples.
</commit_message>
<xml_diff>
--- a/ekona_slides_template_new.pptx
+++ b/ekona_slides_template_new.pptx
@@ -111,6 +111,9 @@
     <p:ext uri="{EFAFB233-063F-42B5-8137-9DF3F51BA10A}">
       <p15:sldGuideLst xmlns:p15="http://schemas.microsoft.com/office/powerpoint/2012/main"/>
     </p:ext>
+    <p:ext uri="{2D200454-40CA-4A62-9FC3-DE9A4176ACB9}">
+      <p15:notesGuideLst xmlns:p15="http://schemas.microsoft.com/office/powerpoint/2012/main"/>
+    </p:ext>
   </p:extLst>
 </p:presentation>
 </file>
@@ -128,7 +131,7 @@
   <pc:docChgLst>
     <pc:chgData name="Sam Khalil" userId="82cd1ec2-6208-465b-9d4d-40ce8f0cbf96" providerId="ADAL" clId="{651B6F30-EC96-2340-AD4B-07A6B9855D0C}"/>
     <pc:docChg chg="undo custSel addSld delSld modSld modMainMaster">
-      <pc:chgData name="Sam Khalil" userId="82cd1ec2-6208-465b-9d4d-40ce8f0cbf96" providerId="ADAL" clId="{651B6F30-EC96-2340-AD4B-07A6B9855D0C}" dt="2025-07-17T22:40:18.173" v="1351" actId="1076"/>
+      <pc:chgData name="Sam Khalil" userId="82cd1ec2-6208-465b-9d4d-40ce8f0cbf96" providerId="ADAL" clId="{651B6F30-EC96-2340-AD4B-07A6B9855D0C}" dt="2025-07-20T12:56:25.527" v="1353" actId="2696"/>
       <pc:docMkLst>
         <pc:docMk/>
       </pc:docMkLst>
@@ -137,6 +140,13 @@
         <pc:sldMkLst>
           <pc:docMk/>
           <pc:sldMk cId="1425710479" sldId="256"/>
+        </pc:sldMkLst>
+      </pc:sldChg>
+      <pc:sldChg chg="new del">
+        <pc:chgData name="Sam Khalil" userId="82cd1ec2-6208-465b-9d4d-40ce8f0cbf96" providerId="ADAL" clId="{651B6F30-EC96-2340-AD4B-07A6B9855D0C}" dt="2025-07-20T12:56:25.527" v="1353" actId="2696"/>
+        <pc:sldMkLst>
+          <pc:docMk/>
+          <pc:sldMk cId="1599994850" sldId="256"/>
         </pc:sldMkLst>
       </pc:sldChg>
       <pc:sldChg chg="new del">
@@ -159,22 +169,6 @@
           <pc:docMk/>
           <pc:sldMk cId="1866868894" sldId="257"/>
         </pc:sldMkLst>
-        <pc:spChg chg="del">
-          <ac:chgData name="Sam Khalil" userId="82cd1ec2-6208-465b-9d4d-40ce8f0cbf96" providerId="ADAL" clId="{651B6F30-EC96-2340-AD4B-07A6B9855D0C}" dt="2025-07-17T20:40:36.576" v="1230"/>
-          <ac:spMkLst>
-            <pc:docMk/>
-            <pc:sldMk cId="1866868894" sldId="257"/>
-            <ac:spMk id="3" creationId="{C6B887A7-ADAA-F876-68AC-B7FF7EA3EE0E}"/>
-          </ac:spMkLst>
-        </pc:spChg>
-        <pc:graphicFrameChg chg="add">
-          <ac:chgData name="Sam Khalil" userId="82cd1ec2-6208-465b-9d4d-40ce8f0cbf96" providerId="ADAL" clId="{651B6F30-EC96-2340-AD4B-07A6B9855D0C}" dt="2025-07-17T20:40:36.576" v="1230"/>
-          <ac:graphicFrameMkLst>
-            <pc:docMk/>
-            <pc:sldMk cId="1866868894" sldId="257"/>
-            <ac:graphicFrameMk id="4" creationId="{5B477F69-9AB2-1667-89A8-A0118C958FCE}"/>
-          </ac:graphicFrameMkLst>
-        </pc:graphicFrameChg>
       </pc:sldChg>
       <pc:sldChg chg="del">
         <pc:chgData name="Sam Khalil" userId="82cd1ec2-6208-465b-9d4d-40ce8f0cbf96" providerId="ADAL" clId="{651B6F30-EC96-2340-AD4B-07A6B9855D0C}" dt="2025-07-16T20:03:04.043" v="1" actId="2696"/>
@@ -236,15 +230,6 @@
               <pc:sldMasterMk cId="2940896467" sldId="2147483648"/>
               <pc:sldLayoutMk cId="3074954578" sldId="2147483650"/>
               <ac:spMk id="4" creationId="{097092C2-9408-32E2-1B17-858560948F97}"/>
-            </ac:spMkLst>
-          </pc:spChg>
-          <pc:spChg chg="add del mod">
-            <ac:chgData name="Sam Khalil" userId="82cd1ec2-6208-465b-9d4d-40ce8f0cbf96" providerId="ADAL" clId="{651B6F30-EC96-2340-AD4B-07A6B9855D0C}" dt="2025-07-17T11:14:27.957" v="971" actId="478"/>
-            <ac:spMkLst>
-              <pc:docMk/>
-              <pc:sldMasterMk cId="2940896467" sldId="2147483648"/>
-              <pc:sldLayoutMk cId="3074954578" sldId="2147483650"/>
-              <ac:spMk id="5" creationId="{59EF2013-F952-FF54-0589-E05FCBA038F9}"/>
             </ac:spMkLst>
           </pc:spChg>
         </pc:sldLayoutChg>
@@ -341,15 +326,6 @@
             <pc:sldMasterMk cId="2940896467" sldId="2147483648"/>
             <pc:sldLayoutMk cId="976521419" sldId="2147483671"/>
           </pc:sldLayoutMkLst>
-          <pc:spChg chg="add del">
-            <ac:chgData name="Sam Khalil" userId="82cd1ec2-6208-465b-9d4d-40ce8f0cbf96" providerId="ADAL" clId="{651B6F30-EC96-2340-AD4B-07A6B9855D0C}" dt="2025-07-16T20:05:30.359" v="19" actId="11529"/>
-            <ac:spMkLst>
-              <pc:docMk/>
-              <pc:sldMasterMk cId="2940896467" sldId="2147483648"/>
-              <pc:sldLayoutMk cId="976521419" sldId="2147483671"/>
-              <ac:spMk id="2" creationId="{3A6CAF80-5DD9-23A5-1ABF-4D93FF94E181}"/>
-            </ac:spMkLst>
-          </pc:spChg>
           <pc:spChg chg="add mod">
             <ac:chgData name="Sam Khalil" userId="82cd1ec2-6208-465b-9d4d-40ce8f0cbf96" providerId="ADAL" clId="{651B6F30-EC96-2340-AD4B-07A6B9855D0C}" dt="2025-07-17T09:03:56.085" v="152" actId="962"/>
             <ac:spMkLst>
@@ -359,33 +335,6 @@
               <ac:spMk id="2" creationId="{451BA699-B22C-5269-513E-35DC959DE690}"/>
             </ac:spMkLst>
           </pc:spChg>
-          <pc:spChg chg="add del">
-            <ac:chgData name="Sam Khalil" userId="82cd1ec2-6208-465b-9d4d-40ce8f0cbf96" providerId="ADAL" clId="{651B6F30-EC96-2340-AD4B-07A6B9855D0C}" dt="2025-07-16T20:09:11.764" v="29" actId="11529"/>
-            <ac:spMkLst>
-              <pc:docMk/>
-              <pc:sldMasterMk cId="2940896467" sldId="2147483648"/>
-              <pc:sldLayoutMk cId="976521419" sldId="2147483671"/>
-              <ac:spMk id="2" creationId="{75ED3873-1E7A-889E-06A1-08006230BB0F}"/>
-            </ac:spMkLst>
-          </pc:spChg>
-          <pc:spChg chg="add del mod">
-            <ac:chgData name="Sam Khalil" userId="82cd1ec2-6208-465b-9d4d-40ce8f0cbf96" providerId="ADAL" clId="{651B6F30-EC96-2340-AD4B-07A6B9855D0C}" dt="2025-07-16T20:10:32.867" v="79" actId="478"/>
-            <ac:spMkLst>
-              <pc:docMk/>
-              <pc:sldMasterMk cId="2940896467" sldId="2147483648"/>
-              <pc:sldLayoutMk cId="976521419" sldId="2147483671"/>
-              <ac:spMk id="3" creationId="{00041EF7-62D8-57AD-657E-C0D07A8C89DB}"/>
-            </ac:spMkLst>
-          </pc:spChg>
-          <pc:spChg chg="add del mod">
-            <ac:chgData name="Sam Khalil" userId="82cd1ec2-6208-465b-9d4d-40ce8f0cbf96" providerId="ADAL" clId="{651B6F30-EC96-2340-AD4B-07A6B9855D0C}" dt="2025-07-16T20:05:39.462" v="20" actId="478"/>
-            <ac:spMkLst>
-              <pc:docMk/>
-              <pc:sldMasterMk cId="2940896467" sldId="2147483648"/>
-              <pc:sldLayoutMk cId="976521419" sldId="2147483671"/>
-              <ac:spMk id="3" creationId="{3B63ED82-8A8B-D18D-4564-53A8FCFFC3CF}"/>
-            </ac:spMkLst>
-          </pc:spChg>
           <pc:spChg chg="add mod">
             <ac:chgData name="Sam Khalil" userId="82cd1ec2-6208-465b-9d4d-40ce8f0cbf96" providerId="ADAL" clId="{651B6F30-EC96-2340-AD4B-07A6B9855D0C}" dt="2025-07-17T09:51:08.809" v="311" actId="1076"/>
             <ac:spMkLst>
@@ -393,24 +342,6 @@
               <pc:sldMasterMk cId="2940896467" sldId="2147483648"/>
               <pc:sldLayoutMk cId="976521419" sldId="2147483671"/>
               <ac:spMk id="5" creationId="{CBE66CB9-C849-3A55-3368-6C1666C50D4F}"/>
-            </ac:spMkLst>
-          </pc:spChg>
-          <pc:spChg chg="add del mod">
-            <ac:chgData name="Sam Khalil" userId="82cd1ec2-6208-465b-9d4d-40ce8f0cbf96" providerId="ADAL" clId="{651B6F30-EC96-2340-AD4B-07A6B9855D0C}" dt="2025-07-16T20:10:34.115" v="80" actId="478"/>
-            <ac:spMkLst>
-              <pc:docMk/>
-              <pc:sldMasterMk cId="2940896467" sldId="2147483648"/>
-              <pc:sldLayoutMk cId="976521419" sldId="2147483671"/>
-              <ac:spMk id="6" creationId="{FB1D2D01-586E-14CE-4797-8F5742CF1EB4}"/>
-            </ac:spMkLst>
-          </pc:spChg>
-          <pc:spChg chg="add del">
-            <ac:chgData name="Sam Khalil" userId="82cd1ec2-6208-465b-9d4d-40ce8f0cbf96" providerId="ADAL" clId="{651B6F30-EC96-2340-AD4B-07A6B9855D0C}" dt="2025-07-16T20:10:10.377" v="61" actId="11529"/>
-            <ac:spMkLst>
-              <pc:docMk/>
-              <pc:sldMasterMk cId="2940896467" sldId="2147483648"/>
-              <pc:sldLayoutMk cId="976521419" sldId="2147483671"/>
-              <ac:spMk id="7" creationId="{FE056DC3-538D-F364-B193-82122E4699F9}"/>
             </ac:spMkLst>
           </pc:spChg>
           <pc:spChg chg="add mod">
@@ -429,33 +360,6 @@
               <pc:sldMasterMk cId="2940896467" sldId="2147483648"/>
               <pc:sldLayoutMk cId="976521419" sldId="2147483671"/>
               <ac:spMk id="9" creationId="{755D5765-4853-2CD1-FD28-234442F507BD}"/>
-            </ac:spMkLst>
-          </pc:spChg>
-          <pc:spChg chg="del">
-            <ac:chgData name="Sam Khalil" userId="82cd1ec2-6208-465b-9d4d-40ce8f0cbf96" providerId="ADAL" clId="{651B6F30-EC96-2340-AD4B-07A6B9855D0C}" dt="2025-07-16T20:05:47.803" v="21" actId="478"/>
-            <ac:spMkLst>
-              <pc:docMk/>
-              <pc:sldMasterMk cId="2940896467" sldId="2147483648"/>
-              <pc:sldLayoutMk cId="976521419" sldId="2147483671"/>
-              <ac:spMk id="10" creationId="{8C830669-7003-374B-4151-D47904C1A2D8}"/>
-            </ac:spMkLst>
-          </pc:spChg>
-          <pc:spChg chg="del">
-            <ac:chgData name="Sam Khalil" userId="82cd1ec2-6208-465b-9d4d-40ce8f0cbf96" providerId="ADAL" clId="{651B6F30-EC96-2340-AD4B-07A6B9855D0C}" dt="2025-07-16T20:09:05.088" v="27" actId="478"/>
-            <ac:spMkLst>
-              <pc:docMk/>
-              <pc:sldMasterMk cId="2940896467" sldId="2147483648"/>
-              <pc:sldLayoutMk cId="976521419" sldId="2147483671"/>
-              <ac:spMk id="11" creationId="{876686D6-9C7D-E581-BCF7-DD6825BD535A}"/>
-            </ac:spMkLst>
-          </pc:spChg>
-          <pc:spChg chg="del">
-            <ac:chgData name="Sam Khalil" userId="82cd1ec2-6208-465b-9d4d-40ce8f0cbf96" providerId="ADAL" clId="{651B6F30-EC96-2340-AD4B-07A6B9855D0C}" dt="2025-07-16T20:09:06.437" v="28" actId="478"/>
-            <ac:spMkLst>
-              <pc:docMk/>
-              <pc:sldMasterMk cId="2940896467" sldId="2147483648"/>
-              <pc:sldLayoutMk cId="976521419" sldId="2147483671"/>
-              <ac:spMk id="12" creationId="{B5526A54-B1E4-D97E-873D-C8FAFDC5486C}"/>
             </ac:spMkLst>
           </pc:spChg>
         </pc:sldLayoutChg>
@@ -482,24 +386,6 @@
             <pc:sldMasterMk cId="2940896467" sldId="2147483648"/>
             <pc:sldLayoutMk cId="374089928" sldId="2147483674"/>
           </pc:sldLayoutMkLst>
-          <pc:spChg chg="mod">
-            <ac:chgData name="Sam Khalil" userId="82cd1ec2-6208-465b-9d4d-40ce8f0cbf96" providerId="ADAL" clId="{651B6F30-EC96-2340-AD4B-07A6B9855D0C}" dt="2025-07-17T09:55:36.490" v="947" actId="20577"/>
-            <ac:spMkLst>
-              <pc:docMk/>
-              <pc:sldMasterMk cId="2940896467" sldId="2147483648"/>
-              <pc:sldLayoutMk cId="374089928" sldId="2147483674"/>
-              <ac:spMk id="2" creationId="{3CD97974-B93C-4C96-B3F6-F69E3D6DE6CA}"/>
-            </ac:spMkLst>
-          </pc:spChg>
-          <pc:spChg chg="mod">
-            <ac:chgData name="Sam Khalil" userId="82cd1ec2-6208-465b-9d4d-40ce8f0cbf96" providerId="ADAL" clId="{651B6F30-EC96-2340-AD4B-07A6B9855D0C}" dt="2025-07-17T09:48:07.019" v="272" actId="20577"/>
-            <ac:spMkLst>
-              <pc:docMk/>
-              <pc:sldMasterMk cId="2940896467" sldId="2147483648"/>
-              <pc:sldLayoutMk cId="374089928" sldId="2147483674"/>
-              <ac:spMk id="3" creationId="{8A6FC6F2-80B4-49A7-9448-33FE2DF0E967}"/>
-            </ac:spMkLst>
-          </pc:spChg>
         </pc:sldLayoutChg>
         <pc:sldLayoutChg chg="addSp delSp modSp mod ord">
           <pc:chgData name="Sam Khalil" userId="82cd1ec2-6208-465b-9d4d-40ce8f0cbf96" providerId="ADAL" clId="{651B6F30-EC96-2340-AD4B-07A6B9855D0C}" dt="2025-07-17T16:52:43.058" v="1222" actId="20577"/>
@@ -515,15 +401,6 @@
               <pc:sldMasterMk cId="2940896467" sldId="2147483648"/>
               <pc:sldLayoutMk cId="1049941252" sldId="2147483675"/>
               <ac:spMk id="2" creationId="{3CD97974-B93C-4C96-B3F6-F69E3D6DE6CA}"/>
-            </ac:spMkLst>
-          </pc:spChg>
-          <pc:spChg chg="del">
-            <ac:chgData name="Sam Khalil" userId="82cd1ec2-6208-465b-9d4d-40ce8f0cbf96" providerId="ADAL" clId="{651B6F30-EC96-2340-AD4B-07A6B9855D0C}" dt="2025-07-17T11:14:37.253" v="974" actId="478"/>
-            <ac:spMkLst>
-              <pc:docMk/>
-              <pc:sldMasterMk cId="2940896467" sldId="2147483648"/>
-              <pc:sldLayoutMk cId="1049941252" sldId="2147483675"/>
-              <ac:spMk id="3" creationId="{8A6FC6F2-80B4-49A7-9448-33FE2DF0E967}"/>
             </ac:spMkLst>
           </pc:spChg>
           <pc:spChg chg="add mod">
@@ -544,15 +421,6 @@
               <ac:spMk id="4" creationId="{127F3D65-4217-C7DF-99AC-5D0069212872}"/>
             </ac:spMkLst>
           </pc:spChg>
-          <pc:spChg chg="add del">
-            <ac:chgData name="Sam Khalil" userId="82cd1ec2-6208-465b-9d4d-40ce8f0cbf96" providerId="ADAL" clId="{651B6F30-EC96-2340-AD4B-07A6B9855D0C}" dt="2025-07-17T11:14:50.389" v="975" actId="11529"/>
-            <ac:spMkLst>
-              <pc:docMk/>
-              <pc:sldMasterMk cId="2940896467" sldId="2147483648"/>
-              <pc:sldLayoutMk cId="1049941252" sldId="2147483675"/>
-              <ac:spMk id="4" creationId="{C88792CE-84C7-C068-C2A0-96B0DB0924E9}"/>
-            </ac:spMkLst>
-          </pc:spChg>
           <pc:spChg chg="add mod">
             <ac:chgData name="Sam Khalil" userId="82cd1ec2-6208-465b-9d4d-40ce8f0cbf96" providerId="ADAL" clId="{651B6F30-EC96-2340-AD4B-07A6B9855D0C}" dt="2025-07-17T16:43:18.506" v="1199" actId="962"/>
             <ac:spMkLst>
@@ -560,15 +428,6 @@
               <pc:sldMasterMk cId="2940896467" sldId="2147483648"/>
               <pc:sldLayoutMk cId="1049941252" sldId="2147483675"/>
               <ac:spMk id="5" creationId="{3EC742A8-1DE0-BB3C-0CAC-88DE22F8BB50}"/>
-            </ac:spMkLst>
-          </pc:spChg>
-          <pc:spChg chg="add del mod">
-            <ac:chgData name="Sam Khalil" userId="82cd1ec2-6208-465b-9d4d-40ce8f0cbf96" providerId="ADAL" clId="{651B6F30-EC96-2340-AD4B-07A6B9855D0C}" dt="2025-07-17T11:14:59.072" v="976" actId="478"/>
-            <ac:spMkLst>
-              <pc:docMk/>
-              <pc:sldMasterMk cId="2940896467" sldId="2147483648"/>
-              <pc:sldLayoutMk cId="1049941252" sldId="2147483675"/>
-              <ac:spMk id="5" creationId="{88AD5357-20EE-EB12-D254-E11CFBC1501D}"/>
             </ac:spMkLst>
           </pc:spChg>
           <pc:spChg chg="add del mod">
@@ -580,15 +439,6 @@
               <ac:spMk id="6" creationId="{78C25294-674A-0237-57DC-CE5D5F857C77}"/>
             </ac:spMkLst>
           </pc:spChg>
-          <pc:spChg chg="add del">
-            <ac:chgData name="Sam Khalil" userId="82cd1ec2-6208-465b-9d4d-40ce8f0cbf96" providerId="ADAL" clId="{651B6F30-EC96-2340-AD4B-07A6B9855D0C}" dt="2025-07-17T11:15:12.429" v="977" actId="11529"/>
-            <ac:spMkLst>
-              <pc:docMk/>
-              <pc:sldMasterMk cId="2940896467" sldId="2147483648"/>
-              <pc:sldLayoutMk cId="1049941252" sldId="2147483675"/>
-              <ac:spMk id="6" creationId="{AE10B823-812F-E9FB-89EA-A2452C4EBD71}"/>
-            </ac:spMkLst>
-          </pc:spChg>
           <pc:spChg chg="add mod">
             <ac:chgData name="Sam Khalil" userId="82cd1ec2-6208-465b-9d4d-40ce8f0cbf96" providerId="ADAL" clId="{651B6F30-EC96-2340-AD4B-07A6B9855D0C}" dt="2025-07-17T13:45:48.242" v="1146" actId="14861"/>
             <ac:spMkLst>
@@ -596,15 +446,6 @@
               <pc:sldMasterMk cId="2940896467" sldId="2147483648"/>
               <pc:sldLayoutMk cId="1049941252" sldId="2147483675"/>
               <ac:spMk id="7" creationId="{B52E7DE5-AE9F-8300-785A-713154A75462}"/>
-            </ac:spMkLst>
-          </pc:spChg>
-          <pc:spChg chg="add del">
-            <ac:chgData name="Sam Khalil" userId="82cd1ec2-6208-465b-9d4d-40ce8f0cbf96" providerId="ADAL" clId="{651B6F30-EC96-2340-AD4B-07A6B9855D0C}" dt="2025-07-17T11:15:25.562" v="979" actId="11529"/>
-            <ac:spMkLst>
-              <pc:docMk/>
-              <pc:sldMasterMk cId="2940896467" sldId="2147483648"/>
-              <pc:sldLayoutMk cId="1049941252" sldId="2147483675"/>
-              <ac:spMk id="8" creationId="{20B25644-6E6E-5187-E903-21AFB14645FA}"/>
             </ac:spMkLst>
           </pc:spChg>
           <pc:spChg chg="add mod">
@@ -670,24 +511,6 @@
               <ac:spMk id="14" creationId="{BCEDE17A-C31D-39B6-1DD5-DFF09F743405}"/>
             </ac:spMkLst>
           </pc:spChg>
-          <pc:spChg chg="add del">
-            <ac:chgData name="Sam Khalil" userId="82cd1ec2-6208-465b-9d4d-40ce8f0cbf96" providerId="ADAL" clId="{651B6F30-EC96-2340-AD4B-07A6B9855D0C}" dt="2025-07-17T11:22:51.021" v="1093" actId="22"/>
-            <ac:spMkLst>
-              <pc:docMk/>
-              <pc:sldMasterMk cId="2940896467" sldId="2147483648"/>
-              <pc:sldLayoutMk cId="1049941252" sldId="2147483675"/>
-              <ac:spMk id="17" creationId="{2E234903-EB21-A931-C865-BDEC2E5B31D1}"/>
-            </ac:spMkLst>
-          </pc:spChg>
-          <pc:picChg chg="add del mod">
-            <ac:chgData name="Sam Khalil" userId="82cd1ec2-6208-465b-9d4d-40ce8f0cbf96" providerId="ADAL" clId="{651B6F30-EC96-2340-AD4B-07A6B9855D0C}" dt="2025-07-17T11:22:34.336" v="1091" actId="21"/>
-            <ac:picMkLst>
-              <pc:docMk/>
-              <pc:sldMasterMk cId="2940896467" sldId="2147483648"/>
-              <pc:sldLayoutMk cId="1049941252" sldId="2147483675"/>
-              <ac:picMk id="15" creationId="{E6C7B655-A6EE-6FA6-4296-36011B8BF412}"/>
-            </ac:picMkLst>
-          </pc:picChg>
         </pc:sldLayoutChg>
         <pc:sldLayoutChg chg="addSp delSp modSp add mod ord modTransition">
           <pc:chgData name="Sam Khalil" userId="82cd1ec2-6208-465b-9d4d-40ce8f0cbf96" providerId="ADAL" clId="{651B6F30-EC96-2340-AD4B-07A6B9855D0C}" dt="2025-07-17T21:10:25.014" v="1236" actId="20578"/>
@@ -696,42 +519,6 @@
             <pc:sldMasterMk cId="2940896467" sldId="2147483648"/>
             <pc:sldLayoutMk cId="88811751" sldId="2147483676"/>
           </pc:sldLayoutMkLst>
-          <pc:spChg chg="add del">
-            <ac:chgData name="Sam Khalil" userId="82cd1ec2-6208-465b-9d4d-40ce8f0cbf96" providerId="ADAL" clId="{651B6F30-EC96-2340-AD4B-07A6B9855D0C}" dt="2025-07-17T20:39:46.295" v="1224" actId="11529"/>
-            <ac:spMkLst>
-              <pc:docMk/>
-              <pc:sldMasterMk cId="2940896467" sldId="2147483648"/>
-              <pc:sldLayoutMk cId="88811751" sldId="2147483676"/>
-              <ac:spMk id="4" creationId="{D61816B6-E94D-6D9C-D518-C718E848339B}"/>
-            </ac:spMkLst>
-          </pc:spChg>
-          <pc:spChg chg="add del mod">
-            <ac:chgData name="Sam Khalil" userId="82cd1ec2-6208-465b-9d4d-40ce8f0cbf96" providerId="ADAL" clId="{651B6F30-EC96-2340-AD4B-07A6B9855D0C}" dt="2025-07-17T20:39:50.387" v="1225" actId="478"/>
-            <ac:spMkLst>
-              <pc:docMk/>
-              <pc:sldMasterMk cId="2940896467" sldId="2147483648"/>
-              <pc:sldLayoutMk cId="88811751" sldId="2147483676"/>
-              <ac:spMk id="5" creationId="{119B0F57-6873-79DD-D2A5-E4210B5DE9E3}"/>
-            </ac:spMkLst>
-          </pc:spChg>
-          <pc:spChg chg="add del">
-            <ac:chgData name="Sam Khalil" userId="82cd1ec2-6208-465b-9d4d-40ce8f0cbf96" providerId="ADAL" clId="{651B6F30-EC96-2340-AD4B-07A6B9855D0C}" dt="2025-07-17T20:39:56.478" v="1226" actId="11529"/>
-            <ac:spMkLst>
-              <pc:docMk/>
-              <pc:sldMasterMk cId="2940896467" sldId="2147483648"/>
-              <pc:sldLayoutMk cId="88811751" sldId="2147483676"/>
-              <ac:spMk id="6" creationId="{4B52941E-4775-6143-2E36-388B9E09B9E9}"/>
-            </ac:spMkLst>
-          </pc:spChg>
-          <pc:spChg chg="add del mod">
-            <ac:chgData name="Sam Khalil" userId="82cd1ec2-6208-465b-9d4d-40ce8f0cbf96" providerId="ADAL" clId="{651B6F30-EC96-2340-AD4B-07A6B9855D0C}" dt="2025-07-17T20:40:02.195" v="1227" actId="478"/>
-            <ac:spMkLst>
-              <pc:docMk/>
-              <pc:sldMasterMk cId="2940896467" sldId="2147483648"/>
-              <pc:sldLayoutMk cId="88811751" sldId="2147483676"/>
-              <ac:spMk id="7" creationId="{249C9B60-EA2D-6F1F-2E58-4BFDDC84A498}"/>
-            </ac:spMkLst>
-          </pc:spChg>
         </pc:sldLayoutChg>
         <pc:sldLayoutChg chg="modSp add mod modTransition">
           <pc:chgData name="Sam Khalil" userId="82cd1ec2-6208-465b-9d4d-40ce8f0cbf96" providerId="ADAL" clId="{651B6F30-EC96-2340-AD4B-07A6B9855D0C}" dt="2025-07-17T22:12:58.955" v="1348" actId="962"/>
@@ -775,24 +562,6 @@
               <ac:spMk id="4" creationId="{127F3D65-4217-C7DF-99AC-5D0069212872}"/>
             </ac:spMkLst>
           </pc:spChg>
-          <pc:spChg chg="del">
-            <ac:chgData name="Sam Khalil" userId="82cd1ec2-6208-465b-9d4d-40ce8f0cbf96" providerId="ADAL" clId="{651B6F30-EC96-2340-AD4B-07A6B9855D0C}" dt="2025-07-17T22:40:12.022" v="1350" actId="478"/>
-            <ac:spMkLst>
-              <pc:docMk/>
-              <pc:sldMasterMk cId="2940896467" sldId="2147483648"/>
-              <pc:sldLayoutMk cId="2538074859" sldId="2147483678"/>
-              <ac:spMk id="5" creationId="{3EC742A8-1DE0-BB3C-0CAC-88DE22F8BB50}"/>
-            </ac:spMkLst>
-          </pc:spChg>
-          <pc:spChg chg="del">
-            <ac:chgData name="Sam Khalil" userId="82cd1ec2-6208-465b-9d4d-40ce8f0cbf96" providerId="ADAL" clId="{651B6F30-EC96-2340-AD4B-07A6B9855D0C}" dt="2025-07-17T22:40:12.022" v="1350" actId="478"/>
-            <ac:spMkLst>
-              <pc:docMk/>
-              <pc:sldMasterMk cId="2940896467" sldId="2147483648"/>
-              <pc:sldLayoutMk cId="2538074859" sldId="2147483678"/>
-              <ac:spMk id="6" creationId="{78C25294-674A-0237-57DC-CE5D5F857C77}"/>
-            </ac:spMkLst>
-          </pc:spChg>
           <pc:spChg chg="mod">
             <ac:chgData name="Sam Khalil" userId="82cd1ec2-6208-465b-9d4d-40ce8f0cbf96" providerId="ADAL" clId="{651B6F30-EC96-2340-AD4B-07A6B9855D0C}" dt="2025-07-17T22:40:18.173" v="1351" actId="1076"/>
             <ac:spMkLst>
@@ -800,15 +569,6 @@
               <pc:sldMasterMk cId="2940896467" sldId="2147483648"/>
               <pc:sldLayoutMk cId="2538074859" sldId="2147483678"/>
               <ac:spMk id="7" creationId="{B52E7DE5-AE9F-8300-785A-713154A75462}"/>
-            </ac:spMkLst>
-          </pc:spChg>
-          <pc:spChg chg="del">
-            <ac:chgData name="Sam Khalil" userId="82cd1ec2-6208-465b-9d4d-40ce8f0cbf96" providerId="ADAL" clId="{651B6F30-EC96-2340-AD4B-07A6B9855D0C}" dt="2025-07-17T22:40:12.022" v="1350" actId="478"/>
-            <ac:spMkLst>
-              <pc:docMk/>
-              <pc:sldMasterMk cId="2940896467" sldId="2147483648"/>
-              <pc:sldLayoutMk cId="2538074859" sldId="2147483678"/>
-              <ac:spMk id="8" creationId="{DCEA0E39-252E-0FD3-E342-D8B9B2DD48A8}"/>
             </ac:spMkLst>
           </pc:spChg>
           <pc:spChg chg="mod">
@@ -856,15 +616,6 @@
               <ac:spMk id="13" creationId="{72AA8F7B-26F0-198C-F59E-D4EAAA390678}"/>
             </ac:spMkLst>
           </pc:spChg>
-          <pc:spChg chg="del">
-            <ac:chgData name="Sam Khalil" userId="82cd1ec2-6208-465b-9d4d-40ce8f0cbf96" providerId="ADAL" clId="{651B6F30-EC96-2340-AD4B-07A6B9855D0C}" dt="2025-07-17T22:40:12.022" v="1350" actId="478"/>
-            <ac:spMkLst>
-              <pc:docMk/>
-              <pc:sldMasterMk cId="2940896467" sldId="2147483648"/>
-              <pc:sldLayoutMk cId="2538074859" sldId="2147483678"/>
-              <ac:spMk id="14" creationId="{BCEDE17A-C31D-39B6-1DD5-DFF09F743405}"/>
-            </ac:spMkLst>
-          </pc:spChg>
         </pc:sldLayoutChg>
       </pc:sldMasterChg>
     </pc:docChg>
@@ -966,7 +717,7 @@
           <a:p>
             <a:fld id="{D2339670-67E6-CD42-B7B2-F285F1108ED9}" type="datetimeFigureOut">
               <a:rPr lang="en-US" smtClean="0"/>
-              <a:t>7/18/25</a:t>
+              <a:t>7/20/25</a:t>
             </a:fld>
             <a:endParaRPr lang="en-US"/>
           </a:p>
@@ -1142,7 +893,7 @@
           </a:lstStyle>
           <a:p>
             <a:fld id="{1E521F2A-B11E-40E0-8F26-7CD21B55A12D}" type="datetimeFigureOut">
-              <a:t>7/17/25</a:t>
+              <a:t>7/20/25</a:t>
             </a:fld>
             <a:endParaRPr lang="en-GB"/>
           </a:p>
@@ -8345,14 +8096,12 @@
 </file>
 
 <file path=customXml/item1.xml><?xml version="1.0" encoding="utf-8"?>
-<p:properties xmlns:p="http://schemas.microsoft.com/office/2006/metadata/properties" xmlns:xsi="http://www.w3.org/2001/XMLSchema-instance" xmlns:pc="http://schemas.microsoft.com/office/infopath/2007/PartnerControls">
-  <documentManagement>
-    <TaxCatchAll xmlns="2bdccfd7-ed75-47c4-ae3e-45ba8291135b" xsi:nil="true"/>
-    <lcf76f155ced4ddcb4097134ff3c332f xmlns="bdfda862-7558-4f4e-99f8-648970d7935e">
-      <Terms xmlns="http://schemas.microsoft.com/office/infopath/2007/PartnerControls"/>
-    </lcf76f155ced4ddcb4097134ff3c332f>
-  </documentManagement>
-</p:properties>
+<?mso-contentType ?>
+<FormTemplates xmlns="http://schemas.microsoft.com/sharepoint/v3/contenttype/forms">
+  <Display>DocumentLibraryForm</Display>
+  <Edit>DocumentLibraryForm</Edit>
+  <New>DocumentLibraryForm</New>
+</FormTemplates>
 </file>
 
 <file path=customXml/item2.xml><?xml version="1.0" encoding="utf-8"?>
@@ -8563,27 +8312,20 @@
 </file>
 
 <file path=customXml/item3.xml><?xml version="1.0" encoding="utf-8"?>
-<?mso-contentType ?>
-<FormTemplates xmlns="http://schemas.microsoft.com/sharepoint/v3/contenttype/forms">
-  <Display>DocumentLibraryForm</Display>
-  <Edit>DocumentLibraryForm</Edit>
-  <New>DocumentLibraryForm</New>
-</FormTemplates>
+<p:properties xmlns:p="http://schemas.microsoft.com/office/2006/metadata/properties" xmlns:xsi="http://www.w3.org/2001/XMLSchema-instance" xmlns:pc="http://schemas.microsoft.com/office/infopath/2007/PartnerControls">
+  <documentManagement>
+    <TaxCatchAll xmlns="2bdccfd7-ed75-47c4-ae3e-45ba8291135b" xsi:nil="true"/>
+    <lcf76f155ced4ddcb4097134ff3c332f xmlns="bdfda862-7558-4f4e-99f8-648970d7935e">
+      <Terms xmlns="http://schemas.microsoft.com/office/infopath/2007/PartnerControls"/>
+    </lcf76f155ced4ddcb4097134ff3c332f>
+  </documentManagement>
+</p:properties>
 </file>
 
 <file path=customXml/itemProps1.xml><?xml version="1.0" encoding="utf-8"?>
-<ds:datastoreItem xmlns:ds="http://schemas.openxmlformats.org/officeDocument/2006/customXml" ds:itemID="{E18F5EE7-65DF-41C5-963C-25B6B377F939}">
+<ds:datastoreItem xmlns:ds="http://schemas.openxmlformats.org/officeDocument/2006/customXml" ds:itemID="{C2B4E4C2-7A23-4EC8-AE63-F75F63DE72BE}">
   <ds:schemaRefs>
-    <ds:schemaRef ds:uri="http://schemas.microsoft.com/office/2006/metadata/properties"/>
-    <ds:schemaRef ds:uri="http://schemas.openxmlformats.org/package/2006/metadata/core-properties"/>
-    <ds:schemaRef ds:uri="bdfda862-7558-4f4e-99f8-648970d7935e"/>
-    <ds:schemaRef ds:uri="http://www.w3.org/XML/1998/namespace"/>
-    <ds:schemaRef ds:uri="http://purl.org/dc/terms/"/>
-    <ds:schemaRef ds:uri="http://schemas.microsoft.com/office/infopath/2007/PartnerControls"/>
-    <ds:schemaRef ds:uri="http://schemas.microsoft.com/office/2006/documentManagement/types"/>
-    <ds:schemaRef ds:uri="2bdccfd7-ed75-47c4-ae3e-45ba8291135b"/>
-    <ds:schemaRef ds:uri="http://purl.org/dc/dcmitype/"/>
-    <ds:schemaRef ds:uri="http://purl.org/dc/elements/1.1/"/>
+    <ds:schemaRef ds:uri="http://schemas.microsoft.com/sharepoint/v3/contenttype/forms"/>
   </ds:schemaRefs>
 </ds:datastoreItem>
 </file>
@@ -8608,9 +8350,18 @@
 </file>
 
 <file path=customXml/itemProps3.xml><?xml version="1.0" encoding="utf-8"?>
-<ds:datastoreItem xmlns:ds="http://schemas.openxmlformats.org/officeDocument/2006/customXml" ds:itemID="{C2B4E4C2-7A23-4EC8-AE63-F75F63DE72BE}">
+<ds:datastoreItem xmlns:ds="http://schemas.openxmlformats.org/officeDocument/2006/customXml" ds:itemID="{E18F5EE7-65DF-41C5-963C-25B6B377F939}">
   <ds:schemaRefs>
-    <ds:schemaRef ds:uri="http://schemas.microsoft.com/sharepoint/v3/contenttype/forms"/>
+    <ds:schemaRef ds:uri="2bdccfd7-ed75-47c4-ae3e-45ba8291135b"/>
+    <ds:schemaRef ds:uri="http://schemas.microsoft.com/office/infopath/2007/PartnerControls"/>
+    <ds:schemaRef ds:uri="http://purl.org/dc/dcmitype/"/>
+    <ds:schemaRef ds:uri="http://schemas.microsoft.com/office/2006/metadata/properties"/>
+    <ds:schemaRef ds:uri="http://purl.org/dc/terms/"/>
+    <ds:schemaRef ds:uri="http://schemas.microsoft.com/office/2006/documentManagement/types"/>
+    <ds:schemaRef ds:uri="http://purl.org/dc/elements/1.1/"/>
+    <ds:schemaRef ds:uri="http://schemas.openxmlformats.org/package/2006/metadata/core-properties"/>
+    <ds:schemaRef ds:uri="bdfda862-7558-4f4e-99f8-648970d7935e"/>
+    <ds:schemaRef ds:uri="http://www.w3.org/XML/1998/namespace"/>
   </ds:schemaRefs>
 </ds:datastoreItem>
 </file>
</xml_diff>

<commit_message>
🤖 Update README.md to document new features including TRUE parallel processing for HTML generation and viewport constraint enforcement. Add image compression functionality in agents.py for optimized LLM processing. Revise HTML content generation to remove sprite definitions and ensure clean HTML output. Update HTMLRenderer to handle sprite injection more effectively.
</commit_message>
<xml_diff>
--- a/ekona_slides_template_new.pptx
+++ b/ekona_slides_template_new.pptx
@@ -121,7 +121,7 @@
 <file path=ppt/revisionInfo.xml><?xml version="1.0" encoding="utf-8"?>
 <p1510:revInfo xmlns:a="http://schemas.openxmlformats.org/drawingml/2006/main" xmlns:r="http://schemas.openxmlformats.org/officeDocument/2006/relationships" xmlns:p1510="http://schemas.microsoft.com/office/powerpoint/2015/10/main">
   <p1510:revLst>
-    <p1510:client id="{651B6F30-EC96-2340-AD4B-07A6B9855D0C}" v="125" dt="2025-07-17T22:12:58.955"/>
+    <p1510:client id="{651B6F30-EC96-2340-AD4B-07A6B9855D0C}" v="174" dt="2025-07-20T15:51:34.838"/>
   </p1510:revLst>
 </p1510:revInfo>
 </file>
@@ -131,10 +131,17 @@
   <pc:docChgLst>
     <pc:chgData name="Sam Khalil" userId="82cd1ec2-6208-465b-9d4d-40ce8f0cbf96" providerId="ADAL" clId="{651B6F30-EC96-2340-AD4B-07A6B9855D0C}"/>
     <pc:docChg chg="undo custSel addSld delSld modSld modMainMaster">
-      <pc:chgData name="Sam Khalil" userId="82cd1ec2-6208-465b-9d4d-40ce8f0cbf96" providerId="ADAL" clId="{651B6F30-EC96-2340-AD4B-07A6B9855D0C}" dt="2025-07-20T12:56:25.527" v="1353" actId="2696"/>
+      <pc:chgData name="Sam Khalil" userId="82cd1ec2-6208-465b-9d4d-40ce8f0cbf96" providerId="ADAL" clId="{651B6F30-EC96-2340-AD4B-07A6B9855D0C}" dt="2025-07-20T15:51:45.829" v="1447" actId="2696"/>
       <pc:docMkLst>
         <pc:docMk/>
       </pc:docMkLst>
+      <pc:sldChg chg="new del">
+        <pc:chgData name="Sam Khalil" userId="82cd1ec2-6208-465b-9d4d-40ce8f0cbf96" providerId="ADAL" clId="{651B6F30-EC96-2340-AD4B-07A6B9855D0C}" dt="2025-07-20T15:51:45.829" v="1447" actId="2696"/>
+        <pc:sldMkLst>
+          <pc:docMk/>
+          <pc:sldMk cId="812657698" sldId="256"/>
+        </pc:sldMkLst>
+      </pc:sldChg>
       <pc:sldChg chg="new del">
         <pc:chgData name="Sam Khalil" userId="82cd1ec2-6208-465b-9d4d-40ce8f0cbf96" providerId="ADAL" clId="{651B6F30-EC96-2340-AD4B-07A6B9855D0C}" dt="2025-07-16T20:03:10.194" v="3" actId="2696"/>
         <pc:sldMkLst>
@@ -185,7 +192,7 @@
         </pc:sldMkLst>
       </pc:sldChg>
       <pc:sldMasterChg chg="addSldLayout delSldLayout modSldLayout sldLayoutOrd">
-        <pc:chgData name="Sam Khalil" userId="82cd1ec2-6208-465b-9d4d-40ce8f0cbf96" providerId="ADAL" clId="{651B6F30-EC96-2340-AD4B-07A6B9855D0C}" dt="2025-07-17T22:40:18.173" v="1351" actId="1076"/>
+        <pc:chgData name="Sam Khalil" userId="82cd1ec2-6208-465b-9d4d-40ce8f0cbf96" providerId="ADAL" clId="{651B6F30-EC96-2340-AD4B-07A6B9855D0C}" dt="2025-07-20T15:51:34.838" v="1445" actId="404"/>
         <pc:sldMasterMkLst>
           <pc:docMk/>
           <pc:sldMasterMk cId="2940896467" sldId="2147483648"/>
@@ -388,7 +395,7 @@
           </pc:sldLayoutMkLst>
         </pc:sldLayoutChg>
         <pc:sldLayoutChg chg="addSp delSp modSp mod ord">
-          <pc:chgData name="Sam Khalil" userId="82cd1ec2-6208-465b-9d4d-40ce8f0cbf96" providerId="ADAL" clId="{651B6F30-EC96-2340-AD4B-07A6B9855D0C}" dt="2025-07-17T16:52:43.058" v="1222" actId="20577"/>
+          <pc:chgData name="Sam Khalil" userId="82cd1ec2-6208-465b-9d4d-40ce8f0cbf96" providerId="ADAL" clId="{651B6F30-EC96-2340-AD4B-07A6B9855D0C}" dt="2025-07-20T15:51:25.535" v="1443" actId="20577"/>
           <pc:sldLayoutMkLst>
             <pc:docMk/>
             <pc:sldMasterMk cId="2940896467" sldId="2147483648"/>
@@ -404,7 +411,7 @@
             </ac:spMkLst>
           </pc:spChg>
           <pc:spChg chg="add mod">
-            <ac:chgData name="Sam Khalil" userId="82cd1ec2-6208-465b-9d4d-40ce8f0cbf96" providerId="ADAL" clId="{651B6F30-EC96-2340-AD4B-07A6B9855D0C}" dt="2025-07-17T16:43:09.084" v="1196" actId="962"/>
+            <ac:chgData name="Sam Khalil" userId="82cd1ec2-6208-465b-9d4d-40ce8f0cbf96" providerId="ADAL" clId="{651B6F30-EC96-2340-AD4B-07A6B9855D0C}" dt="2025-07-20T15:51:25.535" v="1443" actId="20577"/>
             <ac:spMkLst>
               <pc:docMk/>
               <pc:sldMasterMk cId="2940896467" sldId="2147483648"/>
@@ -413,7 +420,7 @@
             </ac:spMkLst>
           </pc:spChg>
           <pc:spChg chg="add mod">
-            <ac:chgData name="Sam Khalil" userId="82cd1ec2-6208-465b-9d4d-40ce8f0cbf96" providerId="ADAL" clId="{651B6F30-EC96-2340-AD4B-07A6B9855D0C}" dt="2025-07-17T16:52:41.643" v="1221" actId="20577"/>
+            <ac:chgData name="Sam Khalil" userId="82cd1ec2-6208-465b-9d4d-40ce8f0cbf96" providerId="ADAL" clId="{651B6F30-EC96-2340-AD4B-07A6B9855D0C}" dt="2025-07-20T15:49:13.279" v="1361" actId="404"/>
             <ac:spMkLst>
               <pc:docMk/>
               <pc:sldMasterMk cId="2940896467" sldId="2147483648"/>
@@ -422,7 +429,7 @@
             </ac:spMkLst>
           </pc:spChg>
           <pc:spChg chg="add mod">
-            <ac:chgData name="Sam Khalil" userId="82cd1ec2-6208-465b-9d4d-40ce8f0cbf96" providerId="ADAL" clId="{651B6F30-EC96-2340-AD4B-07A6B9855D0C}" dt="2025-07-17T16:43:18.506" v="1199" actId="962"/>
+            <ac:chgData name="Sam Khalil" userId="82cd1ec2-6208-465b-9d4d-40ce8f0cbf96" providerId="ADAL" clId="{651B6F30-EC96-2340-AD4B-07A6B9855D0C}" dt="2025-07-20T15:50:43.304" v="1425" actId="122"/>
             <ac:spMkLst>
               <pc:docMk/>
               <pc:sldMasterMk cId="2940896467" sldId="2147483648"/>
@@ -431,7 +438,7 @@
             </ac:spMkLst>
           </pc:spChg>
           <pc:spChg chg="add del mod">
-            <ac:chgData name="Sam Khalil" userId="82cd1ec2-6208-465b-9d4d-40ce8f0cbf96" providerId="ADAL" clId="{651B6F30-EC96-2340-AD4B-07A6B9855D0C}" dt="2025-07-17T16:52:34.116" v="1217" actId="20577"/>
+            <ac:chgData name="Sam Khalil" userId="82cd1ec2-6208-465b-9d4d-40ce8f0cbf96" providerId="ADAL" clId="{651B6F30-EC96-2340-AD4B-07A6B9855D0C}" dt="2025-07-20T15:49:16.063" v="1363" actId="404"/>
             <ac:spMkLst>
               <pc:docMk/>
               <pc:sldMasterMk cId="2940896467" sldId="2147483648"/>
@@ -440,7 +447,7 @@
             </ac:spMkLst>
           </pc:spChg>
           <pc:spChg chg="add mod">
-            <ac:chgData name="Sam Khalil" userId="82cd1ec2-6208-465b-9d4d-40ce8f0cbf96" providerId="ADAL" clId="{651B6F30-EC96-2340-AD4B-07A6B9855D0C}" dt="2025-07-17T13:45:48.242" v="1146" actId="14861"/>
+            <ac:chgData name="Sam Khalil" userId="82cd1ec2-6208-465b-9d4d-40ce8f0cbf96" providerId="ADAL" clId="{651B6F30-EC96-2340-AD4B-07A6B9855D0C}" dt="2025-07-20T15:50:38.422" v="1423" actId="20577"/>
             <ac:spMkLst>
               <pc:docMk/>
               <pc:sldMasterMk cId="2940896467" sldId="2147483648"/>
@@ -449,7 +456,7 @@
             </ac:spMkLst>
           </pc:spChg>
           <pc:spChg chg="add mod">
-            <ac:chgData name="Sam Khalil" userId="82cd1ec2-6208-465b-9d4d-40ce8f0cbf96" providerId="ADAL" clId="{651B6F30-EC96-2340-AD4B-07A6B9855D0C}" dt="2025-07-17T16:43:29.629" v="1204" actId="962"/>
+            <ac:chgData name="Sam Khalil" userId="82cd1ec2-6208-465b-9d4d-40ce8f0cbf96" providerId="ADAL" clId="{651B6F30-EC96-2340-AD4B-07A6B9855D0C}" dt="2025-07-20T15:51:22.837" v="1441" actId="20577"/>
             <ac:spMkLst>
               <pc:docMk/>
               <pc:sldMasterMk cId="2940896467" sldId="2147483648"/>
@@ -458,7 +465,7 @@
             </ac:spMkLst>
           </pc:spChg>
           <pc:spChg chg="add mod">
-            <ac:chgData name="Sam Khalil" userId="82cd1ec2-6208-465b-9d4d-40ce8f0cbf96" providerId="ADAL" clId="{651B6F30-EC96-2340-AD4B-07A6B9855D0C}" dt="2025-07-17T16:52:25.016" v="1206" actId="20577"/>
+            <ac:chgData name="Sam Khalil" userId="82cd1ec2-6208-465b-9d4d-40ce8f0cbf96" providerId="ADAL" clId="{651B6F30-EC96-2340-AD4B-07A6B9855D0C}" dt="2025-07-20T15:49:07.642" v="1357" actId="404"/>
             <ac:spMkLst>
               <pc:docMk/>
               <pc:sldMasterMk cId="2940896467" sldId="2147483648"/>
@@ -467,7 +474,7 @@
             </ac:spMkLst>
           </pc:spChg>
           <pc:spChg chg="add mod">
-            <ac:chgData name="Sam Khalil" userId="82cd1ec2-6208-465b-9d4d-40ce8f0cbf96" providerId="ADAL" clId="{651B6F30-EC96-2340-AD4B-07A6B9855D0C}" dt="2025-07-17T13:46:00.573" v="1149" actId="14861"/>
+            <ac:chgData name="Sam Khalil" userId="82cd1ec2-6208-465b-9d4d-40ce8f0cbf96" providerId="ADAL" clId="{651B6F30-EC96-2340-AD4B-07A6B9855D0C}" dt="2025-07-20T15:51:00.216" v="1431" actId="404"/>
             <ac:spMkLst>
               <pc:docMk/>
               <pc:sldMasterMk cId="2940896467" sldId="2147483648"/>
@@ -476,7 +483,7 @@
             </ac:spMkLst>
           </pc:spChg>
           <pc:spChg chg="add mod">
-            <ac:chgData name="Sam Khalil" userId="82cd1ec2-6208-465b-9d4d-40ce8f0cbf96" providerId="ADAL" clId="{651B6F30-EC96-2340-AD4B-07A6B9855D0C}" dt="2025-07-17T16:52:43.058" v="1222" actId="20577"/>
+            <ac:chgData name="Sam Khalil" userId="82cd1ec2-6208-465b-9d4d-40ce8f0cbf96" providerId="ADAL" clId="{651B6F30-EC96-2340-AD4B-07A6B9855D0C}" dt="2025-07-20T15:49:11.008" v="1359" actId="404"/>
             <ac:spMkLst>
               <pc:docMk/>
               <pc:sldMasterMk cId="2940896467" sldId="2147483648"/>
@@ -485,7 +492,7 @@
             </ac:spMkLst>
           </pc:spChg>
           <pc:spChg chg="add mod">
-            <ac:chgData name="Sam Khalil" userId="82cd1ec2-6208-465b-9d4d-40ce8f0cbf96" providerId="ADAL" clId="{651B6F30-EC96-2340-AD4B-07A6B9855D0C}" dt="2025-07-17T13:45:53.140" v="1147" actId="14861"/>
+            <ac:chgData name="Sam Khalil" userId="82cd1ec2-6208-465b-9d4d-40ce8f0cbf96" providerId="ADAL" clId="{651B6F30-EC96-2340-AD4B-07A6B9855D0C}" dt="2025-07-20T15:50:41.068" v="1424" actId="122"/>
             <ac:spMkLst>
               <pc:docMk/>
               <pc:sldMasterMk cId="2940896467" sldId="2147483648"/>
@@ -494,7 +501,7 @@
             </ac:spMkLst>
           </pc:spChg>
           <pc:spChg chg="add mod">
-            <ac:chgData name="Sam Khalil" userId="82cd1ec2-6208-465b-9d4d-40ce8f0cbf96" providerId="ADAL" clId="{651B6F30-EC96-2340-AD4B-07A6B9855D0C}" dt="2025-07-17T16:52:27.742" v="1210" actId="20577"/>
+            <ac:chgData name="Sam Khalil" userId="82cd1ec2-6208-465b-9d4d-40ce8f0cbf96" providerId="ADAL" clId="{651B6F30-EC96-2340-AD4B-07A6B9855D0C}" dt="2025-07-20T15:49:04.200" v="1355" actId="404"/>
             <ac:spMkLst>
               <pc:docMk/>
               <pc:sldMasterMk cId="2940896467" sldId="2147483648"/>
@@ -503,7 +510,7 @@
             </ac:spMkLst>
           </pc:spChg>
           <pc:spChg chg="add mod">
-            <ac:chgData name="Sam Khalil" userId="82cd1ec2-6208-465b-9d4d-40ce8f0cbf96" providerId="ADAL" clId="{651B6F30-EC96-2340-AD4B-07A6B9855D0C}" dt="2025-07-17T16:52:38.759" v="1220" actId="20577"/>
+            <ac:chgData name="Sam Khalil" userId="82cd1ec2-6208-465b-9d4d-40ce8f0cbf96" providerId="ADAL" clId="{651B6F30-EC96-2340-AD4B-07A6B9855D0C}" dt="2025-07-20T15:49:18.605" v="1365" actId="404"/>
             <ac:spMkLst>
               <pc:docMk/>
               <pc:sldMasterMk cId="2940896467" sldId="2147483648"/>
@@ -538,7 +545,7 @@
           </pc:spChg>
         </pc:sldLayoutChg>
         <pc:sldLayoutChg chg="delSp modSp add mod modTransition">
-          <pc:chgData name="Sam Khalil" userId="82cd1ec2-6208-465b-9d4d-40ce8f0cbf96" providerId="ADAL" clId="{651B6F30-EC96-2340-AD4B-07A6B9855D0C}" dt="2025-07-17T22:40:18.173" v="1351" actId="1076"/>
+          <pc:chgData name="Sam Khalil" userId="82cd1ec2-6208-465b-9d4d-40ce8f0cbf96" providerId="ADAL" clId="{651B6F30-EC96-2340-AD4B-07A6B9855D0C}" dt="2025-07-20T15:51:34.838" v="1445" actId="404"/>
           <pc:sldLayoutMkLst>
             <pc:docMk/>
             <pc:sldMasterMk cId="2940896467" sldId="2147483648"/>
@@ -554,7 +561,7 @@
             </ac:spMkLst>
           </pc:spChg>
           <pc:spChg chg="mod">
-            <ac:chgData name="Sam Khalil" userId="82cd1ec2-6208-465b-9d4d-40ce8f0cbf96" providerId="ADAL" clId="{651B6F30-EC96-2340-AD4B-07A6B9855D0C}" dt="2025-07-17T22:40:18.173" v="1351" actId="1076"/>
+            <ac:chgData name="Sam Khalil" userId="82cd1ec2-6208-465b-9d4d-40ce8f0cbf96" providerId="ADAL" clId="{651B6F30-EC96-2340-AD4B-07A6B9855D0C}" dt="2025-07-20T15:51:34.838" v="1445" actId="404"/>
             <ac:spMkLst>
               <pc:docMk/>
               <pc:sldMasterMk cId="2940896467" sldId="2147483648"/>
@@ -572,7 +579,7 @@
             </ac:spMkLst>
           </pc:spChg>
           <pc:spChg chg="mod">
-            <ac:chgData name="Sam Khalil" userId="82cd1ec2-6208-465b-9d4d-40ce8f0cbf96" providerId="ADAL" clId="{651B6F30-EC96-2340-AD4B-07A6B9855D0C}" dt="2025-07-17T22:40:18.173" v="1351" actId="1076"/>
+            <ac:chgData name="Sam Khalil" userId="82cd1ec2-6208-465b-9d4d-40ce8f0cbf96" providerId="ADAL" clId="{651B6F30-EC96-2340-AD4B-07A6B9855D0C}" dt="2025-07-20T15:51:34.838" v="1445" actId="404"/>
             <ac:spMkLst>
               <pc:docMk/>
               <pc:sldMasterMk cId="2940896467" sldId="2147483648"/>
@@ -590,7 +597,7 @@
             </ac:spMkLst>
           </pc:spChg>
           <pc:spChg chg="mod">
-            <ac:chgData name="Sam Khalil" userId="82cd1ec2-6208-465b-9d4d-40ce8f0cbf96" providerId="ADAL" clId="{651B6F30-EC96-2340-AD4B-07A6B9855D0C}" dt="2025-07-17T22:40:18.173" v="1351" actId="1076"/>
+            <ac:chgData name="Sam Khalil" userId="82cd1ec2-6208-465b-9d4d-40ce8f0cbf96" providerId="ADAL" clId="{651B6F30-EC96-2340-AD4B-07A6B9855D0C}" dt="2025-07-20T15:51:34.838" v="1445" actId="404"/>
             <ac:spMkLst>
               <pc:docMk/>
               <pc:sldMasterMk cId="2940896467" sldId="2147483648"/>
@@ -608,7 +615,7 @@
             </ac:spMkLst>
           </pc:spChg>
           <pc:spChg chg="mod">
-            <ac:chgData name="Sam Khalil" userId="82cd1ec2-6208-465b-9d4d-40ce8f0cbf96" providerId="ADAL" clId="{651B6F30-EC96-2340-AD4B-07A6B9855D0C}" dt="2025-07-17T22:40:18.173" v="1351" actId="1076"/>
+            <ac:chgData name="Sam Khalil" userId="82cd1ec2-6208-465b-9d4d-40ce8f0cbf96" providerId="ADAL" clId="{651B6F30-EC96-2340-AD4B-07A6B9855D0C}" dt="2025-07-20T15:51:34.838" v="1445" actId="404"/>
             <ac:spMkLst>
               <pc:docMk/>
               <pc:sldMasterMk cId="2940896467" sldId="2147483648"/>
@@ -5632,13 +5639,19 @@
           <a:lstStyle>
             <a:lvl1pPr marL="0" indent="0" algn="ctr">
               <a:buNone/>
-              <a:defRPr sz="2000"/>
+              <a:defRPr sz="1400"/>
             </a:lvl1pPr>
           </a:lstStyle>
           <a:p>
             <a:r>
               <a:rPr lang="en-US" dirty="0"/>
-              <a:t>Icon1</a:t>
+              <a:t>Icon 1</a:t>
+            </a:r>
+          </a:p>
+          <a:p>
+            <a:r>
+              <a:rPr lang="en-US" dirty="0"/>
+              <a:t>24x24px</a:t>
             </a:r>
           </a:p>
         </p:txBody>
@@ -5673,7 +5686,7 @@
           <a:lstStyle>
             <a:lvl1pPr marL="0" indent="0">
               <a:buNone/>
-              <a:defRPr/>
+              <a:defRPr sz="2000"/>
             </a:lvl1pPr>
           </a:lstStyle>
           <a:p>
@@ -5703,7 +5716,7 @@
         </p:nvSpPr>
         <p:spPr>
           <a:xfrm>
-            <a:off x="6634162" y="2266198"/>
+            <a:off x="6634161" y="2275808"/>
             <a:ext cx="830263" cy="746125"/>
           </a:xfrm>
           <a:prstGeom prst="rect">
@@ -5720,9 +5733,9 @@
         <p:txBody>
           <a:bodyPr/>
           <a:lstStyle>
-            <a:lvl1pPr marL="0" indent="0">
+            <a:lvl1pPr marL="0" indent="0" algn="ctr">
               <a:buNone/>
-              <a:defRPr sz="2000"/>
+              <a:defRPr sz="1200"/>
             </a:lvl1pPr>
           </a:lstStyle>
           <a:p>
@@ -5731,6 +5744,12 @@
               <a:t>Icon 2</a:t>
             </a:r>
           </a:p>
+          <a:p>
+            <a:r>
+              <a:rPr lang="en-US" dirty="0"/>
+              <a:t>24x24px</a:t>
+            </a:r>
+          </a:p>
         </p:txBody>
       </p:sp>
       <p:sp>
@@ -5763,7 +5782,7 @@
           <a:lstStyle>
             <a:lvl1pPr marL="0" indent="0">
               <a:buNone/>
-              <a:defRPr/>
+              <a:defRPr sz="2000"/>
             </a:lvl1pPr>
           </a:lstStyle>
           <a:p>
@@ -5810,7 +5829,7 @@
         <p:txBody>
           <a:bodyPr/>
           <a:lstStyle>
-            <a:lvl1pPr marL="0" marR="0" indent="0" algn="l" defTabSz="914400" rtl="0" eaLnBrk="1" fontAlgn="auto" latinLnBrk="0" hangingPunct="1">
+            <a:lvl1pPr marL="0" marR="0" indent="0" algn="ctr" defTabSz="914400" rtl="0" eaLnBrk="1" fontAlgn="auto" latinLnBrk="0" hangingPunct="1">
               <a:lnSpc>
                 <a:spcPct val="90000"/>
               </a:lnSpc>
@@ -5825,7 +5844,7 @@
               <a:buFont typeface="Arial" panose="020B0604020202020204" pitchFamily="34" charset="0"/>
               <a:buNone/>
               <a:tabLst/>
-              <a:defRPr sz="2000"/>
+              <a:defRPr sz="1200"/>
             </a:lvl1pPr>
           </a:lstStyle>
           <a:p>
@@ -5834,6 +5853,12 @@
               <a:t>Icon 3</a:t>
             </a:r>
           </a:p>
+          <a:p>
+            <a:r>
+              <a:rPr lang="en-US" dirty="0"/>
+              <a:t>24x24px</a:t>
+            </a:r>
+          </a:p>
         </p:txBody>
       </p:sp>
       <p:sp>
@@ -5866,7 +5891,7 @@
           <a:lstStyle>
             <a:lvl1pPr marL="0" indent="0">
               <a:buNone/>
-              <a:defRPr/>
+              <a:defRPr sz="2000"/>
             </a:lvl1pPr>
           </a:lstStyle>
           <a:p>
@@ -5913,7 +5938,7 @@
         <p:txBody>
           <a:bodyPr/>
           <a:lstStyle>
-            <a:lvl1pPr marL="0" marR="0" indent="0" algn="l" defTabSz="914400" rtl="0" eaLnBrk="1" fontAlgn="auto" latinLnBrk="0" hangingPunct="1">
+            <a:lvl1pPr marL="0" marR="0" indent="0" algn="ctr" defTabSz="914400" rtl="0" eaLnBrk="1" fontAlgn="auto" latinLnBrk="0" hangingPunct="1">
               <a:lnSpc>
                 <a:spcPct val="90000"/>
               </a:lnSpc>
@@ -5928,7 +5953,7 @@
               <a:buFont typeface="Arial" panose="020B0604020202020204" pitchFamily="34" charset="0"/>
               <a:buNone/>
               <a:tabLst/>
-              <a:defRPr sz="2000"/>
+              <a:defRPr sz="1200"/>
             </a:lvl1pPr>
           </a:lstStyle>
           <a:p>
@@ -5937,6 +5962,12 @@
               <a:t>Icon 4</a:t>
             </a:r>
           </a:p>
+          <a:p>
+            <a:r>
+              <a:rPr lang="en-US" dirty="0"/>
+              <a:t>24x24px</a:t>
+            </a:r>
+          </a:p>
         </p:txBody>
       </p:sp>
       <p:sp>
@@ -5969,7 +6000,7 @@
           <a:lstStyle>
             <a:lvl1pPr marL="0" indent="0">
               <a:buNone/>
-              <a:defRPr/>
+              <a:defRPr sz="2000"/>
             </a:lvl1pPr>
           </a:lstStyle>
           <a:p>
@@ -6016,7 +6047,7 @@
         <p:txBody>
           <a:bodyPr/>
           <a:lstStyle>
-            <a:lvl1pPr marL="0" marR="0" indent="0" algn="l" defTabSz="914400" rtl="0" eaLnBrk="1" fontAlgn="auto" latinLnBrk="0" hangingPunct="1">
+            <a:lvl1pPr marL="0" marR="0" indent="0" algn="ctr" defTabSz="914400" rtl="0" eaLnBrk="1" fontAlgn="auto" latinLnBrk="0" hangingPunct="1">
               <a:lnSpc>
                 <a:spcPct val="90000"/>
               </a:lnSpc>
@@ -6031,7 +6062,7 @@
               <a:buFont typeface="Arial" panose="020B0604020202020204" pitchFamily="34" charset="0"/>
               <a:buNone/>
               <a:tabLst/>
-              <a:defRPr sz="2000"/>
+              <a:defRPr sz="1200"/>
             </a:lvl1pPr>
           </a:lstStyle>
           <a:p>
@@ -6040,6 +6071,12 @@
               <a:t>Icon 5</a:t>
             </a:r>
           </a:p>
+          <a:p>
+            <a:r>
+              <a:rPr lang="en-US" dirty="0"/>
+              <a:t>24x24px</a:t>
+            </a:r>
+          </a:p>
         </p:txBody>
       </p:sp>
       <p:sp>
@@ -6072,7 +6109,7 @@
           <a:lstStyle>
             <a:lvl1pPr marL="0" indent="0">
               <a:buNone/>
-              <a:defRPr/>
+              <a:defRPr sz="2000"/>
             </a:lvl1pPr>
           </a:lstStyle>
           <a:p>
@@ -6119,7 +6156,7 @@
         <p:txBody>
           <a:bodyPr/>
           <a:lstStyle>
-            <a:lvl1pPr marL="0" marR="0" indent="0" algn="l" defTabSz="914400" rtl="0" eaLnBrk="1" fontAlgn="auto" latinLnBrk="0" hangingPunct="1">
+            <a:lvl1pPr marL="0" marR="0" indent="0" algn="ctr" defTabSz="914400" rtl="0" eaLnBrk="1" fontAlgn="auto" latinLnBrk="0" hangingPunct="1">
               <a:lnSpc>
                 <a:spcPct val="90000"/>
               </a:lnSpc>
@@ -6134,7 +6171,7 @@
               <a:buFont typeface="Arial" panose="020B0604020202020204" pitchFamily="34" charset="0"/>
               <a:buNone/>
               <a:tabLst/>
-              <a:defRPr sz="2000"/>
+              <a:defRPr sz="1200"/>
             </a:lvl1pPr>
           </a:lstStyle>
           <a:p>
@@ -6143,6 +6180,12 @@
               <a:t>Icon 6</a:t>
             </a:r>
           </a:p>
+          <a:p>
+            <a:r>
+              <a:rPr lang="en-US" dirty="0"/>
+              <a:t>24x24px</a:t>
+            </a:r>
+          </a:p>
         </p:txBody>
       </p:sp>
       <p:sp>
@@ -6175,7 +6218,7 @@
           <a:lstStyle>
             <a:lvl1pPr marL="0" indent="0">
               <a:buNone/>
-              <a:defRPr/>
+              <a:defRPr sz="2000"/>
             </a:lvl1pPr>
           </a:lstStyle>
           <a:p>
@@ -6352,7 +6395,7 @@
           <a:lstStyle>
             <a:lvl1pPr marL="0" indent="0">
               <a:buNone/>
-              <a:defRPr/>
+              <a:defRPr sz="2000"/>
             </a:lvl1pPr>
           </a:lstStyle>
           <a:p>
@@ -6442,7 +6485,7 @@
           <a:lstStyle>
             <a:lvl1pPr marL="0" indent="0">
               <a:buNone/>
-              <a:defRPr/>
+              <a:defRPr sz="2000"/>
             </a:lvl1pPr>
           </a:lstStyle>
           <a:p>
@@ -6545,7 +6588,7 @@
           <a:lstStyle>
             <a:lvl1pPr marL="0" indent="0">
               <a:buNone/>
-              <a:defRPr/>
+              <a:defRPr sz="2000"/>
             </a:lvl1pPr>
           </a:lstStyle>
           <a:p>
@@ -6648,7 +6691,7 @@
           <a:lstStyle>
             <a:lvl1pPr marL="0" indent="0">
               <a:buNone/>
-              <a:defRPr/>
+              <a:defRPr sz="2000"/>
             </a:lvl1pPr>
           </a:lstStyle>
           <a:p>
@@ -8096,12 +8139,14 @@
 </file>
 
 <file path=customXml/item1.xml><?xml version="1.0" encoding="utf-8"?>
-<?mso-contentType ?>
-<FormTemplates xmlns="http://schemas.microsoft.com/sharepoint/v3/contenttype/forms">
-  <Display>DocumentLibraryForm</Display>
-  <Edit>DocumentLibraryForm</Edit>
-  <New>DocumentLibraryForm</New>
-</FormTemplates>
+<p:properties xmlns:p="http://schemas.microsoft.com/office/2006/metadata/properties" xmlns:xsi="http://www.w3.org/2001/XMLSchema-instance" xmlns:pc="http://schemas.microsoft.com/office/infopath/2007/PartnerControls">
+  <documentManagement>
+    <TaxCatchAll xmlns="2bdccfd7-ed75-47c4-ae3e-45ba8291135b" xsi:nil="true"/>
+    <lcf76f155ced4ddcb4097134ff3c332f xmlns="bdfda862-7558-4f4e-99f8-648970d7935e">
+      <Terms xmlns="http://schemas.microsoft.com/office/infopath/2007/PartnerControls"/>
+    </lcf76f155ced4ddcb4097134ff3c332f>
+  </documentManagement>
+</p:properties>
 </file>
 
 <file path=customXml/item2.xml><?xml version="1.0" encoding="utf-8"?>
@@ -8312,20 +8357,27 @@
 </file>
 
 <file path=customXml/item3.xml><?xml version="1.0" encoding="utf-8"?>
-<p:properties xmlns:p="http://schemas.microsoft.com/office/2006/metadata/properties" xmlns:xsi="http://www.w3.org/2001/XMLSchema-instance" xmlns:pc="http://schemas.microsoft.com/office/infopath/2007/PartnerControls">
-  <documentManagement>
-    <TaxCatchAll xmlns="2bdccfd7-ed75-47c4-ae3e-45ba8291135b" xsi:nil="true"/>
-    <lcf76f155ced4ddcb4097134ff3c332f xmlns="bdfda862-7558-4f4e-99f8-648970d7935e">
-      <Terms xmlns="http://schemas.microsoft.com/office/infopath/2007/PartnerControls"/>
-    </lcf76f155ced4ddcb4097134ff3c332f>
-  </documentManagement>
-</p:properties>
+<?mso-contentType ?>
+<FormTemplates xmlns="http://schemas.microsoft.com/sharepoint/v3/contenttype/forms">
+  <Display>DocumentLibraryForm</Display>
+  <Edit>DocumentLibraryForm</Edit>
+  <New>DocumentLibraryForm</New>
+</FormTemplates>
 </file>
 
 <file path=customXml/itemProps1.xml><?xml version="1.0" encoding="utf-8"?>
-<ds:datastoreItem xmlns:ds="http://schemas.openxmlformats.org/officeDocument/2006/customXml" ds:itemID="{C2B4E4C2-7A23-4EC8-AE63-F75F63DE72BE}">
+<ds:datastoreItem xmlns:ds="http://schemas.openxmlformats.org/officeDocument/2006/customXml" ds:itemID="{E18F5EE7-65DF-41C5-963C-25B6B377F939}">
   <ds:schemaRefs>
-    <ds:schemaRef ds:uri="http://schemas.microsoft.com/sharepoint/v3/contenttype/forms"/>
+    <ds:schemaRef ds:uri="http://purl.org/dc/terms/"/>
+    <ds:schemaRef ds:uri="http://www.w3.org/XML/1998/namespace"/>
+    <ds:schemaRef ds:uri="http://schemas.microsoft.com/office/2006/documentManagement/types"/>
+    <ds:schemaRef ds:uri="bdfda862-7558-4f4e-99f8-648970d7935e"/>
+    <ds:schemaRef ds:uri="http://purl.org/dc/elements/1.1/"/>
+    <ds:schemaRef ds:uri="http://schemas.microsoft.com/office/2006/metadata/properties"/>
+    <ds:schemaRef ds:uri="http://schemas.microsoft.com/office/infopath/2007/PartnerControls"/>
+    <ds:schemaRef ds:uri="http://schemas.openxmlformats.org/package/2006/metadata/core-properties"/>
+    <ds:schemaRef ds:uri="2bdccfd7-ed75-47c4-ae3e-45ba8291135b"/>
+    <ds:schemaRef ds:uri="http://purl.org/dc/dcmitype/"/>
   </ds:schemaRefs>
 </ds:datastoreItem>
 </file>
@@ -8350,18 +8402,9 @@
 </file>
 
 <file path=customXml/itemProps3.xml><?xml version="1.0" encoding="utf-8"?>
-<ds:datastoreItem xmlns:ds="http://schemas.openxmlformats.org/officeDocument/2006/customXml" ds:itemID="{E18F5EE7-65DF-41C5-963C-25B6B377F939}">
+<ds:datastoreItem xmlns:ds="http://schemas.openxmlformats.org/officeDocument/2006/customXml" ds:itemID="{C2B4E4C2-7A23-4EC8-AE63-F75F63DE72BE}">
   <ds:schemaRefs>
-    <ds:schemaRef ds:uri="2bdccfd7-ed75-47c4-ae3e-45ba8291135b"/>
-    <ds:schemaRef ds:uri="http://schemas.microsoft.com/office/infopath/2007/PartnerControls"/>
-    <ds:schemaRef ds:uri="http://purl.org/dc/dcmitype/"/>
-    <ds:schemaRef ds:uri="http://schemas.microsoft.com/office/2006/metadata/properties"/>
-    <ds:schemaRef ds:uri="http://purl.org/dc/terms/"/>
-    <ds:schemaRef ds:uri="http://schemas.microsoft.com/office/2006/documentManagement/types"/>
-    <ds:schemaRef ds:uri="http://purl.org/dc/elements/1.1/"/>
-    <ds:schemaRef ds:uri="http://schemas.openxmlformats.org/package/2006/metadata/core-properties"/>
-    <ds:schemaRef ds:uri="bdfda862-7558-4f4e-99f8-648970d7935e"/>
-    <ds:schemaRef ds:uri="http://www.w3.org/XML/1998/namespace"/>
+    <ds:schemaRef ds:uri="http://schemas.microsoft.com/sharepoint/v3/contenttype/forms"/>
   </ds:schemaRefs>
 </ds:datastoreItem>
 </file>
</xml_diff>

<commit_message>
🤖 Update frontend configuration in next.config.ts for environment variables, security headers, image optimization, and performance enhancements. Add new dependencies in package.json for Supabase and Zod. Revise README.md to include detailed environment setup instructions and project structure.
</commit_message>
<xml_diff>
--- a/ekona_slides_template_new.pptx
+++ b/ekona_slides_template_new.pptx
@@ -121,7 +121,7 @@
 <file path=ppt/revisionInfo.xml><?xml version="1.0" encoding="utf-8"?>
 <p1510:revInfo xmlns:a="http://schemas.openxmlformats.org/drawingml/2006/main" xmlns:r="http://schemas.openxmlformats.org/officeDocument/2006/relationships" xmlns:p1510="http://schemas.microsoft.com/office/powerpoint/2015/10/main">
   <p1510:revLst>
-    <p1510:client id="{651B6F30-EC96-2340-AD4B-07A6B9855D0C}" v="174" dt="2025-07-20T15:51:34.838"/>
+    <p1510:client id="{651B6F30-EC96-2340-AD4B-07A6B9855D0C}" v="209" dt="2025-07-21T08:11:00.613"/>
   </p1510:revLst>
 </p1510:revInfo>
 </file>
@@ -131,7 +131,7 @@
   <pc:docChgLst>
     <pc:chgData name="Sam Khalil" userId="82cd1ec2-6208-465b-9d4d-40ce8f0cbf96" providerId="ADAL" clId="{651B6F30-EC96-2340-AD4B-07A6B9855D0C}"/>
     <pc:docChg chg="undo custSel addSld delSld modSld modMainMaster">
-      <pc:chgData name="Sam Khalil" userId="82cd1ec2-6208-465b-9d4d-40ce8f0cbf96" providerId="ADAL" clId="{651B6F30-EC96-2340-AD4B-07A6B9855D0C}" dt="2025-07-20T15:51:45.829" v="1447" actId="2696"/>
+      <pc:chgData name="Sam Khalil" userId="82cd1ec2-6208-465b-9d4d-40ce8f0cbf96" providerId="ADAL" clId="{651B6F30-EC96-2340-AD4B-07A6B9855D0C}" dt="2025-07-21T08:11:04.944" v="2496" actId="29295"/>
       <pc:docMkLst>
         <pc:docMk/>
       </pc:docMkLst>
@@ -192,7 +192,7 @@
         </pc:sldMkLst>
       </pc:sldChg>
       <pc:sldMasterChg chg="addSldLayout delSldLayout modSldLayout sldLayoutOrd">
-        <pc:chgData name="Sam Khalil" userId="82cd1ec2-6208-465b-9d4d-40ce8f0cbf96" providerId="ADAL" clId="{651B6F30-EC96-2340-AD4B-07A6B9855D0C}" dt="2025-07-20T15:51:34.838" v="1445" actId="404"/>
+        <pc:chgData name="Sam Khalil" userId="82cd1ec2-6208-465b-9d4d-40ce8f0cbf96" providerId="ADAL" clId="{651B6F30-EC96-2340-AD4B-07A6B9855D0C}" dt="2025-07-21T08:11:04.944" v="2496" actId="29295"/>
         <pc:sldMasterMkLst>
           <pc:docMk/>
           <pc:sldMasterMk cId="2940896467" sldId="2147483648"/>
@@ -206,7 +206,7 @@
           </pc:sldLayoutMkLst>
         </pc:sldLayoutChg>
         <pc:sldLayoutChg chg="addSp delSp modSp mod">
-          <pc:chgData name="Sam Khalil" userId="82cd1ec2-6208-465b-9d4d-40ce8f0cbf96" providerId="ADAL" clId="{651B6F30-EC96-2340-AD4B-07A6B9855D0C}" dt="2025-07-17T16:10:12.018" v="1195" actId="20577"/>
+          <pc:chgData name="Sam Khalil" userId="82cd1ec2-6208-465b-9d4d-40ce8f0cbf96" providerId="ADAL" clId="{651B6F30-EC96-2340-AD4B-07A6B9855D0C}" dt="2025-07-21T08:06:20.088" v="2162" actId="20577"/>
           <pc:sldLayoutMkLst>
             <pc:docMk/>
             <pc:sldMasterMk cId="2940896467" sldId="2147483648"/>
@@ -222,7 +222,7 @@
             </ac:spMkLst>
           </pc:spChg>
           <pc:spChg chg="mod">
-            <ac:chgData name="Sam Khalil" userId="82cd1ec2-6208-465b-9d4d-40ce8f0cbf96" providerId="ADAL" clId="{651B6F30-EC96-2340-AD4B-07A6B9855D0C}" dt="2025-07-17T11:10:33.408" v="966" actId="20577"/>
+            <ac:chgData name="Sam Khalil" userId="82cd1ec2-6208-465b-9d4d-40ce8f0cbf96" providerId="ADAL" clId="{651B6F30-EC96-2340-AD4B-07A6B9855D0C}" dt="2025-07-21T08:06:13.638" v="2143" actId="20577"/>
             <ac:spMkLst>
               <pc:docMk/>
               <pc:sldMasterMk cId="2940896467" sldId="2147483648"/>
@@ -231,12 +231,30 @@
             </ac:spMkLst>
           </pc:spChg>
           <pc:spChg chg="mod">
-            <ac:chgData name="Sam Khalil" userId="82cd1ec2-6208-465b-9d4d-40ce8f0cbf96" providerId="ADAL" clId="{651B6F30-EC96-2340-AD4B-07A6B9855D0C}" dt="2025-07-17T16:10:12.018" v="1195" actId="20577"/>
+            <ac:chgData name="Sam Khalil" userId="82cd1ec2-6208-465b-9d4d-40ce8f0cbf96" providerId="ADAL" clId="{651B6F30-EC96-2340-AD4B-07A6B9855D0C}" dt="2025-07-21T08:06:20.088" v="2162" actId="20577"/>
             <ac:spMkLst>
               <pc:docMk/>
               <pc:sldMasterMk cId="2940896467" sldId="2147483648"/>
               <pc:sldLayoutMk cId="3074954578" sldId="2147483650"/>
               <ac:spMk id="4" creationId="{097092C2-9408-32E2-1B17-858560948F97}"/>
+            </ac:spMkLst>
+          </pc:spChg>
+          <pc:spChg chg="add mod">
+            <ac:chgData name="Sam Khalil" userId="82cd1ec2-6208-465b-9d4d-40ce8f0cbf96" providerId="ADAL" clId="{651B6F30-EC96-2340-AD4B-07A6B9855D0C}" dt="2025-07-21T08:05:28.875" v="2112" actId="167"/>
+            <ac:spMkLst>
+              <pc:docMk/>
+              <pc:sldMasterMk cId="2940896467" sldId="2147483648"/>
+              <pc:sldLayoutMk cId="3074954578" sldId="2147483650"/>
+              <ac:spMk id="5" creationId="{4286C11B-CD57-AE94-2379-3F6FBE23504C}"/>
+            </ac:spMkLst>
+          </pc:spChg>
+          <pc:spChg chg="add mod">
+            <ac:chgData name="Sam Khalil" userId="82cd1ec2-6208-465b-9d4d-40ce8f0cbf96" providerId="ADAL" clId="{651B6F30-EC96-2340-AD4B-07A6B9855D0C}" dt="2025-07-21T08:05:52.092" v="2121" actId="14100"/>
+            <ac:spMkLst>
+              <pc:docMk/>
+              <pc:sldMasterMk cId="2940896467" sldId="2147483648"/>
+              <pc:sldLayoutMk cId="3074954578" sldId="2147483650"/>
+              <ac:spMk id="6" creationId="{8755C1BE-9560-A50A-74BD-E0FFF7F5B69F}"/>
             </ac:spMkLst>
           </pc:spChg>
         </pc:sldLayoutChg>
@@ -266,8 +284,8 @@
             </ac:spMkLst>
           </pc:spChg>
         </pc:sldLayoutChg>
-        <pc:sldLayoutChg chg="modSp mod">
-          <pc:chgData name="Sam Khalil" userId="82cd1ec2-6208-465b-9d4d-40ce8f0cbf96" providerId="ADAL" clId="{651B6F30-EC96-2340-AD4B-07A6B9855D0C}" dt="2025-07-17T09:54:02.244" v="668"/>
+        <pc:sldLayoutChg chg="addSp modSp mod">
+          <pc:chgData name="Sam Khalil" userId="82cd1ec2-6208-465b-9d4d-40ce8f0cbf96" providerId="ADAL" clId="{651B6F30-EC96-2340-AD4B-07A6B9855D0C}" dt="2025-07-21T08:05:08.740" v="2106" actId="1076"/>
           <pc:sldLayoutMkLst>
             <pc:docMk/>
             <pc:sldMasterMk cId="2940896467" sldId="2147483648"/>
@@ -283,12 +301,21 @@
             </ac:spMkLst>
           </pc:spChg>
           <pc:spChg chg="mod">
-            <ac:chgData name="Sam Khalil" userId="82cd1ec2-6208-465b-9d4d-40ce8f0cbf96" providerId="ADAL" clId="{651B6F30-EC96-2340-AD4B-07A6B9855D0C}" dt="2025-07-17T09:53:47.272" v="622" actId="20577"/>
+            <ac:chgData name="Sam Khalil" userId="82cd1ec2-6208-465b-9d4d-40ce8f0cbf96" providerId="ADAL" clId="{651B6F30-EC96-2340-AD4B-07A6B9855D0C}" dt="2025-07-21T08:05:08.740" v="2106" actId="1076"/>
             <ac:spMkLst>
               <pc:docMk/>
               <pc:sldMasterMk cId="2940896467" sldId="2147483648"/>
               <pc:sldLayoutMk cId="3100185760" sldId="2147483667"/>
               <ac:spMk id="3" creationId="{8A6FC6F2-80B4-49A7-9448-33FE2DF0E967}"/>
+            </ac:spMkLst>
+          </pc:spChg>
+          <pc:spChg chg="add mod">
+            <ac:chgData name="Sam Khalil" userId="82cd1ec2-6208-465b-9d4d-40ce8f0cbf96" providerId="ADAL" clId="{651B6F30-EC96-2340-AD4B-07A6B9855D0C}" dt="2025-07-21T08:05:01.697" v="2104" actId="14100"/>
+            <ac:spMkLst>
+              <pc:docMk/>
+              <pc:sldMasterMk cId="2940896467" sldId="2147483648"/>
+              <pc:sldLayoutMk cId="3100185760" sldId="2147483667"/>
+              <ac:spMk id="4" creationId="{F8567C99-F3EA-939B-081F-B8C4B329CCCE}"/>
             </ac:spMkLst>
           </pc:spChg>
         </pc:sldLayoutChg>
@@ -370,21 +397,336 @@
             </ac:spMkLst>
           </pc:spChg>
         </pc:sldLayoutChg>
-        <pc:sldLayoutChg chg="ord">
-          <pc:chgData name="Sam Khalil" userId="82cd1ec2-6208-465b-9d4d-40ce8f0cbf96" providerId="ADAL" clId="{651B6F30-EC96-2340-AD4B-07A6B9855D0C}" dt="2025-07-17T21:10:19.682" v="1234" actId="20578"/>
+        <pc:sldLayoutChg chg="addSp delSp modSp mod ord">
+          <pc:chgData name="Sam Khalil" userId="82cd1ec2-6208-465b-9d4d-40ce8f0cbf96" providerId="ADAL" clId="{651B6F30-EC96-2340-AD4B-07A6B9855D0C}" dt="2025-07-21T08:09:17.134" v="2468" actId="207"/>
           <pc:sldLayoutMkLst>
             <pc:docMk/>
             <pc:sldMasterMk cId="2940896467" sldId="2147483648"/>
             <pc:sldLayoutMk cId="3393990456" sldId="2147483672"/>
           </pc:sldLayoutMkLst>
+          <pc:spChg chg="del mod">
+            <ac:chgData name="Sam Khalil" userId="82cd1ec2-6208-465b-9d4d-40ce8f0cbf96" providerId="ADAL" clId="{651B6F30-EC96-2340-AD4B-07A6B9855D0C}" dt="2025-07-21T08:09:05.796" v="2416" actId="478"/>
+            <ac:spMkLst>
+              <pc:docMk/>
+              <pc:sldMasterMk cId="2940896467" sldId="2147483648"/>
+              <pc:sldLayoutMk cId="3393990456" sldId="2147483672"/>
+              <ac:spMk id="2" creationId="{6372FCEB-FEC1-18CC-54A6-09739A289B26}"/>
+            </ac:spMkLst>
+          </pc:spChg>
+          <pc:spChg chg="mod">
+            <ac:chgData name="Sam Khalil" userId="82cd1ec2-6208-465b-9d4d-40ce8f0cbf96" providerId="ADAL" clId="{651B6F30-EC96-2340-AD4B-07A6B9855D0C}" dt="2025-07-21T08:08:36.529" v="2240" actId="1076"/>
+            <ac:spMkLst>
+              <pc:docMk/>
+              <pc:sldMasterMk cId="2940896467" sldId="2147483648"/>
+              <pc:sldLayoutMk cId="3393990456" sldId="2147483672"/>
+              <ac:spMk id="12" creationId="{EFC724FB-B7D0-20F8-923C-E4CD8D9194CA}"/>
+            </ac:spMkLst>
+          </pc:spChg>
+          <pc:spChg chg="add mod">
+            <ac:chgData name="Sam Khalil" userId="82cd1ec2-6208-465b-9d4d-40ce8f0cbf96" providerId="ADAL" clId="{651B6F30-EC96-2340-AD4B-07A6B9855D0C}" dt="2025-07-21T08:09:10.569" v="2417" actId="167"/>
+            <ac:spMkLst>
+              <pc:docMk/>
+              <pc:sldMasterMk cId="2940896467" sldId="2147483648"/>
+              <pc:sldLayoutMk cId="3393990456" sldId="2147483672"/>
+              <ac:spMk id="13" creationId="{0617AC1D-26CB-713E-4508-B01954EF86DF}"/>
+            </ac:spMkLst>
+          </pc:spChg>
+          <pc:spChg chg="add mod">
+            <ac:chgData name="Sam Khalil" userId="82cd1ec2-6208-465b-9d4d-40ce8f0cbf96" providerId="ADAL" clId="{651B6F30-EC96-2340-AD4B-07A6B9855D0C}" dt="2025-07-21T08:09:17.134" v="2468" actId="207"/>
+            <ac:spMkLst>
+              <pc:docMk/>
+              <pc:sldMasterMk cId="2940896467" sldId="2147483648"/>
+              <pc:sldLayoutMk cId="3393990456" sldId="2147483672"/>
+              <ac:spMk id="18" creationId="{12CC8E3F-B2A1-F8CA-0B79-3E642C812BBA}"/>
+            </ac:spMkLst>
+          </pc:spChg>
+          <pc:picChg chg="add del mod">
+            <ac:chgData name="Sam Khalil" userId="82cd1ec2-6208-465b-9d4d-40ce8f0cbf96" providerId="ADAL" clId="{651B6F30-EC96-2340-AD4B-07A6B9855D0C}" dt="2025-07-21T08:08:52.775" v="2246" actId="167"/>
+            <ac:picMkLst>
+              <pc:docMk/>
+              <pc:sldMasterMk cId="2940896467" sldId="2147483648"/>
+              <pc:sldLayoutMk cId="3393990456" sldId="2147483672"/>
+              <ac:picMk id="4" creationId="{E92912F8-6299-B5F5-C99C-1BF14D2F0334}"/>
+            </ac:picMkLst>
+          </pc:picChg>
+          <pc:picChg chg="mod">
+            <ac:chgData name="Sam Khalil" userId="82cd1ec2-6208-465b-9d4d-40ce8f0cbf96" providerId="ADAL" clId="{651B6F30-EC96-2340-AD4B-07A6B9855D0C}" dt="2025-07-21T08:08:36.529" v="2240" actId="1076"/>
+            <ac:picMkLst>
+              <pc:docMk/>
+              <pc:sldMasterMk cId="2940896467" sldId="2147483648"/>
+              <pc:sldLayoutMk cId="3393990456" sldId="2147483672"/>
+              <ac:picMk id="14" creationId="{981C10B9-9817-EB54-2841-E3C1D957E143}"/>
+            </ac:picMkLst>
+          </pc:picChg>
         </pc:sldLayoutChg>
-        <pc:sldLayoutChg chg="ord">
-          <pc:chgData name="Sam Khalil" userId="82cd1ec2-6208-465b-9d4d-40ce8f0cbf96" providerId="ADAL" clId="{651B6F30-EC96-2340-AD4B-07A6B9855D0C}" dt="2025-07-17T21:10:32.513" v="1239" actId="20578"/>
+        <pc:sldLayoutChg chg="addSp modSp mod ord">
+          <pc:chgData name="Sam Khalil" userId="82cd1ec2-6208-465b-9d4d-40ce8f0cbf96" providerId="ADAL" clId="{651B6F30-EC96-2340-AD4B-07A6B9855D0C}" dt="2025-07-21T08:11:04.944" v="2496" actId="29295"/>
           <pc:sldLayoutMkLst>
             <pc:docMk/>
             <pc:sldMasterMk cId="2940896467" sldId="2147483648"/>
             <pc:sldLayoutMk cId="2955669845" sldId="2147483673"/>
           </pc:sldLayoutMkLst>
+          <pc:spChg chg="add mod">
+            <ac:chgData name="Sam Khalil" userId="82cd1ec2-6208-465b-9d4d-40ce8f0cbf96" providerId="ADAL" clId="{651B6F30-EC96-2340-AD4B-07A6B9855D0C}" dt="2025-07-21T08:10:30.455" v="2490" actId="14100"/>
+            <ac:spMkLst>
+              <pc:docMk/>
+              <pc:sldMasterMk cId="2940896467" sldId="2147483648"/>
+              <pc:sldLayoutMk cId="2955669845" sldId="2147483673"/>
+              <ac:spMk id="2" creationId="{E4D1961F-E19F-CE3C-40E8-F910B0EE5077}"/>
+            </ac:spMkLst>
+          </pc:spChg>
+          <pc:spChg chg="mod">
+            <ac:chgData name="Sam Khalil" userId="82cd1ec2-6208-465b-9d4d-40ce8f0cbf96" providerId="ADAL" clId="{651B6F30-EC96-2340-AD4B-07A6B9855D0C}" dt="2025-07-21T08:09:45.759" v="2479" actId="1076"/>
+            <ac:spMkLst>
+              <pc:docMk/>
+              <pc:sldMasterMk cId="2940896467" sldId="2147483648"/>
+              <pc:sldLayoutMk cId="2955669845" sldId="2147483673"/>
+              <ac:spMk id="13" creationId="{49D92DF9-4B98-A01C-A7B1-352C8B146E6F}"/>
+            </ac:spMkLst>
+          </pc:spChg>
+          <pc:spChg chg="mod">
+            <ac:chgData name="Sam Khalil" userId="82cd1ec2-6208-465b-9d4d-40ce8f0cbf96" providerId="ADAL" clId="{651B6F30-EC96-2340-AD4B-07A6B9855D0C}" dt="2025-07-21T08:10:15.058" v="2487" actId="1076"/>
+            <ac:spMkLst>
+              <pc:docMk/>
+              <pc:sldMasterMk cId="2940896467" sldId="2147483648"/>
+              <pc:sldLayoutMk cId="2955669845" sldId="2147483673"/>
+              <ac:spMk id="18" creationId="{3D76CCEB-1818-1860-AAF8-7A1CA815CF36}"/>
+            </ac:spMkLst>
+          </pc:spChg>
+          <pc:spChg chg="mod">
+            <ac:chgData name="Sam Khalil" userId="82cd1ec2-6208-465b-9d4d-40ce8f0cbf96" providerId="ADAL" clId="{651B6F30-EC96-2340-AD4B-07A6B9855D0C}" dt="2025-07-21T08:10:15.058" v="2487" actId="1076"/>
+            <ac:spMkLst>
+              <pc:docMk/>
+              <pc:sldMasterMk cId="2940896467" sldId="2147483648"/>
+              <pc:sldLayoutMk cId="2955669845" sldId="2147483673"/>
+              <ac:spMk id="19" creationId="{0BCF71B3-5882-0ACA-8F0C-E597CF37495F}"/>
+            </ac:spMkLst>
+          </pc:spChg>
+          <pc:spChg chg="mod">
+            <ac:chgData name="Sam Khalil" userId="82cd1ec2-6208-465b-9d4d-40ce8f0cbf96" providerId="ADAL" clId="{651B6F30-EC96-2340-AD4B-07A6B9855D0C}" dt="2025-07-21T08:10:15.058" v="2487" actId="1076"/>
+            <ac:spMkLst>
+              <pc:docMk/>
+              <pc:sldMasterMk cId="2940896467" sldId="2147483648"/>
+              <pc:sldLayoutMk cId="2955669845" sldId="2147483673"/>
+              <ac:spMk id="20" creationId="{130FC3E6-58A5-9CD0-8116-16B821E0D0D2}"/>
+            </ac:spMkLst>
+          </pc:spChg>
+          <pc:spChg chg="mod">
+            <ac:chgData name="Sam Khalil" userId="82cd1ec2-6208-465b-9d4d-40ce8f0cbf96" providerId="ADAL" clId="{651B6F30-EC96-2340-AD4B-07A6B9855D0C}" dt="2025-07-21T08:10:15.058" v="2487" actId="1076"/>
+            <ac:spMkLst>
+              <pc:docMk/>
+              <pc:sldMasterMk cId="2940896467" sldId="2147483648"/>
+              <pc:sldLayoutMk cId="2955669845" sldId="2147483673"/>
+              <ac:spMk id="21" creationId="{D7ABC5C1-7F24-0E88-1FBE-F391A1D6443E}"/>
+            </ac:spMkLst>
+          </pc:spChg>
+          <pc:spChg chg="mod">
+            <ac:chgData name="Sam Khalil" userId="82cd1ec2-6208-465b-9d4d-40ce8f0cbf96" providerId="ADAL" clId="{651B6F30-EC96-2340-AD4B-07A6B9855D0C}" dt="2025-07-21T08:10:15.058" v="2487" actId="1076"/>
+            <ac:spMkLst>
+              <pc:docMk/>
+              <pc:sldMasterMk cId="2940896467" sldId="2147483648"/>
+              <pc:sldLayoutMk cId="2955669845" sldId="2147483673"/>
+              <ac:spMk id="22" creationId="{45583127-2AD4-6B03-1813-71A4E76C8329}"/>
+            </ac:spMkLst>
+          </pc:spChg>
+          <pc:spChg chg="mod">
+            <ac:chgData name="Sam Khalil" userId="82cd1ec2-6208-465b-9d4d-40ce8f0cbf96" providerId="ADAL" clId="{651B6F30-EC96-2340-AD4B-07A6B9855D0C}" dt="2025-07-21T08:10:15.058" v="2487" actId="1076"/>
+            <ac:spMkLst>
+              <pc:docMk/>
+              <pc:sldMasterMk cId="2940896467" sldId="2147483648"/>
+              <pc:sldLayoutMk cId="2955669845" sldId="2147483673"/>
+              <ac:spMk id="23" creationId="{43C77D6C-536D-288A-9A07-AE2C0979AAAF}"/>
+            </ac:spMkLst>
+          </pc:spChg>
+          <pc:spChg chg="mod">
+            <ac:chgData name="Sam Khalil" userId="82cd1ec2-6208-465b-9d4d-40ce8f0cbf96" providerId="ADAL" clId="{651B6F30-EC96-2340-AD4B-07A6B9855D0C}" dt="2025-07-21T08:10:21.949" v="2488" actId="1076"/>
+            <ac:spMkLst>
+              <pc:docMk/>
+              <pc:sldMasterMk cId="2940896467" sldId="2147483648"/>
+              <pc:sldLayoutMk cId="2955669845" sldId="2147483673"/>
+              <ac:spMk id="24" creationId="{74DF3F49-B1AD-72D3-895F-DCC4FB73D793}"/>
+            </ac:spMkLst>
+          </pc:spChg>
+          <pc:spChg chg="mod">
+            <ac:chgData name="Sam Khalil" userId="82cd1ec2-6208-465b-9d4d-40ce8f0cbf96" providerId="ADAL" clId="{651B6F30-EC96-2340-AD4B-07A6B9855D0C}" dt="2025-07-21T08:10:21.949" v="2488" actId="1076"/>
+            <ac:spMkLst>
+              <pc:docMk/>
+              <pc:sldMasterMk cId="2940896467" sldId="2147483648"/>
+              <pc:sldLayoutMk cId="2955669845" sldId="2147483673"/>
+              <ac:spMk id="25" creationId="{FE001DDF-FBDF-E249-6F7B-99181D69AC28}"/>
+            </ac:spMkLst>
+          </pc:spChg>
+          <pc:spChg chg="mod">
+            <ac:chgData name="Sam Khalil" userId="82cd1ec2-6208-465b-9d4d-40ce8f0cbf96" providerId="ADAL" clId="{651B6F30-EC96-2340-AD4B-07A6B9855D0C}" dt="2025-07-21T08:10:21.949" v="2488" actId="1076"/>
+            <ac:spMkLst>
+              <pc:docMk/>
+              <pc:sldMasterMk cId="2940896467" sldId="2147483648"/>
+              <pc:sldLayoutMk cId="2955669845" sldId="2147483673"/>
+              <ac:spMk id="26" creationId="{86912470-7B43-22A2-00D0-17B9520EA500}"/>
+            </ac:spMkLst>
+          </pc:spChg>
+          <pc:spChg chg="mod">
+            <ac:chgData name="Sam Khalil" userId="82cd1ec2-6208-465b-9d4d-40ce8f0cbf96" providerId="ADAL" clId="{651B6F30-EC96-2340-AD4B-07A6B9855D0C}" dt="2025-07-21T08:10:21.949" v="2488" actId="1076"/>
+            <ac:spMkLst>
+              <pc:docMk/>
+              <pc:sldMasterMk cId="2940896467" sldId="2147483648"/>
+              <pc:sldLayoutMk cId="2955669845" sldId="2147483673"/>
+              <ac:spMk id="27" creationId="{DD4101A6-1B1B-4243-E876-B17CEA780A39}"/>
+            </ac:spMkLst>
+          </pc:spChg>
+          <pc:spChg chg="mod">
+            <ac:chgData name="Sam Khalil" userId="82cd1ec2-6208-465b-9d4d-40ce8f0cbf96" providerId="ADAL" clId="{651B6F30-EC96-2340-AD4B-07A6B9855D0C}" dt="2025-07-21T08:10:21.949" v="2488" actId="1076"/>
+            <ac:spMkLst>
+              <pc:docMk/>
+              <pc:sldMasterMk cId="2940896467" sldId="2147483648"/>
+              <pc:sldLayoutMk cId="2955669845" sldId="2147483673"/>
+              <ac:spMk id="43" creationId="{DE242BD1-E8F0-2635-BF7D-9643DA4A8844}"/>
+            </ac:spMkLst>
+          </pc:spChg>
+          <pc:picChg chg="mod">
+            <ac:chgData name="Sam Khalil" userId="82cd1ec2-6208-465b-9d4d-40ce8f0cbf96" providerId="ADAL" clId="{651B6F30-EC96-2340-AD4B-07A6B9855D0C}" dt="2025-07-21T08:10:15.058" v="2487" actId="1076"/>
+            <ac:picMkLst>
+              <pc:docMk/>
+              <pc:sldMasterMk cId="2940896467" sldId="2147483648"/>
+              <pc:sldLayoutMk cId="2955669845" sldId="2147483673"/>
+              <ac:picMk id="28" creationId="{BBAD7591-F744-4098-E06F-543F90015B7A}"/>
+            </ac:picMkLst>
+          </pc:picChg>
+          <pc:picChg chg="mod">
+            <ac:chgData name="Sam Khalil" userId="82cd1ec2-6208-465b-9d4d-40ce8f0cbf96" providerId="ADAL" clId="{651B6F30-EC96-2340-AD4B-07A6B9855D0C}" dt="2025-07-21T08:10:21.949" v="2488" actId="1076"/>
+            <ac:picMkLst>
+              <pc:docMk/>
+              <pc:sldMasterMk cId="2940896467" sldId="2147483648"/>
+              <pc:sldLayoutMk cId="2955669845" sldId="2147483673"/>
+              <ac:picMk id="29" creationId="{95D0FA04-3AB7-EAAA-0E84-5E95CEFF0D4F}"/>
+            </ac:picMkLst>
+          </pc:picChg>
+          <pc:picChg chg="mod">
+            <ac:chgData name="Sam Khalil" userId="82cd1ec2-6208-465b-9d4d-40ce8f0cbf96" providerId="ADAL" clId="{651B6F30-EC96-2340-AD4B-07A6B9855D0C}" dt="2025-07-21T08:10:15.058" v="2487" actId="1076"/>
+            <ac:picMkLst>
+              <pc:docMk/>
+              <pc:sldMasterMk cId="2940896467" sldId="2147483648"/>
+              <pc:sldLayoutMk cId="2955669845" sldId="2147483673"/>
+              <ac:picMk id="30" creationId="{D2732E4D-CDD3-0A02-898B-AAE31D61CD92}"/>
+            </ac:picMkLst>
+          </pc:picChg>
+          <pc:picChg chg="mod">
+            <ac:chgData name="Sam Khalil" userId="82cd1ec2-6208-465b-9d4d-40ce8f0cbf96" providerId="ADAL" clId="{651B6F30-EC96-2340-AD4B-07A6B9855D0C}" dt="2025-07-21T08:10:15.058" v="2487" actId="1076"/>
+            <ac:picMkLst>
+              <pc:docMk/>
+              <pc:sldMasterMk cId="2940896467" sldId="2147483648"/>
+              <pc:sldLayoutMk cId="2955669845" sldId="2147483673"/>
+              <ac:picMk id="31" creationId="{327537E7-188C-632A-88A4-0CDB609626B8}"/>
+            </ac:picMkLst>
+          </pc:picChg>
+          <pc:picChg chg="mod">
+            <ac:chgData name="Sam Khalil" userId="82cd1ec2-6208-465b-9d4d-40ce8f0cbf96" providerId="ADAL" clId="{651B6F30-EC96-2340-AD4B-07A6B9855D0C}" dt="2025-07-21T08:09:59.562" v="2484" actId="1076"/>
+            <ac:picMkLst>
+              <pc:docMk/>
+              <pc:sldMasterMk cId="2940896467" sldId="2147483648"/>
+              <pc:sldLayoutMk cId="2955669845" sldId="2147483673"/>
+              <ac:picMk id="33" creationId="{D4538602-E74E-0718-5FA7-047BC0C9B4DC}"/>
+            </ac:picMkLst>
+          </pc:picChg>
+          <pc:picChg chg="mod">
+            <ac:chgData name="Sam Khalil" userId="82cd1ec2-6208-465b-9d4d-40ce8f0cbf96" providerId="ADAL" clId="{651B6F30-EC96-2340-AD4B-07A6B9855D0C}" dt="2025-07-21T08:10:15.058" v="2487" actId="1076"/>
+            <ac:picMkLst>
+              <pc:docMk/>
+              <pc:sldMasterMk cId="2940896467" sldId="2147483648"/>
+              <pc:sldLayoutMk cId="2955669845" sldId="2147483673"/>
+              <ac:picMk id="34" creationId="{5E7BF02C-615A-3088-AF8E-15E632D47456}"/>
+            </ac:picMkLst>
+          </pc:picChg>
+          <pc:picChg chg="mod">
+            <ac:chgData name="Sam Khalil" userId="82cd1ec2-6208-465b-9d4d-40ce8f0cbf96" providerId="ADAL" clId="{651B6F30-EC96-2340-AD4B-07A6B9855D0C}" dt="2025-07-21T08:10:21.949" v="2488" actId="1076"/>
+            <ac:picMkLst>
+              <pc:docMk/>
+              <pc:sldMasterMk cId="2940896467" sldId="2147483648"/>
+              <pc:sldLayoutMk cId="2955669845" sldId="2147483673"/>
+              <ac:picMk id="35" creationId="{5AA8A8E1-06B7-4373-90E9-1E30C3724DEB}"/>
+            </ac:picMkLst>
+          </pc:picChg>
+          <pc:picChg chg="mod">
+            <ac:chgData name="Sam Khalil" userId="82cd1ec2-6208-465b-9d4d-40ce8f0cbf96" providerId="ADAL" clId="{651B6F30-EC96-2340-AD4B-07A6B9855D0C}" dt="2025-07-21T08:11:04.944" v="2496" actId="29295"/>
+            <ac:picMkLst>
+              <pc:docMk/>
+              <pc:sldMasterMk cId="2940896467" sldId="2147483648"/>
+              <pc:sldLayoutMk cId="2955669845" sldId="2147483673"/>
+              <ac:picMk id="37" creationId="{21C476F9-E6D3-0A4B-C426-8A1E5FB20E13}"/>
+            </ac:picMkLst>
+          </pc:picChg>
+          <pc:picChg chg="mod">
+            <ac:chgData name="Sam Khalil" userId="82cd1ec2-6208-465b-9d4d-40ce8f0cbf96" providerId="ADAL" clId="{651B6F30-EC96-2340-AD4B-07A6B9855D0C}" dt="2025-07-21T08:11:04.944" v="2496" actId="29295"/>
+            <ac:picMkLst>
+              <pc:docMk/>
+              <pc:sldMasterMk cId="2940896467" sldId="2147483648"/>
+              <pc:sldLayoutMk cId="2955669845" sldId="2147483673"/>
+              <ac:picMk id="38" creationId="{F2D5E519-A47C-7694-5CD1-E81E57C25B5D}"/>
+            </ac:picMkLst>
+          </pc:picChg>
+          <pc:picChg chg="mod">
+            <ac:chgData name="Sam Khalil" userId="82cd1ec2-6208-465b-9d4d-40ce8f0cbf96" providerId="ADAL" clId="{651B6F30-EC96-2340-AD4B-07A6B9855D0C}" dt="2025-07-21T08:11:04.944" v="2496" actId="29295"/>
+            <ac:picMkLst>
+              <pc:docMk/>
+              <pc:sldMasterMk cId="2940896467" sldId="2147483648"/>
+              <pc:sldLayoutMk cId="2955669845" sldId="2147483673"/>
+              <ac:picMk id="39" creationId="{72E483E8-247A-32FF-E55C-B3B693F060F8}"/>
+            </ac:picMkLst>
+          </pc:picChg>
+          <pc:picChg chg="mod">
+            <ac:chgData name="Sam Khalil" userId="82cd1ec2-6208-465b-9d4d-40ce8f0cbf96" providerId="ADAL" clId="{651B6F30-EC96-2340-AD4B-07A6B9855D0C}" dt="2025-07-21T08:11:04.944" v="2496" actId="29295"/>
+            <ac:picMkLst>
+              <pc:docMk/>
+              <pc:sldMasterMk cId="2940896467" sldId="2147483648"/>
+              <pc:sldLayoutMk cId="2955669845" sldId="2147483673"/>
+              <ac:picMk id="40" creationId="{76DB1012-F4EF-F66E-9015-3D60A0635AF3}"/>
+            </ac:picMkLst>
+          </pc:picChg>
+          <pc:picChg chg="mod">
+            <ac:chgData name="Sam Khalil" userId="82cd1ec2-6208-465b-9d4d-40ce8f0cbf96" providerId="ADAL" clId="{651B6F30-EC96-2340-AD4B-07A6B9855D0C}" dt="2025-07-21T08:11:04.944" v="2496" actId="29295"/>
+            <ac:picMkLst>
+              <pc:docMk/>
+              <pc:sldMasterMk cId="2940896467" sldId="2147483648"/>
+              <pc:sldLayoutMk cId="2955669845" sldId="2147483673"/>
+              <ac:picMk id="41" creationId="{AD420B4B-954A-D141-F1E8-0FE269447133}"/>
+            </ac:picMkLst>
+          </pc:picChg>
+          <pc:picChg chg="mod">
+            <ac:chgData name="Sam Khalil" userId="82cd1ec2-6208-465b-9d4d-40ce8f0cbf96" providerId="ADAL" clId="{651B6F30-EC96-2340-AD4B-07A6B9855D0C}" dt="2025-07-21T08:11:04.944" v="2496" actId="29295"/>
+            <ac:picMkLst>
+              <pc:docMk/>
+              <pc:sldMasterMk cId="2940896467" sldId="2147483648"/>
+              <pc:sldLayoutMk cId="2955669845" sldId="2147483673"/>
+              <ac:picMk id="42" creationId="{A3FE8608-9DB4-ACFD-20F0-E31C800B57D1}"/>
+            </ac:picMkLst>
+          </pc:picChg>
+          <pc:picChg chg="mod">
+            <ac:chgData name="Sam Khalil" userId="82cd1ec2-6208-465b-9d4d-40ce8f0cbf96" providerId="ADAL" clId="{651B6F30-EC96-2340-AD4B-07A6B9855D0C}" dt="2025-07-21T08:10:09.122" v="2486" actId="1076"/>
+            <ac:picMkLst>
+              <pc:docMk/>
+              <pc:sldMasterMk cId="2940896467" sldId="2147483648"/>
+              <pc:sldLayoutMk cId="2955669845" sldId="2147483673"/>
+              <ac:picMk id="44" creationId="{B215E11D-C506-B6AF-57D4-6EDD9DBD59BE}"/>
+            </ac:picMkLst>
+          </pc:picChg>
+          <pc:picChg chg="mod">
+            <ac:chgData name="Sam Khalil" userId="82cd1ec2-6208-465b-9d4d-40ce8f0cbf96" providerId="ADAL" clId="{651B6F30-EC96-2340-AD4B-07A6B9855D0C}" dt="2025-07-21T08:10:21.949" v="2488" actId="1076"/>
+            <ac:picMkLst>
+              <pc:docMk/>
+              <pc:sldMasterMk cId="2940896467" sldId="2147483648"/>
+              <pc:sldLayoutMk cId="2955669845" sldId="2147483673"/>
+              <ac:picMk id="45" creationId="{65D7D50D-033A-59ED-8EEA-390729267733}"/>
+            </ac:picMkLst>
+          </pc:picChg>
+          <pc:picChg chg="mod">
+            <ac:chgData name="Sam Khalil" userId="82cd1ec2-6208-465b-9d4d-40ce8f0cbf96" providerId="ADAL" clId="{651B6F30-EC96-2340-AD4B-07A6B9855D0C}" dt="2025-07-21T08:09:59.562" v="2484" actId="1076"/>
+            <ac:picMkLst>
+              <pc:docMk/>
+              <pc:sldMasterMk cId="2940896467" sldId="2147483648"/>
+              <pc:sldLayoutMk cId="2955669845" sldId="2147483673"/>
+              <ac:picMk id="46" creationId="{3AFCA702-B7A3-1F38-1616-7308C99E9BDE}"/>
+            </ac:picMkLst>
+          </pc:picChg>
         </pc:sldLayoutChg>
         <pc:sldLayoutChg chg="modSp add mod ord modTransition">
           <pc:chgData name="Sam Khalil" userId="82cd1ec2-6208-465b-9d4d-40ce8f0cbf96" providerId="ADAL" clId="{651B6F30-EC96-2340-AD4B-07A6B9855D0C}" dt="2025-07-17T09:55:36.490" v="947" actId="20577"/>
@@ -395,7 +737,7 @@
           </pc:sldLayoutMkLst>
         </pc:sldLayoutChg>
         <pc:sldLayoutChg chg="addSp delSp modSp mod ord">
-          <pc:chgData name="Sam Khalil" userId="82cd1ec2-6208-465b-9d4d-40ce8f0cbf96" providerId="ADAL" clId="{651B6F30-EC96-2340-AD4B-07A6B9855D0C}" dt="2025-07-20T15:51:25.535" v="1443" actId="20577"/>
+          <pc:chgData name="Sam Khalil" userId="82cd1ec2-6208-465b-9d4d-40ce8f0cbf96" providerId="ADAL" clId="{651B6F30-EC96-2340-AD4B-07A6B9855D0C}" dt="2025-07-21T08:07:35.499" v="2207"/>
           <pc:sldLayoutMkLst>
             <pc:docMk/>
             <pc:sldMasterMk cId="2940896467" sldId="2147483648"/>
@@ -411,7 +753,7 @@
             </ac:spMkLst>
           </pc:spChg>
           <pc:spChg chg="add mod">
-            <ac:chgData name="Sam Khalil" userId="82cd1ec2-6208-465b-9d4d-40ce8f0cbf96" providerId="ADAL" clId="{651B6F30-EC96-2340-AD4B-07A6B9855D0C}" dt="2025-07-20T15:51:25.535" v="1443" actId="20577"/>
+            <ac:chgData name="Sam Khalil" userId="82cd1ec2-6208-465b-9d4d-40ce8f0cbf96" providerId="ADAL" clId="{651B6F30-EC96-2340-AD4B-07A6B9855D0C}" dt="2025-07-21T08:06:45.805" v="2167" actId="1076"/>
             <ac:spMkLst>
               <pc:docMk/>
               <pc:sldMasterMk cId="2940896467" sldId="2147483648"/>
@@ -420,7 +762,7 @@
             </ac:spMkLst>
           </pc:spChg>
           <pc:spChg chg="add mod">
-            <ac:chgData name="Sam Khalil" userId="82cd1ec2-6208-465b-9d4d-40ce8f0cbf96" providerId="ADAL" clId="{651B6F30-EC96-2340-AD4B-07A6B9855D0C}" dt="2025-07-20T15:49:13.279" v="1361" actId="404"/>
+            <ac:chgData name="Sam Khalil" userId="82cd1ec2-6208-465b-9d4d-40ce8f0cbf96" providerId="ADAL" clId="{651B6F30-EC96-2340-AD4B-07A6B9855D0C}" dt="2025-07-21T08:07:33.541" v="2205"/>
             <ac:spMkLst>
               <pc:docMk/>
               <pc:sldMasterMk cId="2940896467" sldId="2147483648"/>
@@ -429,7 +771,7 @@
             </ac:spMkLst>
           </pc:spChg>
           <pc:spChg chg="add mod">
-            <ac:chgData name="Sam Khalil" userId="82cd1ec2-6208-465b-9d4d-40ce8f0cbf96" providerId="ADAL" clId="{651B6F30-EC96-2340-AD4B-07A6B9855D0C}" dt="2025-07-20T15:50:43.304" v="1425" actId="122"/>
+            <ac:chgData name="Sam Khalil" userId="82cd1ec2-6208-465b-9d4d-40ce8f0cbf96" providerId="ADAL" clId="{651B6F30-EC96-2340-AD4B-07A6B9855D0C}" dt="2025-07-21T08:06:41.036" v="2166" actId="1076"/>
             <ac:spMkLst>
               <pc:docMk/>
               <pc:sldMasterMk cId="2940896467" sldId="2147483648"/>
@@ -438,7 +780,7 @@
             </ac:spMkLst>
           </pc:spChg>
           <pc:spChg chg="add del mod">
-            <ac:chgData name="Sam Khalil" userId="82cd1ec2-6208-465b-9d4d-40ce8f0cbf96" providerId="ADAL" clId="{651B6F30-EC96-2340-AD4B-07A6B9855D0C}" dt="2025-07-20T15:49:16.063" v="1363" actId="404"/>
+            <ac:chgData name="Sam Khalil" userId="82cd1ec2-6208-465b-9d4d-40ce8f0cbf96" providerId="ADAL" clId="{651B6F30-EC96-2340-AD4B-07A6B9855D0C}" dt="2025-07-21T08:07:29.210" v="2201"/>
             <ac:spMkLst>
               <pc:docMk/>
               <pc:sldMasterMk cId="2940896467" sldId="2147483648"/>
@@ -447,7 +789,7 @@
             </ac:spMkLst>
           </pc:spChg>
           <pc:spChg chg="add mod">
-            <ac:chgData name="Sam Khalil" userId="82cd1ec2-6208-465b-9d4d-40ce8f0cbf96" providerId="ADAL" clId="{651B6F30-EC96-2340-AD4B-07A6B9855D0C}" dt="2025-07-20T15:50:38.422" v="1423" actId="20577"/>
+            <ac:chgData name="Sam Khalil" userId="82cd1ec2-6208-465b-9d4d-40ce8f0cbf96" providerId="ADAL" clId="{651B6F30-EC96-2340-AD4B-07A6B9855D0C}" dt="2025-07-21T08:06:41.036" v="2166" actId="1076"/>
             <ac:spMkLst>
               <pc:docMk/>
               <pc:sldMasterMk cId="2940896467" sldId="2147483648"/>
@@ -456,7 +798,7 @@
             </ac:spMkLst>
           </pc:spChg>
           <pc:spChg chg="add mod">
-            <ac:chgData name="Sam Khalil" userId="82cd1ec2-6208-465b-9d4d-40ce8f0cbf96" providerId="ADAL" clId="{651B6F30-EC96-2340-AD4B-07A6B9855D0C}" dt="2025-07-20T15:51:22.837" v="1441" actId="20577"/>
+            <ac:chgData name="Sam Khalil" userId="82cd1ec2-6208-465b-9d4d-40ce8f0cbf96" providerId="ADAL" clId="{651B6F30-EC96-2340-AD4B-07A6B9855D0C}" dt="2025-07-21T08:06:45.805" v="2167" actId="1076"/>
             <ac:spMkLst>
               <pc:docMk/>
               <pc:sldMasterMk cId="2940896467" sldId="2147483648"/>
@@ -465,7 +807,7 @@
             </ac:spMkLst>
           </pc:spChg>
           <pc:spChg chg="add mod">
-            <ac:chgData name="Sam Khalil" userId="82cd1ec2-6208-465b-9d4d-40ce8f0cbf96" providerId="ADAL" clId="{651B6F30-EC96-2340-AD4B-07A6B9855D0C}" dt="2025-07-20T15:49:07.642" v="1357" actId="404"/>
+            <ac:chgData name="Sam Khalil" userId="82cd1ec2-6208-465b-9d4d-40ce8f0cbf96" providerId="ADAL" clId="{651B6F30-EC96-2340-AD4B-07A6B9855D0C}" dt="2025-07-21T08:07:26.618" v="2199"/>
             <ac:spMkLst>
               <pc:docMk/>
               <pc:sldMasterMk cId="2940896467" sldId="2147483648"/>
@@ -474,7 +816,7 @@
             </ac:spMkLst>
           </pc:spChg>
           <pc:spChg chg="add mod">
-            <ac:chgData name="Sam Khalil" userId="82cd1ec2-6208-465b-9d4d-40ce8f0cbf96" providerId="ADAL" clId="{651B6F30-EC96-2340-AD4B-07A6B9855D0C}" dt="2025-07-20T15:51:00.216" v="1431" actId="404"/>
+            <ac:chgData name="Sam Khalil" userId="82cd1ec2-6208-465b-9d4d-40ce8f0cbf96" providerId="ADAL" clId="{651B6F30-EC96-2340-AD4B-07A6B9855D0C}" dt="2025-07-21T08:06:45.805" v="2167" actId="1076"/>
             <ac:spMkLst>
               <pc:docMk/>
               <pc:sldMasterMk cId="2940896467" sldId="2147483648"/>
@@ -483,7 +825,7 @@
             </ac:spMkLst>
           </pc:spChg>
           <pc:spChg chg="add mod">
-            <ac:chgData name="Sam Khalil" userId="82cd1ec2-6208-465b-9d4d-40ce8f0cbf96" providerId="ADAL" clId="{651B6F30-EC96-2340-AD4B-07A6B9855D0C}" dt="2025-07-20T15:49:11.008" v="1359" actId="404"/>
+            <ac:chgData name="Sam Khalil" userId="82cd1ec2-6208-465b-9d4d-40ce8f0cbf96" providerId="ADAL" clId="{651B6F30-EC96-2340-AD4B-07A6B9855D0C}" dt="2025-07-21T08:07:31.485" v="2203"/>
             <ac:spMkLst>
               <pc:docMk/>
               <pc:sldMasterMk cId="2940896467" sldId="2147483648"/>
@@ -492,7 +834,7 @@
             </ac:spMkLst>
           </pc:spChg>
           <pc:spChg chg="add mod">
-            <ac:chgData name="Sam Khalil" userId="82cd1ec2-6208-465b-9d4d-40ce8f0cbf96" providerId="ADAL" clId="{651B6F30-EC96-2340-AD4B-07A6B9855D0C}" dt="2025-07-20T15:50:41.068" v="1424" actId="122"/>
+            <ac:chgData name="Sam Khalil" userId="82cd1ec2-6208-465b-9d4d-40ce8f0cbf96" providerId="ADAL" clId="{651B6F30-EC96-2340-AD4B-07A6B9855D0C}" dt="2025-07-21T08:06:41.036" v="2166" actId="1076"/>
             <ac:spMkLst>
               <pc:docMk/>
               <pc:sldMasterMk cId="2940896467" sldId="2147483648"/>
@@ -501,7 +843,7 @@
             </ac:spMkLst>
           </pc:spChg>
           <pc:spChg chg="add mod">
-            <ac:chgData name="Sam Khalil" userId="82cd1ec2-6208-465b-9d4d-40ce8f0cbf96" providerId="ADAL" clId="{651B6F30-EC96-2340-AD4B-07A6B9855D0C}" dt="2025-07-20T15:49:04.200" v="1355" actId="404"/>
+            <ac:chgData name="Sam Khalil" userId="82cd1ec2-6208-465b-9d4d-40ce8f0cbf96" providerId="ADAL" clId="{651B6F30-EC96-2340-AD4B-07A6B9855D0C}" dt="2025-07-21T08:07:27.788" v="2200"/>
             <ac:spMkLst>
               <pc:docMk/>
               <pc:sldMasterMk cId="2940896467" sldId="2147483648"/>
@@ -510,7 +852,7 @@
             </ac:spMkLst>
           </pc:spChg>
           <pc:spChg chg="add mod">
-            <ac:chgData name="Sam Khalil" userId="82cd1ec2-6208-465b-9d4d-40ce8f0cbf96" providerId="ADAL" clId="{651B6F30-EC96-2340-AD4B-07A6B9855D0C}" dt="2025-07-20T15:49:18.605" v="1365" actId="404"/>
+            <ac:chgData name="Sam Khalil" userId="82cd1ec2-6208-465b-9d4d-40ce8f0cbf96" providerId="ADAL" clId="{651B6F30-EC96-2340-AD4B-07A6B9855D0C}" dt="2025-07-21T08:07:35.499" v="2207"/>
             <ac:spMkLst>
               <pc:docMk/>
               <pc:sldMasterMk cId="2940896467" sldId="2147483648"/>
@@ -518,14 +860,41 @@
               <ac:spMk id="14" creationId="{BCEDE17A-C31D-39B6-1DD5-DFF09F743405}"/>
             </ac:spMkLst>
           </pc:spChg>
+          <pc:spChg chg="add mod">
+            <ac:chgData name="Sam Khalil" userId="82cd1ec2-6208-465b-9d4d-40ce8f0cbf96" providerId="ADAL" clId="{651B6F30-EC96-2340-AD4B-07A6B9855D0C}" dt="2025-07-21T08:06:35.192" v="2165" actId="167"/>
+            <ac:spMkLst>
+              <pc:docMk/>
+              <pc:sldMasterMk cId="2940896467" sldId="2147483648"/>
+              <pc:sldLayoutMk cId="1049941252" sldId="2147483675"/>
+              <ac:spMk id="15" creationId="{A947E235-B803-CB82-33BD-ED0DA2439F22}"/>
+            </ac:spMkLst>
+          </pc:spChg>
         </pc:sldLayoutChg>
         <pc:sldLayoutChg chg="addSp delSp modSp add mod ord modTransition">
-          <pc:chgData name="Sam Khalil" userId="82cd1ec2-6208-465b-9d4d-40ce8f0cbf96" providerId="ADAL" clId="{651B6F30-EC96-2340-AD4B-07A6B9855D0C}" dt="2025-07-17T21:10:25.014" v="1236" actId="20578"/>
+          <pc:chgData name="Sam Khalil" userId="82cd1ec2-6208-465b-9d4d-40ce8f0cbf96" providerId="ADAL" clId="{651B6F30-EC96-2340-AD4B-07A6B9855D0C}" dt="2025-07-21T08:07:59.793" v="2234" actId="20577"/>
           <pc:sldLayoutMkLst>
             <pc:docMk/>
             <pc:sldMasterMk cId="2940896467" sldId="2147483648"/>
             <pc:sldLayoutMk cId="88811751" sldId="2147483676"/>
           </pc:sldLayoutMkLst>
+          <pc:spChg chg="mod">
+            <ac:chgData name="Sam Khalil" userId="82cd1ec2-6208-465b-9d4d-40ce8f0cbf96" providerId="ADAL" clId="{651B6F30-EC96-2340-AD4B-07A6B9855D0C}" dt="2025-07-21T08:07:59.793" v="2234" actId="20577"/>
+            <ac:spMkLst>
+              <pc:docMk/>
+              <pc:sldMasterMk cId="2940896467" sldId="2147483648"/>
+              <pc:sldLayoutMk cId="88811751" sldId="2147483676"/>
+              <ac:spMk id="3" creationId="{8A6FC6F2-80B4-49A7-9448-33FE2DF0E967}"/>
+            </ac:spMkLst>
+          </pc:spChg>
+          <pc:spChg chg="add mod">
+            <ac:chgData name="Sam Khalil" userId="82cd1ec2-6208-465b-9d4d-40ce8f0cbf96" providerId="ADAL" clId="{651B6F30-EC96-2340-AD4B-07A6B9855D0C}" dt="2025-07-21T08:07:48.278" v="2210" actId="167"/>
+            <ac:spMkLst>
+              <pc:docMk/>
+              <pc:sldMasterMk cId="2940896467" sldId="2147483648"/>
+              <pc:sldLayoutMk cId="88811751" sldId="2147483676"/>
+              <ac:spMk id="4" creationId="{BE22977E-9585-6DDE-2FD8-59AEA03AE068}"/>
+            </ac:spMkLst>
+          </pc:spChg>
         </pc:sldLayoutChg>
         <pc:sldLayoutChg chg="modSp add mod modTransition">
           <pc:chgData name="Sam Khalil" userId="82cd1ec2-6208-465b-9d4d-40ce8f0cbf96" providerId="ADAL" clId="{651B6F30-EC96-2340-AD4B-07A6B9855D0C}" dt="2025-07-17T22:12:58.955" v="1348" actId="962"/>
@@ -544,15 +913,15 @@
             </ac:spMkLst>
           </pc:spChg>
         </pc:sldLayoutChg>
-        <pc:sldLayoutChg chg="delSp modSp add mod modTransition">
-          <pc:chgData name="Sam Khalil" userId="82cd1ec2-6208-465b-9d4d-40ce8f0cbf96" providerId="ADAL" clId="{651B6F30-EC96-2340-AD4B-07A6B9855D0C}" dt="2025-07-20T15:51:34.838" v="1445" actId="404"/>
+        <pc:sldLayoutChg chg="addSp delSp modSp add mod modTransition">
+          <pc:chgData name="Sam Khalil" userId="82cd1ec2-6208-465b-9d4d-40ce8f0cbf96" providerId="ADAL" clId="{651B6F30-EC96-2340-AD4B-07A6B9855D0C}" dt="2025-07-21T08:07:22.700" v="2197"/>
           <pc:sldLayoutMkLst>
             <pc:docMk/>
             <pc:sldMasterMk cId="2940896467" sldId="2147483648"/>
             <pc:sldLayoutMk cId="2538074859" sldId="2147483678"/>
           </pc:sldLayoutMkLst>
           <pc:spChg chg="mod">
-            <ac:chgData name="Sam Khalil" userId="82cd1ec2-6208-465b-9d4d-40ce8f0cbf96" providerId="ADAL" clId="{651B6F30-EC96-2340-AD4B-07A6B9855D0C}" dt="2025-07-17T22:40:18.173" v="1351" actId="1076"/>
+            <ac:chgData name="Sam Khalil" userId="82cd1ec2-6208-465b-9d4d-40ce8f0cbf96" providerId="ADAL" clId="{651B6F30-EC96-2340-AD4B-07A6B9855D0C}" dt="2025-07-21T08:07:07.892" v="2172" actId="1076"/>
             <ac:spMkLst>
               <pc:docMk/>
               <pc:sldMasterMk cId="2940896467" sldId="2147483648"/>
@@ -561,7 +930,7 @@
             </ac:spMkLst>
           </pc:spChg>
           <pc:spChg chg="mod">
-            <ac:chgData name="Sam Khalil" userId="82cd1ec2-6208-465b-9d4d-40ce8f0cbf96" providerId="ADAL" clId="{651B6F30-EC96-2340-AD4B-07A6B9855D0C}" dt="2025-07-20T15:51:34.838" v="1445" actId="404"/>
+            <ac:chgData name="Sam Khalil" userId="82cd1ec2-6208-465b-9d4d-40ce8f0cbf96" providerId="ADAL" clId="{651B6F30-EC96-2340-AD4B-07A6B9855D0C}" dt="2025-07-21T08:07:22.700" v="2197"/>
             <ac:spMkLst>
               <pc:docMk/>
               <pc:sldMasterMk cId="2940896467" sldId="2147483648"/>
@@ -569,8 +938,17 @@
               <ac:spMk id="4" creationId="{127F3D65-4217-C7DF-99AC-5D0069212872}"/>
             </ac:spMkLst>
           </pc:spChg>
+          <pc:spChg chg="add mod">
+            <ac:chgData name="Sam Khalil" userId="82cd1ec2-6208-465b-9d4d-40ce8f0cbf96" providerId="ADAL" clId="{651B6F30-EC96-2340-AD4B-07A6B9855D0C}" dt="2025-07-21T08:06:56.521" v="2170" actId="167"/>
+            <ac:spMkLst>
+              <pc:docMk/>
+              <pc:sldMasterMk cId="2940896467" sldId="2147483648"/>
+              <pc:sldLayoutMk cId="2538074859" sldId="2147483678"/>
+              <ac:spMk id="5" creationId="{E016E7B1-923A-B9B7-53D4-CEA8E79FC61D}"/>
+            </ac:spMkLst>
+          </pc:spChg>
           <pc:spChg chg="mod">
-            <ac:chgData name="Sam Khalil" userId="82cd1ec2-6208-465b-9d4d-40ce8f0cbf96" providerId="ADAL" clId="{651B6F30-EC96-2340-AD4B-07A6B9855D0C}" dt="2025-07-17T22:40:18.173" v="1351" actId="1076"/>
+            <ac:chgData name="Sam Khalil" userId="82cd1ec2-6208-465b-9d4d-40ce8f0cbf96" providerId="ADAL" clId="{651B6F30-EC96-2340-AD4B-07A6B9855D0C}" dt="2025-07-21T08:07:02.184" v="2171" actId="1076"/>
             <ac:spMkLst>
               <pc:docMk/>
               <pc:sldMasterMk cId="2940896467" sldId="2147483648"/>
@@ -579,7 +957,7 @@
             </ac:spMkLst>
           </pc:spChg>
           <pc:spChg chg="mod">
-            <ac:chgData name="Sam Khalil" userId="82cd1ec2-6208-465b-9d4d-40ce8f0cbf96" providerId="ADAL" clId="{651B6F30-EC96-2340-AD4B-07A6B9855D0C}" dt="2025-07-20T15:51:34.838" v="1445" actId="404"/>
+            <ac:chgData name="Sam Khalil" userId="82cd1ec2-6208-465b-9d4d-40ce8f0cbf96" providerId="ADAL" clId="{651B6F30-EC96-2340-AD4B-07A6B9855D0C}" dt="2025-07-21T08:07:14.822" v="2191" actId="20577"/>
             <ac:spMkLst>
               <pc:docMk/>
               <pc:sldMasterMk cId="2940896467" sldId="2147483648"/>
@@ -588,7 +966,7 @@
             </ac:spMkLst>
           </pc:spChg>
           <pc:spChg chg="mod">
-            <ac:chgData name="Sam Khalil" userId="82cd1ec2-6208-465b-9d4d-40ce8f0cbf96" providerId="ADAL" clId="{651B6F30-EC96-2340-AD4B-07A6B9855D0C}" dt="2025-07-17T22:40:18.173" v="1351" actId="1076"/>
+            <ac:chgData name="Sam Khalil" userId="82cd1ec2-6208-465b-9d4d-40ce8f0cbf96" providerId="ADAL" clId="{651B6F30-EC96-2340-AD4B-07A6B9855D0C}" dt="2025-07-21T08:07:07.892" v="2172" actId="1076"/>
             <ac:spMkLst>
               <pc:docMk/>
               <pc:sldMasterMk cId="2940896467" sldId="2147483648"/>
@@ -597,7 +975,7 @@
             </ac:spMkLst>
           </pc:spChg>
           <pc:spChg chg="mod">
-            <ac:chgData name="Sam Khalil" userId="82cd1ec2-6208-465b-9d4d-40ce8f0cbf96" providerId="ADAL" clId="{651B6F30-EC96-2340-AD4B-07A6B9855D0C}" dt="2025-07-20T15:51:34.838" v="1445" actId="404"/>
+            <ac:chgData name="Sam Khalil" userId="82cd1ec2-6208-465b-9d4d-40ce8f0cbf96" providerId="ADAL" clId="{651B6F30-EC96-2340-AD4B-07A6B9855D0C}" dt="2025-07-21T08:07:20.929" v="2195"/>
             <ac:spMkLst>
               <pc:docMk/>
               <pc:sldMasterMk cId="2940896467" sldId="2147483648"/>
@@ -606,7 +984,7 @@
             </ac:spMkLst>
           </pc:spChg>
           <pc:spChg chg="mod">
-            <ac:chgData name="Sam Khalil" userId="82cd1ec2-6208-465b-9d4d-40ce8f0cbf96" providerId="ADAL" clId="{651B6F30-EC96-2340-AD4B-07A6B9855D0C}" dt="2025-07-17T22:40:18.173" v="1351" actId="1076"/>
+            <ac:chgData name="Sam Khalil" userId="82cd1ec2-6208-465b-9d4d-40ce8f0cbf96" providerId="ADAL" clId="{651B6F30-EC96-2340-AD4B-07A6B9855D0C}" dt="2025-07-21T08:07:02.184" v="2171" actId="1076"/>
             <ac:spMkLst>
               <pc:docMk/>
               <pc:sldMasterMk cId="2940896467" sldId="2147483648"/>
@@ -615,7 +993,7 @@
             </ac:spMkLst>
           </pc:spChg>
           <pc:spChg chg="mod">
-            <ac:chgData name="Sam Khalil" userId="82cd1ec2-6208-465b-9d4d-40ce8f0cbf96" providerId="ADAL" clId="{651B6F30-EC96-2340-AD4B-07A6B9855D0C}" dt="2025-07-20T15:51:34.838" v="1445" actId="404"/>
+            <ac:chgData name="Sam Khalil" userId="82cd1ec2-6208-465b-9d4d-40ce8f0cbf96" providerId="ADAL" clId="{651B6F30-EC96-2340-AD4B-07A6B9855D0C}" dt="2025-07-21T08:07:18.652" v="2193"/>
             <ac:spMkLst>
               <pc:docMk/>
               <pc:sldMasterMk cId="2940896467" sldId="2147483648"/>
@@ -724,7 +1102,7 @@
           <a:p>
             <a:fld id="{D2339670-67E6-CD42-B7B2-F285F1108ED9}" type="datetimeFigureOut">
               <a:rPr lang="en-US" smtClean="0"/>
-              <a:t>7/20/25</a:t>
+              <a:t>7/21/25</a:t>
             </a:fld>
             <a:endParaRPr lang="en-US"/>
           </a:p>
@@ -900,7 +1278,7 @@
           </a:lstStyle>
           <a:p>
             <a:fld id="{1E521F2A-B11E-40E0-8F26-7CD21B55A12D}" type="datetimeFigureOut">
-              <a:t>7/20/25</a:t>
+              <a:t>7/21/25</a:t>
             </a:fld>
             <a:endParaRPr lang="en-GB"/>
           </a:p>
@@ -1320,6 +1698,67 @@
       </p:grpSpPr>
       <p:sp>
         <p:nvSpPr>
+          <p:cNvPr id="4" name="Rounded Rectangle 3">
+            <a:extLst>
+              <a:ext uri="{FF2B5EF4-FFF2-40B4-BE49-F238E27FC236}">
+                <a16:creationId xmlns:a16="http://schemas.microsoft.com/office/drawing/2014/main" id="{BE22977E-9585-6DDE-2FD8-59AEA03AE068}"/>
+              </a:ext>
+            </a:extLst>
+          </p:cNvPr>
+          <p:cNvSpPr/>
+          <p:nvPr userDrawn="1"/>
+        </p:nvSpPr>
+        <p:spPr>
+          <a:xfrm>
+            <a:off x="381000" y="1855425"/>
+            <a:ext cx="11430000" cy="4193309"/>
+          </a:xfrm>
+          <a:prstGeom prst="roundRect">
+            <a:avLst>
+              <a:gd name="adj" fmla="val 4552"/>
+            </a:avLst>
+          </a:prstGeom>
+          <a:solidFill>
+            <a:schemeClr val="bg1"/>
+          </a:solidFill>
+          <a:ln>
+            <a:noFill/>
+          </a:ln>
+          <a:effectLst>
+            <a:outerShdw blurRad="253894" dist="38100" dir="4200000" sx="100317" sy="100317" algn="tl" rotWithShape="0">
+              <a:prstClr val="black">
+                <a:alpha val="22007"/>
+              </a:prstClr>
+            </a:outerShdw>
+          </a:effectLst>
+        </p:spPr>
+        <p:style>
+          <a:lnRef idx="2">
+            <a:schemeClr val="accent1">
+              <a:shade val="15000"/>
+            </a:schemeClr>
+          </a:lnRef>
+          <a:fillRef idx="1">
+            <a:schemeClr val="accent1"/>
+          </a:fillRef>
+          <a:effectRef idx="0">
+            <a:schemeClr val="accent1"/>
+          </a:effectRef>
+          <a:fontRef idx="minor">
+            <a:schemeClr val="lt1"/>
+          </a:fontRef>
+        </p:style>
+        <p:txBody>
+          <a:bodyPr rtlCol="0" anchor="ctr"/>
+          <a:lstStyle/>
+          <a:p>
+            <a:pPr algn="ctr"/>
+            <a:endParaRPr lang="en-US"/>
+          </a:p>
+        </p:txBody>
+      </p:sp>
+      <p:sp>
+        <p:nvSpPr>
           <p:cNvPr id="2" name="Conclusion Title">
             <a:extLst>
               <a:ext uri="{FF2B5EF4-FFF2-40B4-BE49-F238E27FC236}">
@@ -1392,8 +1831,8 @@
         </p:nvSpPr>
         <p:spPr>
           <a:xfrm>
-            <a:off x="381000" y="1825625"/>
-            <a:ext cx="11430000" cy="4351338"/>
+            <a:off x="990600" y="2030660"/>
+            <a:ext cx="10210800" cy="3842837"/>
           </a:xfrm>
           <a:prstGeom prst="rect">
             <a:avLst/>
@@ -1570,7 +2009,7 @@
           <a:p>
             <a:r>
               <a:rPr lang="en-US" dirty="0"/>
-              <a:t>A bulleted list of items and a short conclusion text</a:t>
+              <a:t>A bulleted list of items and a short conclusion text in markdown format</a:t>
             </a:r>
           </a:p>
         </p:txBody>
@@ -1605,6 +2044,69 @@
           <a:chExt cx="0" cy="0"/>
         </a:xfrm>
       </p:grpSpPr>
+      <p:sp>
+        <p:nvSpPr>
+          <p:cNvPr id="13" name="Rounded Rectangle 12">
+            <a:extLst>
+              <a:ext uri="{FF2B5EF4-FFF2-40B4-BE49-F238E27FC236}">
+                <a16:creationId xmlns:a16="http://schemas.microsoft.com/office/drawing/2014/main" id="{0617AC1D-26CB-713E-4508-B01954EF86DF}"/>
+              </a:ext>
+            </a:extLst>
+          </p:cNvPr>
+          <p:cNvSpPr/>
+          <p:nvPr userDrawn="1"/>
+        </p:nvSpPr>
+        <p:spPr>
+          <a:xfrm>
+            <a:off x="381000" y="204537"/>
+            <a:ext cx="11430000" cy="5844197"/>
+          </a:xfrm>
+          <a:prstGeom prst="roundRect">
+            <a:avLst>
+              <a:gd name="adj" fmla="val 4552"/>
+            </a:avLst>
+          </a:prstGeom>
+          <a:solidFill>
+            <a:schemeClr val="bg1">
+              <a:alpha val="82425"/>
+            </a:schemeClr>
+          </a:solidFill>
+          <a:ln>
+            <a:noFill/>
+          </a:ln>
+          <a:effectLst>
+            <a:outerShdw blurRad="253894" dist="38100" dir="4200000" sx="100317" sy="100317" algn="tl" rotWithShape="0">
+              <a:prstClr val="black">
+                <a:alpha val="22007"/>
+              </a:prstClr>
+            </a:outerShdw>
+          </a:effectLst>
+        </p:spPr>
+        <p:style>
+          <a:lnRef idx="2">
+            <a:schemeClr val="accent1">
+              <a:shade val="15000"/>
+            </a:schemeClr>
+          </a:lnRef>
+          <a:fillRef idx="1">
+            <a:schemeClr val="accent1"/>
+          </a:fillRef>
+          <a:effectRef idx="0">
+            <a:schemeClr val="accent1"/>
+          </a:effectRef>
+          <a:fontRef idx="minor">
+            <a:schemeClr val="lt1"/>
+          </a:fontRef>
+        </p:style>
+        <p:txBody>
+          <a:bodyPr rtlCol="0" anchor="ctr"/>
+          <a:lstStyle/>
+          <a:p>
+            <a:pPr algn="ctr"/>
+            <a:endParaRPr lang="en-US"/>
+          </a:p>
+        </p:txBody>
+      </p:sp>
       <p:pic>
         <p:nvPicPr>
           <p:cNvPr id="4" name="Picture 3" descr="A snowy mountain tops with clouds in the background&#10;&#10;AI-generated content may be incorrect.">
@@ -1659,10 +2161,10 @@
       </p:pic>
       <p:sp>
         <p:nvSpPr>
-          <p:cNvPr id="2" name="Rounded Rectangle 1">
-            <a:extLst>
-              <a:ext uri="{FF2B5EF4-FFF2-40B4-BE49-F238E27FC236}">
-                <a16:creationId xmlns:a16="http://schemas.microsoft.com/office/drawing/2014/main" id="{6372FCEB-FEC1-18CC-54A6-09739A289B26}"/>
+          <p:cNvPr id="18" name="Rounded Rectangle 17">
+            <a:extLst>
+              <a:ext uri="{FF2B5EF4-FFF2-40B4-BE49-F238E27FC236}">
+                <a16:creationId xmlns:a16="http://schemas.microsoft.com/office/drawing/2014/main" id="{12CC8E3F-B2A1-F8CA-0B79-3E642C812BBA}"/>
               </a:ext>
             </a:extLst>
           </p:cNvPr>
@@ -1671,29 +2173,28 @@
         </p:nvSpPr>
         <p:spPr>
           <a:xfrm>
-            <a:off x="7855153" y="2401368"/>
-            <a:ext cx="3878223" cy="2385232"/>
+            <a:off x="7579551" y="1999874"/>
+            <a:ext cx="3878224" cy="2385232"/>
           </a:xfrm>
           <a:prstGeom prst="roundRect">
             <a:avLst>
-              <a:gd name="adj" fmla="val 4127"/>
+              <a:gd name="adj" fmla="val 4552"/>
             </a:avLst>
           </a:prstGeom>
           <a:solidFill>
             <a:schemeClr val="bg1">
-              <a:lumMod val="85000"/>
-              <a:alpha val="13425"/>
+              <a:alpha val="84116"/>
             </a:schemeClr>
           </a:solidFill>
           <a:ln>
             <a:noFill/>
           </a:ln>
           <a:effectLst>
-            <a:innerShdw blurRad="63500" dist="50800" dir="13500000">
+            <a:outerShdw blurRad="253894" dist="38100" dir="4200000" sx="100317" sy="100317" algn="tl" rotWithShape="0">
               <a:prstClr val="black">
-                <a:alpha val="50000"/>
+                <a:alpha val="22007"/>
               </a:prstClr>
-            </a:innerShdw>
+            </a:outerShdw>
           </a:effectLst>
         </p:spPr>
         <p:style>
@@ -2143,7 +2644,7 @@
         </p:nvSpPr>
         <p:spPr>
           <a:xfrm>
-            <a:off x="7944857" y="2525381"/>
+            <a:off x="7624404" y="2083374"/>
             <a:ext cx="3788519" cy="1569660"/>
           </a:xfrm>
           <a:prstGeom prst="rect">
@@ -2159,7 +2660,7 @@
           <a:p>
             <a:pPr algn="ctr"/>
             <a:r>
-              <a:rPr lang="en-US" sz="2400" b="1" i="0">
+              <a:rPr lang="en-US" sz="2400" b="1" i="0" dirty="0">
                 <a:solidFill>
                   <a:schemeClr val="tx1">
                     <a:lumMod val="75000"/>
@@ -2202,7 +2703,7 @@
         </p:blipFill>
         <p:spPr>
           <a:xfrm>
-            <a:off x="9454583" y="3953226"/>
+            <a:off x="9134130" y="3511219"/>
             <a:ext cx="914400" cy="914400"/>
           </a:xfrm>
           <a:prstGeom prst="rect">
@@ -2369,6 +2870,67 @@
       </p:grpSpPr>
       <p:sp>
         <p:nvSpPr>
+          <p:cNvPr id="2" name="Rounded Rectangle 1">
+            <a:extLst>
+              <a:ext uri="{FF2B5EF4-FFF2-40B4-BE49-F238E27FC236}">
+                <a16:creationId xmlns:a16="http://schemas.microsoft.com/office/drawing/2014/main" id="{E4D1961F-E19F-CE3C-40E8-F910B0EE5077}"/>
+              </a:ext>
+            </a:extLst>
+          </p:cNvPr>
+          <p:cNvSpPr/>
+          <p:nvPr userDrawn="1"/>
+        </p:nvSpPr>
+        <p:spPr>
+          <a:xfrm>
+            <a:off x="398954" y="1031459"/>
+            <a:ext cx="11513737" cy="5017276"/>
+          </a:xfrm>
+          <a:prstGeom prst="roundRect">
+            <a:avLst>
+              <a:gd name="adj" fmla="val 4552"/>
+            </a:avLst>
+          </a:prstGeom>
+          <a:solidFill>
+            <a:schemeClr val="bg1"/>
+          </a:solidFill>
+          <a:ln>
+            <a:noFill/>
+          </a:ln>
+          <a:effectLst>
+            <a:outerShdw blurRad="253894" dist="38100" dir="4200000" sx="100317" sy="100317" algn="tl" rotWithShape="0">
+              <a:prstClr val="black">
+                <a:alpha val="22007"/>
+              </a:prstClr>
+            </a:outerShdw>
+          </a:effectLst>
+        </p:spPr>
+        <p:style>
+          <a:lnRef idx="2">
+            <a:schemeClr val="accent1">
+              <a:shade val="15000"/>
+            </a:schemeClr>
+          </a:lnRef>
+          <a:fillRef idx="1">
+            <a:schemeClr val="accent1"/>
+          </a:fillRef>
+          <a:effectRef idx="0">
+            <a:schemeClr val="accent1"/>
+          </a:effectRef>
+          <a:fontRef idx="minor">
+            <a:schemeClr val="lt1"/>
+          </a:fontRef>
+        </p:style>
+        <p:txBody>
+          <a:bodyPr rtlCol="0" anchor="ctr"/>
+          <a:lstStyle/>
+          <a:p>
+            <a:pPr algn="ctr"/>
+            <a:endParaRPr lang="en-US"/>
+          </a:p>
+        </p:txBody>
+      </p:sp>
+      <p:sp>
+        <p:nvSpPr>
           <p:cNvPr id="13" name="TextBox 12">
             <a:extLst>
               <a:ext uri="{FF2B5EF4-FFF2-40B4-BE49-F238E27FC236}">
@@ -2381,8 +2943,8 @@
         </p:nvSpPr>
         <p:spPr>
           <a:xfrm>
-            <a:off x="398954" y="385127"/>
-            <a:ext cx="11445516" cy="646331"/>
+            <a:off x="398954" y="123295"/>
+            <a:ext cx="11445516" cy="830997"/>
           </a:xfrm>
           <a:prstGeom prst="rect">
             <a:avLst/>
@@ -2395,12 +2957,12 @@
           </a:bodyPr>
           <a:lstStyle/>
           <a:p>
-            <a:pPr algn="ctr"/>
+            <a:pPr algn="l"/>
             <a:r>
-              <a:rPr lang="en-US" sz="3600" b="1" dirty="0"/>
-              <a:t>Why ekona</a:t>
+              <a:rPr lang="en-US" sz="4800" b="1" dirty="0"/>
+              <a:t>WHY EKONA</a:t>
             </a:r>
-            <a:endParaRPr lang="en-US" sz="3600" dirty="0"/>
+            <a:endParaRPr lang="en-US" sz="4800" dirty="0"/>
           </a:p>
         </p:txBody>
       </p:sp>
@@ -2418,7 +2980,7 @@
         </p:nvSpPr>
         <p:spPr>
           <a:xfrm>
-            <a:off x="1318169" y="1337258"/>
+            <a:off x="1579004" y="1337258"/>
             <a:ext cx="6152972" cy="369332"/>
           </a:xfrm>
           <a:prstGeom prst="rect">
@@ -2484,7 +3046,7 @@
         </p:nvSpPr>
         <p:spPr>
           <a:xfrm>
-            <a:off x="1318169" y="2951486"/>
+            <a:off x="1579004" y="2951486"/>
             <a:ext cx="6152972" cy="369332"/>
           </a:xfrm>
           <a:prstGeom prst="rect">
@@ -2553,7 +3115,7 @@
         </p:nvSpPr>
         <p:spPr>
           <a:xfrm>
-            <a:off x="931492" y="1708438"/>
+            <a:off x="1192327" y="1708438"/>
             <a:ext cx="4797039" cy="738664"/>
           </a:xfrm>
           <a:prstGeom prst="rect">
@@ -2592,7 +3154,7 @@
         </p:nvSpPr>
         <p:spPr>
           <a:xfrm>
-            <a:off x="931492" y="3324512"/>
+            <a:off x="1192327" y="3324512"/>
             <a:ext cx="4797039" cy="738664"/>
           </a:xfrm>
           <a:prstGeom prst="rect">
@@ -2659,7 +3221,7 @@
         </p:nvSpPr>
         <p:spPr>
           <a:xfrm>
-            <a:off x="1318168" y="4598939"/>
+            <a:off x="1579003" y="4598939"/>
             <a:ext cx="4623275" cy="369332"/>
           </a:xfrm>
           <a:prstGeom prst="rect">
@@ -2703,7 +3265,7 @@
         </p:nvSpPr>
         <p:spPr>
           <a:xfrm>
-            <a:off x="905573" y="5032463"/>
+            <a:off x="1166408" y="5032463"/>
             <a:ext cx="4725824" cy="738664"/>
           </a:xfrm>
           <a:prstGeom prst="rect">
@@ -2746,7 +3308,7 @@
         </p:nvSpPr>
         <p:spPr>
           <a:xfrm>
-            <a:off x="7271046" y="1339106"/>
+            <a:off x="7127541" y="1306294"/>
             <a:ext cx="4573424" cy="369332"/>
           </a:xfrm>
           <a:prstGeom prst="rect">
@@ -2789,7 +3351,7 @@
         </p:nvSpPr>
         <p:spPr>
           <a:xfrm>
-            <a:off x="6929214" y="1708437"/>
+            <a:off x="6785709" y="1675625"/>
             <a:ext cx="4797039" cy="738664"/>
           </a:xfrm>
           <a:prstGeom prst="rect">
@@ -2824,7 +3386,7 @@
         </p:nvSpPr>
         <p:spPr>
           <a:xfrm>
-            <a:off x="7295430" y="2907227"/>
+            <a:off x="7151925" y="2874415"/>
             <a:ext cx="4573424" cy="369332"/>
           </a:xfrm>
           <a:prstGeom prst="rect">
@@ -2867,7 +3429,7 @@
         </p:nvSpPr>
         <p:spPr>
           <a:xfrm>
-            <a:off x="6929214" y="3283946"/>
+            <a:off x="6785709" y="3251134"/>
             <a:ext cx="4797039" cy="738664"/>
           </a:xfrm>
           <a:prstGeom prst="rect">
@@ -2916,7 +3478,7 @@
         </p:blipFill>
         <p:spPr>
           <a:xfrm>
-            <a:off x="329520" y="1270462"/>
+            <a:off x="590355" y="1270462"/>
             <a:ext cx="506619" cy="506619"/>
           </a:xfrm>
           <a:prstGeom prst="rect">
@@ -2952,7 +3514,7 @@
         </p:blipFill>
         <p:spPr>
           <a:xfrm>
-            <a:off x="6340202" y="1261195"/>
+            <a:off x="6196697" y="1228383"/>
             <a:ext cx="506619" cy="506619"/>
           </a:xfrm>
           <a:prstGeom prst="rect">
@@ -2988,7 +3550,7 @@
         </p:blipFill>
         <p:spPr>
           <a:xfrm>
-            <a:off x="329520" y="2886536"/>
+            <a:off x="590355" y="2886536"/>
             <a:ext cx="506619" cy="506619"/>
           </a:xfrm>
           <a:prstGeom prst="rect">
@@ -3024,7 +3586,7 @@
         </p:blipFill>
         <p:spPr>
           <a:xfrm>
-            <a:off x="398954" y="4566590"/>
+            <a:off x="659789" y="4566590"/>
             <a:ext cx="506619" cy="506619"/>
           </a:xfrm>
           <a:prstGeom prst="rect">
@@ -3060,7 +3622,7 @@
         </p:blipFill>
         <p:spPr>
           <a:xfrm>
-            <a:off x="6340202" y="2863970"/>
+            <a:off x="6196697" y="2831158"/>
             <a:ext cx="506619" cy="506619"/>
           </a:xfrm>
           <a:prstGeom prst="rect">
@@ -3096,7 +3658,7 @@
         </p:blipFill>
         <p:spPr>
           <a:xfrm>
-            <a:off x="1013538" y="2983837"/>
+            <a:off x="1274373" y="2983837"/>
             <a:ext cx="304631" cy="304631"/>
           </a:xfrm>
           <a:prstGeom prst="rect">
@@ -3132,7 +3694,7 @@
         </p:blipFill>
         <p:spPr>
           <a:xfrm>
-            <a:off x="1013537" y="4631290"/>
+            <a:off x="1274372" y="4631290"/>
             <a:ext cx="304631" cy="304631"/>
           </a:xfrm>
           <a:prstGeom prst="rect">
@@ -3168,7 +3730,7 @@
         </p:blipFill>
         <p:spPr>
           <a:xfrm>
-            <a:off x="7022862" y="1368929"/>
+            <a:off x="6879357" y="1336117"/>
             <a:ext cx="305989" cy="305989"/>
           </a:xfrm>
           <a:prstGeom prst="rect">
@@ -3204,7 +3766,7 @@
         </p:blipFill>
         <p:spPr>
           <a:xfrm>
-            <a:off x="6966415" y="2955271"/>
+            <a:off x="6822910" y="2922459"/>
             <a:ext cx="304631" cy="304631"/>
           </a:xfrm>
           <a:prstGeom prst="rect">
@@ -3234,7 +3796,7 @@
         </p:blipFill>
         <p:spPr>
           <a:xfrm>
-            <a:off x="7067636" y="4898362"/>
+            <a:off x="6924131" y="4865550"/>
             <a:ext cx="853861" cy="809619"/>
           </a:xfrm>
           <a:prstGeom prst="rect">
@@ -3267,7 +3829,7 @@
         </p:blipFill>
         <p:spPr>
           <a:xfrm>
-            <a:off x="9212971" y="5032463"/>
+            <a:off x="9069466" y="4999651"/>
             <a:ext cx="853860" cy="623807"/>
           </a:xfrm>
           <a:prstGeom prst="rect">
@@ -3300,7 +3862,7 @@
         </p:blipFill>
         <p:spPr>
           <a:xfrm>
-            <a:off x="8145802" y="5008424"/>
+            <a:off x="8002297" y="4975612"/>
             <a:ext cx="596239" cy="605209"/>
           </a:xfrm>
           <a:prstGeom prst="rect">
@@ -3333,7 +3895,7 @@
         </p:blipFill>
         <p:spPr>
           <a:xfrm>
-            <a:off x="7022862" y="5656778"/>
+            <a:off x="6879357" y="5623966"/>
             <a:ext cx="1635687" cy="207535"/>
           </a:xfrm>
           <a:prstGeom prst="rect">
@@ -3366,7 +3928,7 @@
         </p:blipFill>
         <p:spPr>
           <a:xfrm>
-            <a:off x="10075017" y="5109625"/>
+            <a:off x="9931512" y="5076813"/>
             <a:ext cx="859887" cy="508778"/>
           </a:xfrm>
           <a:prstGeom prst="rect">
@@ -3403,7 +3965,7 @@
         </p:blipFill>
         <p:spPr>
           <a:xfrm>
-            <a:off x="9179458" y="5700588"/>
+            <a:off x="9035953" y="5667776"/>
             <a:ext cx="1755446" cy="163725"/>
           </a:xfrm>
           <a:prstGeom prst="rect">
@@ -3429,7 +3991,7 @@
         </p:nvSpPr>
         <p:spPr>
           <a:xfrm>
-            <a:off x="7259158" y="4631751"/>
+            <a:off x="7115653" y="4598939"/>
             <a:ext cx="4797038" cy="369332"/>
           </a:xfrm>
           <a:prstGeom prst="rect">
@@ -3483,7 +4045,7 @@
         </p:blipFill>
         <p:spPr>
           <a:xfrm>
-            <a:off x="6339930" y="4570494"/>
+            <a:off x="6196425" y="4537682"/>
             <a:ext cx="506619" cy="506619"/>
           </a:xfrm>
           <a:prstGeom prst="rect">
@@ -3519,7 +4081,7 @@
         </p:blipFill>
         <p:spPr>
           <a:xfrm>
-            <a:off x="6980926" y="4671079"/>
+            <a:off x="6837421" y="4638267"/>
             <a:ext cx="275608" cy="275608"/>
           </a:xfrm>
           <a:prstGeom prst="rect">
@@ -3555,7 +4117,7 @@
         </p:blipFill>
         <p:spPr>
           <a:xfrm>
-            <a:off x="981529" y="1333500"/>
+            <a:off x="1242364" y="1333500"/>
             <a:ext cx="359228" cy="373742"/>
           </a:xfrm>
           <a:prstGeom prst="rect">
@@ -4485,6 +5047,67 @@
       </p:grpSpPr>
       <p:sp>
         <p:nvSpPr>
+          <p:cNvPr id="4" name="Rounded Rectangle 3">
+            <a:extLst>
+              <a:ext uri="{FF2B5EF4-FFF2-40B4-BE49-F238E27FC236}">
+                <a16:creationId xmlns:a16="http://schemas.microsoft.com/office/drawing/2014/main" id="{F8567C99-F3EA-939B-081F-B8C4B329CCCE}"/>
+              </a:ext>
+            </a:extLst>
+          </p:cNvPr>
+          <p:cNvSpPr/>
+          <p:nvPr userDrawn="1"/>
+        </p:nvSpPr>
+        <p:spPr>
+          <a:xfrm>
+            <a:off x="381000" y="1855425"/>
+            <a:ext cx="11430000" cy="4193309"/>
+          </a:xfrm>
+          <a:prstGeom prst="roundRect">
+            <a:avLst>
+              <a:gd name="adj" fmla="val 4552"/>
+            </a:avLst>
+          </a:prstGeom>
+          <a:solidFill>
+            <a:schemeClr val="bg1"/>
+          </a:solidFill>
+          <a:ln>
+            <a:noFill/>
+          </a:ln>
+          <a:effectLst>
+            <a:outerShdw blurRad="253894" dist="38100" dir="4200000" sx="100317" sy="100317" algn="tl" rotWithShape="0">
+              <a:prstClr val="black">
+                <a:alpha val="22007"/>
+              </a:prstClr>
+            </a:outerShdw>
+          </a:effectLst>
+        </p:spPr>
+        <p:style>
+          <a:lnRef idx="2">
+            <a:schemeClr val="accent1">
+              <a:shade val="15000"/>
+            </a:schemeClr>
+          </a:lnRef>
+          <a:fillRef idx="1">
+            <a:schemeClr val="accent1"/>
+          </a:fillRef>
+          <a:effectRef idx="0">
+            <a:schemeClr val="accent1"/>
+          </a:effectRef>
+          <a:fontRef idx="minor">
+            <a:schemeClr val="lt1"/>
+          </a:fontRef>
+        </p:style>
+        <p:txBody>
+          <a:bodyPr rtlCol="0" anchor="ctr"/>
+          <a:lstStyle/>
+          <a:p>
+            <a:pPr algn="ctr"/>
+            <a:endParaRPr lang="en-US"/>
+          </a:p>
+        </p:txBody>
+      </p:sp>
+      <p:sp>
+        <p:nvSpPr>
           <p:cNvPr id="2" name="Title">
             <a:extLst>
               <a:ext uri="{FF2B5EF4-FFF2-40B4-BE49-F238E27FC236}">
@@ -4557,8 +5180,8 @@
         </p:nvSpPr>
         <p:spPr>
           <a:xfrm>
-            <a:off x="381000" y="1825625"/>
-            <a:ext cx="11430000" cy="4351338"/>
+            <a:off x="855517" y="2063717"/>
+            <a:ext cx="10480965" cy="3776723"/>
           </a:xfrm>
           <a:prstGeom prst="rect">
             <a:avLst/>
@@ -4735,7 +5358,7 @@
           <a:p>
             <a:r>
               <a:rPr lang="en-US" dirty="0"/>
-              <a:t>Content can be either a long paragraph, bullet points or a table. It can also be a mix, with no more than 50 words.</a:t>
+              <a:t>Content can be either a long paragraph, bullet points or a table all in markdown format. It can also be a mix, with no more than 100 words.</a:t>
             </a:r>
           </a:p>
         </p:txBody>
@@ -5059,6 +5682,128 @@
       </p:grpSpPr>
       <p:sp>
         <p:nvSpPr>
+          <p:cNvPr id="6" name="Rounded Rectangle 5">
+            <a:extLst>
+              <a:ext uri="{FF2B5EF4-FFF2-40B4-BE49-F238E27FC236}">
+                <a16:creationId xmlns:a16="http://schemas.microsoft.com/office/drawing/2014/main" id="{8755C1BE-9560-A50A-74BD-E0FFF7F5B69F}"/>
+              </a:ext>
+            </a:extLst>
+          </p:cNvPr>
+          <p:cNvSpPr/>
+          <p:nvPr userDrawn="1"/>
+        </p:nvSpPr>
+        <p:spPr>
+          <a:xfrm>
+            <a:off x="6187440" y="1855425"/>
+            <a:ext cx="5623560" cy="4193309"/>
+          </a:xfrm>
+          <a:prstGeom prst="roundRect">
+            <a:avLst>
+              <a:gd name="adj" fmla="val 4552"/>
+            </a:avLst>
+          </a:prstGeom>
+          <a:solidFill>
+            <a:schemeClr val="bg1"/>
+          </a:solidFill>
+          <a:ln>
+            <a:noFill/>
+          </a:ln>
+          <a:effectLst>
+            <a:outerShdw blurRad="253894" dist="38100" dir="4200000" sx="100317" sy="100317" algn="tl" rotWithShape="0">
+              <a:prstClr val="black">
+                <a:alpha val="22007"/>
+              </a:prstClr>
+            </a:outerShdw>
+          </a:effectLst>
+        </p:spPr>
+        <p:style>
+          <a:lnRef idx="2">
+            <a:schemeClr val="accent1">
+              <a:shade val="15000"/>
+            </a:schemeClr>
+          </a:lnRef>
+          <a:fillRef idx="1">
+            <a:schemeClr val="accent1"/>
+          </a:fillRef>
+          <a:effectRef idx="0">
+            <a:schemeClr val="accent1"/>
+          </a:effectRef>
+          <a:fontRef idx="minor">
+            <a:schemeClr val="lt1"/>
+          </a:fontRef>
+        </p:style>
+        <p:txBody>
+          <a:bodyPr rtlCol="0" anchor="ctr"/>
+          <a:lstStyle/>
+          <a:p>
+            <a:pPr algn="ctr"/>
+            <a:endParaRPr lang="en-US"/>
+          </a:p>
+        </p:txBody>
+      </p:sp>
+      <p:sp>
+        <p:nvSpPr>
+          <p:cNvPr id="5" name="Rounded Rectangle 4">
+            <a:extLst>
+              <a:ext uri="{FF2B5EF4-FFF2-40B4-BE49-F238E27FC236}">
+                <a16:creationId xmlns:a16="http://schemas.microsoft.com/office/drawing/2014/main" id="{4286C11B-CD57-AE94-2379-3F6FBE23504C}"/>
+              </a:ext>
+            </a:extLst>
+          </p:cNvPr>
+          <p:cNvSpPr/>
+          <p:nvPr userDrawn="1"/>
+        </p:nvSpPr>
+        <p:spPr>
+          <a:xfrm>
+            <a:off x="381000" y="1855425"/>
+            <a:ext cx="5623560" cy="4193309"/>
+          </a:xfrm>
+          <a:prstGeom prst="roundRect">
+            <a:avLst>
+              <a:gd name="adj" fmla="val 4552"/>
+            </a:avLst>
+          </a:prstGeom>
+          <a:solidFill>
+            <a:schemeClr val="bg1"/>
+          </a:solidFill>
+          <a:ln>
+            <a:noFill/>
+          </a:ln>
+          <a:effectLst>
+            <a:outerShdw blurRad="253894" dist="38100" dir="4200000" sx="100317" sy="100317" algn="tl" rotWithShape="0">
+              <a:prstClr val="black">
+                <a:alpha val="22007"/>
+              </a:prstClr>
+            </a:outerShdw>
+          </a:effectLst>
+        </p:spPr>
+        <p:style>
+          <a:lnRef idx="2">
+            <a:schemeClr val="accent1">
+              <a:shade val="15000"/>
+            </a:schemeClr>
+          </a:lnRef>
+          <a:fillRef idx="1">
+            <a:schemeClr val="accent1"/>
+          </a:fillRef>
+          <a:effectRef idx="0">
+            <a:schemeClr val="accent1"/>
+          </a:effectRef>
+          <a:fontRef idx="minor">
+            <a:schemeClr val="lt1"/>
+          </a:fontRef>
+        </p:style>
+        <p:txBody>
+          <a:bodyPr rtlCol="0" anchor="ctr"/>
+          <a:lstStyle/>
+          <a:p>
+            <a:pPr algn="ctr"/>
+            <a:endParaRPr lang="en-US"/>
+          </a:p>
+        </p:txBody>
+      </p:sp>
+      <p:sp>
+        <p:nvSpPr>
           <p:cNvPr id="2" name="Title">
             <a:extLst>
               <a:ext uri="{FF2B5EF4-FFF2-40B4-BE49-F238E27FC236}">
@@ -5131,8 +5876,8 @@
         </p:nvSpPr>
         <p:spPr>
           <a:xfrm>
-            <a:off x="381000" y="1825625"/>
-            <a:ext cx="5715000" cy="4351338"/>
+            <a:off x="770022" y="2018131"/>
+            <a:ext cx="4824663" cy="3877343"/>
           </a:xfrm>
           <a:prstGeom prst="rect">
             <a:avLst/>
@@ -5309,7 +6054,7 @@
           <a:p>
             <a:r>
               <a:rPr lang="en-US" dirty="0"/>
-              <a:t>First of two columns on a slide split in half. Content can be either paragraphs of text, bullet points or a table. Max 20-30 words.</a:t>
+              <a:t>First of two columns on a slide split in half. Content can be either paragraphs of text, bullet points or a table in markdown format. Max 20-30 words.</a:t>
             </a:r>
           </a:p>
         </p:txBody>
@@ -5332,8 +6077,8 @@
         </p:nvSpPr>
         <p:spPr>
           <a:xfrm>
-            <a:off x="6187440" y="1825625"/>
-            <a:ext cx="5623560" cy="4351338"/>
+            <a:off x="6597315" y="2018131"/>
+            <a:ext cx="4824663" cy="3877343"/>
           </a:xfrm>
           <a:prstGeom prst="rect">
             <a:avLst/>
@@ -5510,7 +6255,7 @@
           <a:p>
             <a:r>
               <a:rPr lang="en-US" dirty="0"/>
-              <a:t>Second of two columns on a slide split in half. Content can be either paragraphs of text, bullet points or a table. Max 20-30 words. Keep same style as in the first column.</a:t>
+              <a:t>Second of two columns on a slide split in half. Content can be either paragraphs of text, bullet points or a table in markdown format. Max 20-30 words. Keep same style as in the first column.</a:t>
             </a:r>
           </a:p>
         </p:txBody>
@@ -5547,6 +6292,67 @@
       </p:grpSpPr>
       <p:sp>
         <p:nvSpPr>
+          <p:cNvPr id="15" name="Rounded Rectangle 14">
+            <a:extLst>
+              <a:ext uri="{FF2B5EF4-FFF2-40B4-BE49-F238E27FC236}">
+                <a16:creationId xmlns:a16="http://schemas.microsoft.com/office/drawing/2014/main" id="{A947E235-B803-CB82-33BD-ED0DA2439F22}"/>
+              </a:ext>
+            </a:extLst>
+          </p:cNvPr>
+          <p:cNvSpPr/>
+          <p:nvPr userDrawn="1"/>
+        </p:nvSpPr>
+        <p:spPr>
+          <a:xfrm>
+            <a:off x="380999" y="1855425"/>
+            <a:ext cx="11429999" cy="4193309"/>
+          </a:xfrm>
+          <a:prstGeom prst="roundRect">
+            <a:avLst>
+              <a:gd name="adj" fmla="val 4552"/>
+            </a:avLst>
+          </a:prstGeom>
+          <a:solidFill>
+            <a:schemeClr val="bg1"/>
+          </a:solidFill>
+          <a:ln>
+            <a:noFill/>
+          </a:ln>
+          <a:effectLst>
+            <a:outerShdw blurRad="253894" dist="38100" dir="4200000" sx="100317" sy="100317" algn="tl" rotWithShape="0">
+              <a:prstClr val="black">
+                <a:alpha val="22007"/>
+              </a:prstClr>
+            </a:outerShdw>
+          </a:effectLst>
+        </p:spPr>
+        <p:style>
+          <a:lnRef idx="2">
+            <a:schemeClr val="accent1">
+              <a:shade val="15000"/>
+            </a:schemeClr>
+          </a:lnRef>
+          <a:fillRef idx="1">
+            <a:schemeClr val="accent1"/>
+          </a:fillRef>
+          <a:effectRef idx="0">
+            <a:schemeClr val="accent1"/>
+          </a:effectRef>
+          <a:fontRef idx="minor">
+            <a:schemeClr val="lt1"/>
+          </a:fontRef>
+        </p:style>
+        <p:txBody>
+          <a:bodyPr rtlCol="0" anchor="ctr"/>
+          <a:lstStyle/>
+          <a:p>
+            <a:pPr algn="ctr"/>
+            <a:endParaRPr lang="en-US"/>
+          </a:p>
+        </p:txBody>
+      </p:sp>
+      <p:sp>
+        <p:nvSpPr>
           <p:cNvPr id="2" name="Conclusion Title">
             <a:extLst>
               <a:ext uri="{FF2B5EF4-FFF2-40B4-BE49-F238E27FC236}">
@@ -5619,7 +6425,7 @@
         </p:nvSpPr>
         <p:spPr>
           <a:xfrm>
-            <a:off x="381000" y="2282909"/>
+            <a:off x="645695" y="2535572"/>
             <a:ext cx="830263" cy="746125"/>
           </a:xfrm>
           <a:prstGeom prst="rect">
@@ -5674,7 +6480,7 @@
         </p:nvSpPr>
         <p:spPr>
           <a:xfrm>
-            <a:off x="1308100" y="2275808"/>
+            <a:off x="1572795" y="2528471"/>
             <a:ext cx="4249738" cy="769937"/>
           </a:xfrm>
           <a:prstGeom prst="rect">
@@ -5693,7 +6499,7 @@
             <a:pPr lvl="0"/>
             <a:r>
               <a:rPr lang="en-US" dirty="0"/>
-              <a:t>Text beside icon 1 maximum 8 words</a:t>
+              <a:t>Text beside icon 1 maximum 8 words in markdown format</a:t>
             </a:r>
           </a:p>
         </p:txBody>
@@ -5716,7 +6522,7 @@
         </p:nvSpPr>
         <p:spPr>
           <a:xfrm>
-            <a:off x="6634161" y="2275808"/>
+            <a:off x="6369469" y="2528471"/>
             <a:ext cx="830263" cy="746125"/>
           </a:xfrm>
           <a:prstGeom prst="rect">
@@ -5770,7 +6576,7 @@
         </p:nvSpPr>
         <p:spPr>
           <a:xfrm>
-            <a:off x="7561262" y="2259097"/>
+            <a:off x="7296570" y="2511760"/>
             <a:ext cx="4249738" cy="769937"/>
           </a:xfrm>
           <a:prstGeom prst="rect">
@@ -5789,7 +6595,7 @@
             <a:pPr lvl="0"/>
             <a:r>
               <a:rPr lang="en-US" dirty="0"/>
-              <a:t>Text beside icon 2 maximum 8 words</a:t>
+              <a:t>Text beside icon 2 maximum 8 words in markdown format</a:t>
             </a:r>
           </a:p>
         </p:txBody>
@@ -5812,7 +6618,7 @@
         </p:nvSpPr>
         <p:spPr>
           <a:xfrm>
-            <a:off x="381000" y="3333667"/>
+            <a:off x="645695" y="3586330"/>
             <a:ext cx="830263" cy="746125"/>
           </a:xfrm>
           <a:prstGeom prst="rect">
@@ -5879,7 +6685,7 @@
         </p:nvSpPr>
         <p:spPr>
           <a:xfrm>
-            <a:off x="1308100" y="3326566"/>
+            <a:off x="1572795" y="3579229"/>
             <a:ext cx="4249738" cy="769937"/>
           </a:xfrm>
           <a:prstGeom prst="rect">
@@ -5898,7 +6704,7 @@
             <a:pPr lvl="0"/>
             <a:r>
               <a:rPr lang="en-US" dirty="0"/>
-              <a:t>Text beside icon 3 maximum 8 words</a:t>
+              <a:t>Text beside icon 3 maximum 8 words in markdown format</a:t>
             </a:r>
           </a:p>
         </p:txBody>
@@ -5921,7 +6727,7 @@
         </p:nvSpPr>
         <p:spPr>
           <a:xfrm>
-            <a:off x="6634162" y="3316956"/>
+            <a:off x="6369470" y="3569619"/>
             <a:ext cx="830263" cy="746125"/>
           </a:xfrm>
           <a:prstGeom prst="rect">
@@ -5988,7 +6794,7 @@
         </p:nvSpPr>
         <p:spPr>
           <a:xfrm>
-            <a:off x="7561262" y="3309855"/>
+            <a:off x="7296570" y="3562518"/>
             <a:ext cx="4249738" cy="769937"/>
           </a:xfrm>
           <a:prstGeom prst="rect">
@@ -6007,7 +6813,7 @@
             <a:pPr lvl="0"/>
             <a:r>
               <a:rPr lang="en-US" dirty="0"/>
-              <a:t>Text beside icon 4 maximum 8 words</a:t>
+              <a:t>Text beside icon 4 maximum 8 words in markdown format</a:t>
             </a:r>
           </a:p>
         </p:txBody>
@@ -6030,7 +6836,7 @@
         </p:nvSpPr>
         <p:spPr>
           <a:xfrm>
-            <a:off x="381000" y="4360613"/>
+            <a:off x="645695" y="4613276"/>
             <a:ext cx="830263" cy="746125"/>
           </a:xfrm>
           <a:prstGeom prst="rect">
@@ -6097,7 +6903,7 @@
         </p:nvSpPr>
         <p:spPr>
           <a:xfrm>
-            <a:off x="1308100" y="4353512"/>
+            <a:off x="1572795" y="4606175"/>
             <a:ext cx="4249738" cy="769937"/>
           </a:xfrm>
           <a:prstGeom prst="rect">
@@ -6116,7 +6922,7 @@
             <a:pPr lvl="0"/>
             <a:r>
               <a:rPr lang="en-US" dirty="0"/>
-              <a:t>Text beside icon 5 maximum 8 words</a:t>
+              <a:t>Text beside icon 5 maximum 8 words in markdown format</a:t>
             </a:r>
           </a:p>
         </p:txBody>
@@ -6139,7 +6945,7 @@
         </p:nvSpPr>
         <p:spPr>
           <a:xfrm>
-            <a:off x="6634162" y="4343902"/>
+            <a:off x="6369470" y="4596565"/>
             <a:ext cx="830263" cy="746125"/>
           </a:xfrm>
           <a:prstGeom prst="rect">
@@ -6206,7 +7012,7 @@
         </p:nvSpPr>
         <p:spPr>
           <a:xfrm>
-            <a:off x="7561262" y="4336801"/>
+            <a:off x="7296570" y="4589464"/>
             <a:ext cx="4249738" cy="769937"/>
           </a:xfrm>
           <a:prstGeom prst="rect">
@@ -6225,7 +7031,7 @@
             <a:pPr lvl="0"/>
             <a:r>
               <a:rPr lang="en-US" dirty="0"/>
-              <a:t>Text beside icon 6 maximum 8 words</a:t>
+              <a:t>Text beside icon 6 maximum 8 words in markdown format</a:t>
             </a:r>
           </a:p>
         </p:txBody>
@@ -6262,6 +7068,67 @@
       </p:grpSpPr>
       <p:sp>
         <p:nvSpPr>
+          <p:cNvPr id="5" name="Rounded Rectangle 4">
+            <a:extLst>
+              <a:ext uri="{FF2B5EF4-FFF2-40B4-BE49-F238E27FC236}">
+                <a16:creationId xmlns:a16="http://schemas.microsoft.com/office/drawing/2014/main" id="{E016E7B1-923A-B9B7-53D4-CEA8E79FC61D}"/>
+              </a:ext>
+            </a:extLst>
+          </p:cNvPr>
+          <p:cNvSpPr/>
+          <p:nvPr userDrawn="1"/>
+        </p:nvSpPr>
+        <p:spPr>
+          <a:xfrm>
+            <a:off x="381000" y="1855425"/>
+            <a:ext cx="11430000" cy="4193309"/>
+          </a:xfrm>
+          <a:prstGeom prst="roundRect">
+            <a:avLst>
+              <a:gd name="adj" fmla="val 4552"/>
+            </a:avLst>
+          </a:prstGeom>
+          <a:solidFill>
+            <a:schemeClr val="bg1"/>
+          </a:solidFill>
+          <a:ln>
+            <a:noFill/>
+          </a:ln>
+          <a:effectLst>
+            <a:outerShdw blurRad="253894" dist="38100" dir="4200000" sx="100317" sy="100317" algn="tl" rotWithShape="0">
+              <a:prstClr val="black">
+                <a:alpha val="22007"/>
+              </a:prstClr>
+            </a:outerShdw>
+          </a:effectLst>
+        </p:spPr>
+        <p:style>
+          <a:lnRef idx="2">
+            <a:schemeClr val="accent1">
+              <a:shade val="15000"/>
+            </a:schemeClr>
+          </a:lnRef>
+          <a:fillRef idx="1">
+            <a:schemeClr val="accent1"/>
+          </a:fillRef>
+          <a:effectRef idx="0">
+            <a:schemeClr val="accent1"/>
+          </a:effectRef>
+          <a:fontRef idx="minor">
+            <a:schemeClr val="lt1"/>
+          </a:fontRef>
+        </p:style>
+        <p:txBody>
+          <a:bodyPr rtlCol="0" anchor="ctr"/>
+          <a:lstStyle/>
+          <a:p>
+            <a:pPr algn="ctr"/>
+            <a:endParaRPr lang="en-US"/>
+          </a:p>
+        </p:txBody>
+      </p:sp>
+      <p:sp>
+        <p:nvSpPr>
           <p:cNvPr id="2" name="Conclusion Title">
             <a:extLst>
               <a:ext uri="{FF2B5EF4-FFF2-40B4-BE49-F238E27FC236}">
@@ -6334,7 +7201,7 @@
         </p:nvSpPr>
         <p:spPr>
           <a:xfrm>
-            <a:off x="460022" y="2937664"/>
+            <a:off x="724716" y="2934190"/>
             <a:ext cx="830263" cy="746125"/>
           </a:xfrm>
           <a:prstGeom prst="rect">
@@ -6383,7 +7250,7 @@
         </p:nvSpPr>
         <p:spPr>
           <a:xfrm>
-            <a:off x="1387122" y="2930563"/>
+            <a:off x="1651816" y="2927089"/>
             <a:ext cx="4249738" cy="769937"/>
           </a:xfrm>
           <a:prstGeom prst="rect">
@@ -6402,7 +7269,7 @@
             <a:pPr lvl="0"/>
             <a:r>
               <a:rPr lang="en-US" dirty="0"/>
-              <a:t>Text beside icon 1 maximum 8 words</a:t>
+              <a:t>Text beside icon 1 maximum 8 words in markdown format</a:t>
             </a:r>
           </a:p>
         </p:txBody>
@@ -6425,7 +7292,7 @@
         </p:nvSpPr>
         <p:spPr>
           <a:xfrm>
-            <a:off x="6713184" y="2920953"/>
+            <a:off x="6412395" y="2948633"/>
             <a:ext cx="830263" cy="746125"/>
           </a:xfrm>
           <a:prstGeom prst="rect">
@@ -6473,7 +7340,7 @@
         </p:nvSpPr>
         <p:spPr>
           <a:xfrm>
-            <a:off x="7640284" y="2913852"/>
+            <a:off x="7339495" y="2941532"/>
             <a:ext cx="4249738" cy="769937"/>
           </a:xfrm>
           <a:prstGeom prst="rect">
@@ -6492,7 +7359,7 @@
             <a:pPr lvl="0"/>
             <a:r>
               <a:rPr lang="en-US" dirty="0"/>
-              <a:t>Text beside icon 2 maximum 8 words</a:t>
+              <a:t>Text beside icon 2 maximum 8 words in markdown format</a:t>
             </a:r>
           </a:p>
         </p:txBody>
@@ -6515,7 +7382,7 @@
         </p:nvSpPr>
         <p:spPr>
           <a:xfrm>
-            <a:off x="460022" y="3988422"/>
+            <a:off x="724716" y="3984948"/>
             <a:ext cx="830263" cy="746125"/>
           </a:xfrm>
           <a:prstGeom prst="rect">
@@ -6576,7 +7443,7 @@
         </p:nvSpPr>
         <p:spPr>
           <a:xfrm>
-            <a:off x="1387122" y="3981321"/>
+            <a:off x="1651816" y="3977847"/>
             <a:ext cx="4249738" cy="769937"/>
           </a:xfrm>
           <a:prstGeom prst="rect">
@@ -6595,7 +7462,7 @@
             <a:pPr lvl="0"/>
             <a:r>
               <a:rPr lang="en-US" dirty="0"/>
-              <a:t>Text beside icon 3 maximum 8 words</a:t>
+              <a:t>Text beside icon 3 maximum 8 words in markdown format</a:t>
             </a:r>
           </a:p>
         </p:txBody>
@@ -6618,7 +7485,7 @@
         </p:nvSpPr>
         <p:spPr>
           <a:xfrm>
-            <a:off x="6713184" y="3971711"/>
+            <a:off x="6412395" y="3999391"/>
             <a:ext cx="830263" cy="746125"/>
           </a:xfrm>
           <a:prstGeom prst="rect">
@@ -6679,7 +7546,7 @@
         </p:nvSpPr>
         <p:spPr>
           <a:xfrm>
-            <a:off x="7640284" y="3964610"/>
+            <a:off x="7339495" y="3992290"/>
             <a:ext cx="4249738" cy="769937"/>
           </a:xfrm>
           <a:prstGeom prst="rect">
@@ -6698,7 +7565,7 @@
             <a:pPr lvl="0"/>
             <a:r>
               <a:rPr lang="en-US" dirty="0"/>
-              <a:t>Text beside icon 4 maximum 8 words</a:t>
+              <a:t>Text beside icon 4 maximum 8 words in markdown format</a:t>
             </a:r>
           </a:p>
         </p:txBody>
@@ -8139,14 +9006,12 @@
 </file>
 
 <file path=customXml/item1.xml><?xml version="1.0" encoding="utf-8"?>
-<p:properties xmlns:p="http://schemas.microsoft.com/office/2006/metadata/properties" xmlns:xsi="http://www.w3.org/2001/XMLSchema-instance" xmlns:pc="http://schemas.microsoft.com/office/infopath/2007/PartnerControls">
-  <documentManagement>
-    <TaxCatchAll xmlns="2bdccfd7-ed75-47c4-ae3e-45ba8291135b" xsi:nil="true"/>
-    <lcf76f155ced4ddcb4097134ff3c332f xmlns="bdfda862-7558-4f4e-99f8-648970d7935e">
-      <Terms xmlns="http://schemas.microsoft.com/office/infopath/2007/PartnerControls"/>
-    </lcf76f155ced4ddcb4097134ff3c332f>
-  </documentManagement>
-</p:properties>
+<?mso-contentType ?>
+<FormTemplates xmlns="http://schemas.microsoft.com/sharepoint/v3/contenttype/forms">
+  <Display>DocumentLibraryForm</Display>
+  <Edit>DocumentLibraryForm</Edit>
+  <New>DocumentLibraryForm</New>
+</FormTemplates>
 </file>
 
 <file path=customXml/item2.xml><?xml version="1.0" encoding="utf-8"?>
@@ -8357,27 +9222,20 @@
 </file>
 
 <file path=customXml/item3.xml><?xml version="1.0" encoding="utf-8"?>
-<?mso-contentType ?>
-<FormTemplates xmlns="http://schemas.microsoft.com/sharepoint/v3/contenttype/forms">
-  <Display>DocumentLibraryForm</Display>
-  <Edit>DocumentLibraryForm</Edit>
-  <New>DocumentLibraryForm</New>
-</FormTemplates>
+<p:properties xmlns:p="http://schemas.microsoft.com/office/2006/metadata/properties" xmlns:xsi="http://www.w3.org/2001/XMLSchema-instance" xmlns:pc="http://schemas.microsoft.com/office/infopath/2007/PartnerControls">
+  <documentManagement>
+    <TaxCatchAll xmlns="2bdccfd7-ed75-47c4-ae3e-45ba8291135b" xsi:nil="true"/>
+    <lcf76f155ced4ddcb4097134ff3c332f xmlns="bdfda862-7558-4f4e-99f8-648970d7935e">
+      <Terms xmlns="http://schemas.microsoft.com/office/infopath/2007/PartnerControls"/>
+    </lcf76f155ced4ddcb4097134ff3c332f>
+  </documentManagement>
+</p:properties>
 </file>
 
 <file path=customXml/itemProps1.xml><?xml version="1.0" encoding="utf-8"?>
-<ds:datastoreItem xmlns:ds="http://schemas.openxmlformats.org/officeDocument/2006/customXml" ds:itemID="{E18F5EE7-65DF-41C5-963C-25B6B377F939}">
+<ds:datastoreItem xmlns:ds="http://schemas.openxmlformats.org/officeDocument/2006/customXml" ds:itemID="{C2B4E4C2-7A23-4EC8-AE63-F75F63DE72BE}">
   <ds:schemaRefs>
-    <ds:schemaRef ds:uri="http://purl.org/dc/terms/"/>
-    <ds:schemaRef ds:uri="http://www.w3.org/XML/1998/namespace"/>
-    <ds:schemaRef ds:uri="http://schemas.microsoft.com/office/2006/documentManagement/types"/>
-    <ds:schemaRef ds:uri="bdfda862-7558-4f4e-99f8-648970d7935e"/>
-    <ds:schemaRef ds:uri="http://purl.org/dc/elements/1.1/"/>
-    <ds:schemaRef ds:uri="http://schemas.microsoft.com/office/2006/metadata/properties"/>
-    <ds:schemaRef ds:uri="http://schemas.microsoft.com/office/infopath/2007/PartnerControls"/>
-    <ds:schemaRef ds:uri="http://schemas.openxmlformats.org/package/2006/metadata/core-properties"/>
-    <ds:schemaRef ds:uri="2bdccfd7-ed75-47c4-ae3e-45ba8291135b"/>
-    <ds:schemaRef ds:uri="http://purl.org/dc/dcmitype/"/>
+    <ds:schemaRef ds:uri="http://schemas.microsoft.com/sharepoint/v3/contenttype/forms"/>
   </ds:schemaRefs>
 </ds:datastoreItem>
 </file>
@@ -8402,9 +9260,18 @@
 </file>
 
 <file path=customXml/itemProps3.xml><?xml version="1.0" encoding="utf-8"?>
-<ds:datastoreItem xmlns:ds="http://schemas.openxmlformats.org/officeDocument/2006/customXml" ds:itemID="{C2B4E4C2-7A23-4EC8-AE63-F75F63DE72BE}">
+<ds:datastoreItem xmlns:ds="http://schemas.openxmlformats.org/officeDocument/2006/customXml" ds:itemID="{E18F5EE7-65DF-41C5-963C-25B6B377F939}">
   <ds:schemaRefs>
-    <ds:schemaRef ds:uri="http://schemas.microsoft.com/sharepoint/v3/contenttype/forms"/>
+    <ds:schemaRef ds:uri="http://purl.org/dc/terms/"/>
+    <ds:schemaRef ds:uri="http://schemas.microsoft.com/office/2006/metadata/properties"/>
+    <ds:schemaRef ds:uri="http://schemas.openxmlformats.org/package/2006/metadata/core-properties"/>
+    <ds:schemaRef ds:uri="http://schemas.microsoft.com/office/2006/documentManagement/types"/>
+    <ds:schemaRef ds:uri="bdfda862-7558-4f4e-99f8-648970d7935e"/>
+    <ds:schemaRef ds:uri="http://purl.org/dc/dcmitype/"/>
+    <ds:schemaRef ds:uri="http://www.w3.org/XML/1998/namespace"/>
+    <ds:schemaRef ds:uri="http://schemas.microsoft.com/office/infopath/2007/PartnerControls"/>
+    <ds:schemaRef ds:uri="2bdccfd7-ed75-47c4-ae3e-45ba8291135b"/>
+    <ds:schemaRef ds:uri="http://purl.org/dc/elements/1.1/"/>
   </ds:schemaRefs>
 </ds:datastoreItem>
 </file>
</xml_diff>

<commit_message>
Update presentation template and enhance frontend with new drag-and-drop dependency. Modify ProjectDetailPage to include interactive planning button and improve WebSocket endpoint for real-time updates, including chat session management and slide generation features. Add chat-related models and endpoints for interactive presentation planning in the API server.
</commit_message>
<xml_diff>
--- a/ekona_slides_template_new.pptx
+++ b/ekona_slides_template_new.pptx
@@ -116,14 +116,6 @@
     </p:ext>
   </p:extLst>
 </p:presentation>
-</file>
-
-<file path=ppt/revisionInfo.xml><?xml version="1.0" encoding="utf-8"?>
-<p1510:revInfo xmlns:a="http://schemas.openxmlformats.org/drawingml/2006/main" xmlns:r="http://schemas.openxmlformats.org/officeDocument/2006/relationships" xmlns:p1510="http://schemas.microsoft.com/office/powerpoint/2015/10/main">
-  <p1510:revLst>
-    <p1510:client id="{651B6F30-EC96-2340-AD4B-07A6B9855D0C}" v="209" dt="2025-07-21T08:11:00.613"/>
-  </p1510:revLst>
-</p1510:revInfo>
 </file>
 
 <file path=ppt/changesInfos/changesInfo1.xml><?xml version="1.0" encoding="utf-8"?>
@@ -404,15 +396,6 @@
             <pc:sldMasterMk cId="2940896467" sldId="2147483648"/>
             <pc:sldLayoutMk cId="3393990456" sldId="2147483672"/>
           </pc:sldLayoutMkLst>
-          <pc:spChg chg="del mod">
-            <ac:chgData name="Sam Khalil" userId="82cd1ec2-6208-465b-9d4d-40ce8f0cbf96" providerId="ADAL" clId="{651B6F30-EC96-2340-AD4B-07A6B9855D0C}" dt="2025-07-21T08:09:05.796" v="2416" actId="478"/>
-            <ac:spMkLst>
-              <pc:docMk/>
-              <pc:sldMasterMk cId="2940896467" sldId="2147483648"/>
-              <pc:sldLayoutMk cId="3393990456" sldId="2147483672"/>
-              <ac:spMk id="2" creationId="{6372FCEB-FEC1-18CC-54A6-09739A289B26}"/>
-            </ac:spMkLst>
-          </pc:spChg>
           <pc:spChg chg="mod">
             <ac:chgData name="Sam Khalil" userId="82cd1ec2-6208-465b-9d4d-40ce8f0cbf96" providerId="ADAL" clId="{651B6F30-EC96-2340-AD4B-07A6B9855D0C}" dt="2025-07-21T08:08:36.529" v="2240" actId="1076"/>
             <ac:spMkLst>
@@ -1005,6 +988,39 @@
       </pc:sldMasterChg>
     </pc:docChg>
   </pc:docChgLst>
+  <pc:docChgLst>
+    <pc:chgData name="Sam Khalil" userId="82cd1ec2-6208-465b-9d4d-40ce8f0cbf96" providerId="ADAL" clId="{EDFF173F-DF9C-D14E-964C-429E56C8376C}"/>
+    <pc:docChg chg="modMainMaster">
+      <pc:chgData name="Sam Khalil" userId="82cd1ec2-6208-465b-9d4d-40ce8f0cbf96" providerId="ADAL" clId="{EDFF173F-DF9C-D14E-964C-429E56C8376C}" dt="2025-08-11T07:57:31.112" v="0" actId="1076"/>
+      <pc:docMkLst>
+        <pc:docMk/>
+      </pc:docMkLst>
+      <pc:sldMasterChg chg="modSldLayout">
+        <pc:chgData name="Sam Khalil" userId="82cd1ec2-6208-465b-9d4d-40ce8f0cbf96" providerId="ADAL" clId="{EDFF173F-DF9C-D14E-964C-429E56C8376C}" dt="2025-08-11T07:57:31.112" v="0" actId="1076"/>
+        <pc:sldMasterMkLst>
+          <pc:docMk/>
+          <pc:sldMasterMk cId="2940896467" sldId="2147483648"/>
+        </pc:sldMasterMkLst>
+        <pc:sldLayoutChg chg="modSp mod">
+          <pc:chgData name="Sam Khalil" userId="82cd1ec2-6208-465b-9d4d-40ce8f0cbf96" providerId="ADAL" clId="{EDFF173F-DF9C-D14E-964C-429E56C8376C}" dt="2025-08-11T07:57:31.112" v="0" actId="1076"/>
+          <pc:sldLayoutMkLst>
+            <pc:docMk/>
+            <pc:sldMasterMk cId="2940896467" sldId="2147483648"/>
+            <pc:sldLayoutMk cId="3074954578" sldId="2147483650"/>
+          </pc:sldLayoutMkLst>
+          <pc:spChg chg="mod">
+            <ac:chgData name="Sam Khalil" userId="82cd1ec2-6208-465b-9d4d-40ce8f0cbf96" providerId="ADAL" clId="{EDFF173F-DF9C-D14E-964C-429E56C8376C}" dt="2025-08-11T07:57:31.112" v="0" actId="1076"/>
+            <ac:spMkLst>
+              <pc:docMk/>
+              <pc:sldMasterMk cId="2940896467" sldId="2147483648"/>
+              <pc:sldLayoutMk cId="3074954578" sldId="2147483650"/>
+              <ac:spMk id="5" creationId="{4286C11B-CD57-AE94-2379-3F6FBE23504C}"/>
+            </ac:spMkLst>
+          </pc:spChg>
+        </pc:sldLayoutChg>
+      </pc:sldMasterChg>
+    </pc:docChg>
+  </pc:docChgLst>
 </pc:chgInfo>
 </file>
 
@@ -1102,7 +1118,7 @@
           <a:p>
             <a:fld id="{D2339670-67E6-CD42-B7B2-F285F1108ED9}" type="datetimeFigureOut">
               <a:rPr lang="en-US" smtClean="0"/>
-              <a:t>7/21/25</a:t>
+              <a:t>8/11/25</a:t>
             </a:fld>
             <a:endParaRPr lang="en-US"/>
           </a:p>
@@ -1278,7 +1294,7 @@
           </a:lstStyle>
           <a:p>
             <a:fld id="{1E521F2A-B11E-40E0-8F26-7CD21B55A12D}" type="datetimeFigureOut">
-              <a:t>7/21/25</a:t>
+              <a:t>8/11/25</a:t>
             </a:fld>
             <a:endParaRPr lang="en-GB"/>
           </a:p>
@@ -5755,7 +5771,7 @@
         </p:nvSpPr>
         <p:spPr>
           <a:xfrm>
-            <a:off x="381000" y="1855425"/>
+            <a:off x="421178" y="1855424"/>
             <a:ext cx="5623560" cy="4193309"/>
           </a:xfrm>
           <a:prstGeom prst="roundRect">
@@ -9006,12 +9022,14 @@
 </file>
 
 <file path=customXml/item1.xml><?xml version="1.0" encoding="utf-8"?>
-<?mso-contentType ?>
-<FormTemplates xmlns="http://schemas.microsoft.com/sharepoint/v3/contenttype/forms">
-  <Display>DocumentLibraryForm</Display>
-  <Edit>DocumentLibraryForm</Edit>
-  <New>DocumentLibraryForm</New>
-</FormTemplates>
+<p:properties xmlns:p="http://schemas.microsoft.com/office/2006/metadata/properties" xmlns:xsi="http://www.w3.org/2001/XMLSchema-instance" xmlns:pc="http://schemas.microsoft.com/office/infopath/2007/PartnerControls">
+  <documentManagement>
+    <TaxCatchAll xmlns="2bdccfd7-ed75-47c4-ae3e-45ba8291135b" xsi:nil="true"/>
+    <lcf76f155ced4ddcb4097134ff3c332f xmlns="bdfda862-7558-4f4e-99f8-648970d7935e">
+      <Terms xmlns="http://schemas.microsoft.com/office/infopath/2007/PartnerControls"/>
+    </lcf76f155ced4ddcb4097134ff3c332f>
+  </documentManagement>
+</p:properties>
 </file>
 
 <file path=customXml/item2.xml><?xml version="1.0" encoding="utf-8"?>
@@ -9222,20 +9240,27 @@
 </file>
 
 <file path=customXml/item3.xml><?xml version="1.0" encoding="utf-8"?>
-<p:properties xmlns:p="http://schemas.microsoft.com/office/2006/metadata/properties" xmlns:xsi="http://www.w3.org/2001/XMLSchema-instance" xmlns:pc="http://schemas.microsoft.com/office/infopath/2007/PartnerControls">
-  <documentManagement>
-    <TaxCatchAll xmlns="2bdccfd7-ed75-47c4-ae3e-45ba8291135b" xsi:nil="true"/>
-    <lcf76f155ced4ddcb4097134ff3c332f xmlns="bdfda862-7558-4f4e-99f8-648970d7935e">
-      <Terms xmlns="http://schemas.microsoft.com/office/infopath/2007/PartnerControls"/>
-    </lcf76f155ced4ddcb4097134ff3c332f>
-  </documentManagement>
-</p:properties>
+<?mso-contentType ?>
+<FormTemplates xmlns="http://schemas.microsoft.com/sharepoint/v3/contenttype/forms">
+  <Display>DocumentLibraryForm</Display>
+  <Edit>DocumentLibraryForm</Edit>
+  <New>DocumentLibraryForm</New>
+</FormTemplates>
 </file>
 
 <file path=customXml/itemProps1.xml><?xml version="1.0" encoding="utf-8"?>
-<ds:datastoreItem xmlns:ds="http://schemas.openxmlformats.org/officeDocument/2006/customXml" ds:itemID="{C2B4E4C2-7A23-4EC8-AE63-F75F63DE72BE}">
+<ds:datastoreItem xmlns:ds="http://schemas.openxmlformats.org/officeDocument/2006/customXml" ds:itemID="{E18F5EE7-65DF-41C5-963C-25B6B377F939}">
   <ds:schemaRefs>
-    <ds:schemaRef ds:uri="http://schemas.microsoft.com/sharepoint/v3/contenttype/forms"/>
+    <ds:schemaRef ds:uri="http://schemas.microsoft.com/office/2006/metadata/properties"/>
+    <ds:schemaRef ds:uri="http://purl.org/dc/dcmitype/"/>
+    <ds:schemaRef ds:uri="http://purl.org/dc/terms/"/>
+    <ds:schemaRef ds:uri="bdfda862-7558-4f4e-99f8-648970d7935e"/>
+    <ds:schemaRef ds:uri="http://purl.org/dc/elements/1.1/"/>
+    <ds:schemaRef ds:uri="http://www.w3.org/XML/1998/namespace"/>
+    <ds:schemaRef ds:uri="http://schemas.microsoft.com/office/2006/documentManagement/types"/>
+    <ds:schemaRef ds:uri="http://schemas.microsoft.com/office/infopath/2007/PartnerControls"/>
+    <ds:schemaRef ds:uri="http://schemas.openxmlformats.org/package/2006/metadata/core-properties"/>
+    <ds:schemaRef ds:uri="2bdccfd7-ed75-47c4-ae3e-45ba8291135b"/>
   </ds:schemaRefs>
 </ds:datastoreItem>
 </file>
@@ -9260,18 +9285,9 @@
 </file>
 
 <file path=customXml/itemProps3.xml><?xml version="1.0" encoding="utf-8"?>
-<ds:datastoreItem xmlns:ds="http://schemas.openxmlformats.org/officeDocument/2006/customXml" ds:itemID="{E18F5EE7-65DF-41C5-963C-25B6B377F939}">
+<ds:datastoreItem xmlns:ds="http://schemas.openxmlformats.org/officeDocument/2006/customXml" ds:itemID="{C2B4E4C2-7A23-4EC8-AE63-F75F63DE72BE}">
   <ds:schemaRefs>
-    <ds:schemaRef ds:uri="http://purl.org/dc/terms/"/>
-    <ds:schemaRef ds:uri="http://schemas.microsoft.com/office/2006/metadata/properties"/>
-    <ds:schemaRef ds:uri="http://schemas.openxmlformats.org/package/2006/metadata/core-properties"/>
-    <ds:schemaRef ds:uri="http://schemas.microsoft.com/office/2006/documentManagement/types"/>
-    <ds:schemaRef ds:uri="bdfda862-7558-4f4e-99f8-648970d7935e"/>
-    <ds:schemaRef ds:uri="http://purl.org/dc/dcmitype/"/>
-    <ds:schemaRef ds:uri="http://www.w3.org/XML/1998/namespace"/>
-    <ds:schemaRef ds:uri="http://schemas.microsoft.com/office/infopath/2007/PartnerControls"/>
-    <ds:schemaRef ds:uri="2bdccfd7-ed75-47c4-ae3e-45ba8291135b"/>
-    <ds:schemaRef ds:uri="http://purl.org/dc/elements/1.1/"/>
+    <ds:schemaRef ds:uri="http://schemas.microsoft.com/sharepoint/v3/contenttype/forms"/>
   </ds:schemaRefs>
 </ds:datastoreItem>
 </file>
</xml_diff>